<commit_message>
v2.30 (John's word, 13 October): Sessions 9-10 teach testing what you hear, before the garden
From the Four Connects deck (Sept 2025), "Hearing God - The How" and "What If?":
two new slides after the check-in (When have you heard God? / How did you know?
- the room's answers first, then the checks: Scripture first, sense, the Spirit's
witness, peace, company, circumstances, obedience over time); "notice, don't
conclude" on the bridge; two test lines after each garden return. Clock re-timed
to 90 minutes (check-in and framing trimmed; garden keeps 32). New one-page
How Did You Know? card (H9.4) synced beside the take-home; Session 9 take-home
filled in, preparation sentence points to Any Doubts?. The "silent place"
exercise is saved for Session 11. Leader notes rebuilt; run sheet two pages.

Co-Authored-By: Claude Opus 5.5 <noreply@anthropic.com>
</commit_message>
<xml_diff>
--- a/_implementation-notes/evening-series/FotH Evening Session 9-10 Combined Slides DRAFT v1.pptx
+++ b/_implementation-notes/evening-series/FotH Evening Session 9-10 Combined Slides DRAFT v1.pptx
@@ -14,6 +14,8 @@
     <p:sldId id="285" r:id="rId116"/>
     <p:sldId id="401" r:id="rId117"/>
     <p:sldId id="402" r:id="rId118"/>
+    <p:sldId id="536" r:id="rId21"/>
+    <p:sldId id="537" r:id="rId25"/>
     <p:sldId id="403" r:id="rId119"/>
     <p:sldId id="404" r:id="rId120"/>
     <p:sldId id="405" r:id="rId121"/>
@@ -851,12 +853,17 @@
           </a:p>
           <a:p>
             <a:r>
-              <a:t>2. Shape: open, check-in, Scripture and framing (John 15; Psalm 23), bridge and settle, the guided run — a senior reads the walk-through, two words per second, the pauses are where the work happens; adults hold the sharing — journaling, pair sharing by invitation, merge, the returns commissioned, feedback, gentle close.</a:t>
+              <a:t>2. Shape: open, a short check-in, remembering a real hearing and how we knew (the tests, before the garden), Scripture and framing (John 15; Psalm 23), bridge and settle, the guided run — a senior reads the walk-through, two words per second, the pauses are where the work happens; adults hold the sharing — journaling, pair sharing by invitation, merge, the returns commissioned, feedback, gentle close.</a:t>
             </a:r>
           </a:p>
           <a:p>
             <a:r>
               <a:t>3. The current-condition form: teen-led from the first run. The separate second-running evening (Session 10) is held in reserve for a larger room of newer people.</a:t>
+            </a:r>
+          </a:p>
+          <a:p>
+            <a:r>
+              <a:t>4. Why the testing comes first (John's word, 13 October): what anyone notices in the garden is held loosely and tested on the returns, not concluded tonight. Session 11, Any Doubts?, starts from here.</a:t>
             </a:r>
           </a:p>
           <a:p>
@@ -907,7 +914,7 @@
           <a:lstStyle/>
           <a:p>
             <a:r>
-              <a:t>S9 · 7:00–7:08 · LEAD: CONTAINER HOLDER</a:t>
+              <a:t>S9 · 7:00–7:06 · LEAD: CONTAINER HOLDER</a:t>
             </a:r>
           </a:p>
           <a:p>
@@ -963,19 +970,16 @@
           <a:lstStyle/>
           <a:p>
             <a:r>
-              <a:rPr lang="en-US" sz="1200"/>
-              <a:t>S9 · 7:08–7:25 · LEAD: CONTAINER HOLDER</a:t>
-            </a:r>
-          </a:p>
-          <a:p>
-            <a:r>
-              <a:rPr lang="en-US" sz="1200"/>
-              <a:t>BEATS: 1. One sentence each on how the daily PROAPT practice has been. 2. Take 2–3 voluntary contributions and keep it brief — today's arc needs the time later.</a:t>
-            </a:r>
-          </a:p>
-          <a:p>
-            <a:r>
-              <a:rPr lang="en-US" sz="1200"/>
+              <a:t>S9 · 7:06–7:10 · LEAD: CONTAINER HOLDER</a:t>
+            </a:r>
+          </a:p>
+          <a:p>
+            <a:r>
+              <a:t>BEATS: 1. One sentence each on how the daily PROAPT practice has been. 2. Two voluntary contributions, kept brief — four minutes; tonight's arc needs the time.</a:t>
+            </a:r>
+          </a:p>
+          <a:p>
+            <a:r>
               <a:t>CUES: Arranged parent opens (check the Run Card) — never cold-call a teen; pass-anytime holds.</a:t>
             </a:r>
           </a:p>
@@ -1022,14 +1026,12 @@
           <a:lstStyle/>
           <a:p>
             <a:r>
-              <a:rPr lang="en-US" sz="1200"/>
-              <a:t>S9 · 7:25–7:40 · LEAD: CONTENT PRESENTER</a:t>
-            </a:r>
-          </a:p>
-          <a:p>
-            <a:r>
-              <a:rPr lang="en-US" sz="1200"/>
-              <a:t>BEATS: 1. Read Psalm 23 and John 15:1–11 slowly — 'listen as if you have not heard it.' 2. Teach: scripture pictures the heart as cultivated ground; today we walk into that image and invite Jesus in to walk it with us. 3. Name the lineage — imaginative prayer: Ignatius, Bonaventure, the Puritans — and the two nots: not visualization-as-self-help, not emptying the mind. 4. 'Vivid experience or nothing at all — both fine. The turning toward Him is the practice.' 5. If you sense resistance, read the skepticism paragraph — the frame IS the work; do not skip it.</a:t>
+              <a:t>S9 · 7:25–7:31 · LEAD: CONTENT PRESENTER</a:t>
+            </a:r>
+          </a:p>
+          <a:p>
+            <a:r>
+              <a:t>BEATS: 1. Read John 15:1–11 slowly, then Psalm 23:1–3 — 'listen as if you have not heard it.' 2. Teach: scripture pictures the heart as cultivated ground; today we walk into that image and invite Jesus in to walk it with us. 3. Name the lineage in a sentence — imaginative prayer: Ignatius, Bonaventure, the Puritans — and the two nots: not visualization-as-self-help, not emptying the mind. 4. 'Vivid experience or nothing at all — both fine. The turning toward Him is the practice.' 5. If you sense resistance, read the skepticism paragraph — the frame IS the work; do not skip it.</a:t>
             </a:r>
           </a:p>
         </p:txBody>
@@ -1075,14 +1077,12 @@
           <a:lstStyle/>
           <a:p>
             <a:r>
-              <a:rPr lang="en-US" sz="1200"/>
-              <a:t>S9 · 7:40–7:42 · LEAD: CONTENT PRESENTER · TRANSITION</a:t>
-            </a:r>
-          </a:p>
-          <a:p>
-            <a:r>
-              <a:rPr lang="en-US" sz="1200"/>
-              <a:t>BEATS: 1. Preview the shape: guided prayer 12–15 min, whole room, eyes open or closed, your own family beside you; then 5 min silent journaling; then pairs for sharing by invitation only — silence is a complete answer. 2. Room about ten or fewer: name it now — sharing happens right in this circle, no moving. 3. Pray the bridge prayer: where it is hard, be tender; where it is closed, be patient; where it is opening, be present.</a:t>
+              <a:t>S9 · 7:31–7:35 · LEAD: CONTENT PRESENTER · TRANSITION</a:t>
+            </a:r>
+          </a:p>
+          <a:p>
+            <a:r>
+              <a:t>BEATS: 1. Preview the shape: guided prayer 12–15 min, whole room, eyes open or closed, your own family beside you; then 5 min silent journaling; then pairs for sharing by invitation only — silence is a complete answer. 2. Room about ten or fewer: name it now — sharing happens right in this circle, no moving. 3. One line from the testing slide: notice, don't conclude — tonight is for noticing; the returns are for testing. 4. Pray the bridge prayer: where it is hard, be tender; where it is closed, be patient; where it is opening, be present.</a:t>
             </a:r>
           </a:p>
         </p:txBody>
@@ -1128,7 +1128,7 @@
           <a:lstStyle/>
           <a:p>
             <a:r>
-              <a:t>S9 · 7:42–8:14 · LEAD: CONTENT PRESENTER</a:t>
+              <a:t>S9 · 7:35–8:07 · LEAD: CONTENT PRESENTER</a:t>
             </a:r>
           </a:p>
           <a:p>
@@ -1194,19 +1194,16 @@
           <a:lstStyle/>
           <a:p>
             <a:r>
-              <a:rPr lang="en-US" sz="1200"/>
-              <a:t>S9 · 8:14–8:20 · LEAD: CONTENT PRESENTER</a:t>
-            </a:r>
-          </a:p>
-          <a:p>
-            <a:r>
-              <a:rPr lang="en-US" sz="1200"/>
+              <a:t>S9 · 8:07–8:13 · LEAD: CONTENT PRESENTER</a:t>
+            </a:r>
+          </a:p>
+          <a:p>
+            <a:r>
               <a:t>BEATS: 1. The room will be quieter than usual — honor it; wait before speaking. 2. What happened in the pairs stays there; ask only one word about today — 'surprised', 'tender', 'empty', 'found', 'quiet'. 3. Receive each word with eye contact and a slight nod; say nothing else. 4. Close: whatever happened today is yours; some of it will quietly do its work for a long time.</a:t>
             </a:r>
           </a:p>
           <a:p>
             <a:r>
-              <a:rPr lang="en-US" sz="1200"/>
               <a:t>CUES: Arranged parent begins; anyone may pass.</a:t>
             </a:r>
           </a:p>
@@ -1253,12 +1250,12 @@
           <a:lstStyle/>
           <a:p>
             <a:r>
-              <a:t>S9 · 8:20–8:24 · LEAD: CONTENT PRESENTER</a:t>
-            </a:r>
-          </a:p>
-          <a:p>
-            <a:r>
-              <a:t>BEATS: 1. Co-Companion (Parent) leads. Three brief returns to the garden this week, 5–10 min each — no script needed, you have the place now; journal each visit (H9.2). 2. Gentle warning: a return can surface something heavy — you can stop, open your eyes, come back another day; and tell a trusted adult. You are not meant to carry the heavy things alone. 3. For the uneasy: H9.3, the Note for the Skeptic — adapting the practice or sitting it out is honored.</a:t>
+              <a:t>S9 · 8:13–8:18 · LEAD: CONTENT PRESENTER</a:t>
+            </a:r>
+          </a:p>
+          <a:p>
+            <a:r>
+              <a:t>BEATS: 1. Co-Companion (Parent) leads. Three brief returns to the garden this week, 5–10 min each — no script needed, you have the place now; journal each visit (H9.2). 2. Gentle warning: a return can surface something heavy — you can stop, open your eyes, come back another day; and tell a trusted adult. You are not meant to carry the heavy things alone. 3. After each return, test it: two lines in the journal — does what I noticed fit Scripture? who could I tell? The How Did You Know? card (H9.4) has the checks. 4. For the uneasy: H9.3, the Note for the Skeptic — adapting the practice or sitting it out is honored.</a:t>
             </a:r>
           </a:p>
           <a:p>
@@ -1309,13 +1306,11 @@
           <a:lstStyle/>
           <a:p>
             <a:r>
-              <a:rPr lang="en-US" sz="1200"/>
-              <a:t>S9 · 8:24–8:28 · LEAD: BOTH LEADERS</a:t>
-            </a:r>
-          </a:p>
-          <a:p>
-            <a:r>
-              <a:rPr lang="en-US" sz="1200"/>
+              <a:t>S9 · 8:21–8:24 · LEAD: BOTH LEADERS</a:t>
+            </a:r>
+          </a:p>
+          <a:p>
+            <a:r>
               <a:t>BEATS: 1. Same round: leader's three answers first, then the room's two questions; 'thank you' is the whole response. 2. Today is the likeliest night of the series to DROP the round: if the room is still deep in the garden's quiet, five minutes of process talk can break what the Spirit is holding. Drop it, and say so at the debrief.</a:t>
             </a:r>
           </a:p>
@@ -1362,7 +1357,7 @@
           <a:lstStyle/>
           <a:p>
             <a:r>
-              <a:t>S9 · 8:28–8:30 · LEAD: CONTAINER HOLDER</a:t>
+              <a:t>S9 · 8:24–8:30 · LEAD: CONTAINER HOLDER</a:t>
             </a:r>
           </a:p>
           <a:p>
@@ -1378,6 +1373,72 @@
           <a:p>
             <a:r>
               <a:t>BLESSINGS: eyes on the person, not the screen — nothing to read; say what is on your heart for them, specific and short.</a:t>
+            </a:r>
+          </a:p>
+        </p:txBody>
+      </p:sp>
+    </p:spTree>
+  </p:cSld>
+  <p:clrMapOvr>
+    <a:masterClrMapping/>
+  </p:clrMapOvr>
+</p:notes>
+</file>
+
+<file path=ppt/notesSlides/notesSlide13.xml><?xml version="1.0" encoding="utf-8"?>
+<p:notes xmlns:a="http://schemas.openxmlformats.org/drawingml/2006/main" xmlns:p="http://schemas.openxmlformats.org/presentationml/2006/main" xmlns:r="http://schemas.openxmlformats.org/officeDocument/2006/relationships">
+  <p:cSld>
+    <p:spTree>
+      <p:nvGrpSpPr>
+        <p:cNvPr id="1" name=""/>
+        <p:cNvGrpSpPr/>
+        <p:nvPr/>
+      </p:nvGrpSpPr>
+      <p:grpSpPr>
+        <a:xfrm>
+          <a:off x="0" y="0"/>
+          <a:ext cx="0" cy="0"/>
+          <a:chOff x="0" y="0"/>
+          <a:chExt cx="0" cy="0"/>
+        </a:xfrm>
+      </p:grpSpPr>
+      <p:sp>
+        <p:nvSpPr>
+          <p:cNvPr id="2" name="Notes Placeholder 1"/>
+          <p:cNvSpPr>
+            <a:spLocks noGrp="1"/>
+          </p:cNvSpPr>
+          <p:nvPr>
+            <p:ph type="body" idx="1"/>
+          </p:nvPr>
+        </p:nvSpPr>
+        <p:spPr/>
+        <p:txBody>
+          <a:bodyPr/>
+          <a:lstStyle/>
+          <a:p>
+            <a:r>
+              <a:t>S9 · 7:10–7:20 · LEAD: CONTENT PRESENTER</a:t>
+            </a:r>
+          </a:p>
+          <a:p>
+            <a:r>
+              <a:t>BEATS: 1. Frame, 30 seconds: 'Before we go into the garden, we remember a time we really heard — and how we knew. Next time is Any Doubts?; this is the ground under it.' 2. A leader tells first, arranged beforehand: two or three plain sentences — a real time you heard, how you knew, what you did. 3. Quiet recall, 3 minutes, journals open: when and where, what was going on, what it looked, sounded or felt like, what you heard, what you did with it. Make it fuller as you write. 4. Pairs, 4 minutes, by invitation: the partner asks only one question — 'How did you know?' — and listens.</a:t>
+            </a:r>
+          </a:p>
+          <a:p>
+            <a:r>
+              <a:t>CUES: Never cold-call a teen; pass-anytime holds. 'I can't think of one' is an honest answer — offer the creation door (Rom. 1:20) or a time you simply knew something was true. Keep the answers to 'How did you know?' for the next slide.</a:t>
+            </a:r>
+          </a:p>
+          <a:p>
+            <a:r>
+              <a:t>GUARD: This is remembering, not judging — no one rules on whether another person's hearing was God. If a memory turns heavy, the Settle Protocol stands.</a:t>
+            </a:r>
+          </a:p>
+          <a:p>
+            <a:r>
+              <a:t>FROM: the Four Connects deck (FotH, September 2025), 'Hearing God — The How': remember a time of hearing, see it, hear it, feel it, make it fuller, anchor it.</a:t>
             </a:r>
           </a:p>
         </p:txBody>
@@ -1586,6 +1647,72 @@
           <a:p>
             <a:r>
               <a:t>GUARD: The sheet-walk, not a re-teach.</a:t>
+            </a:r>
+          </a:p>
+        </p:txBody>
+      </p:sp>
+    </p:spTree>
+  </p:cSld>
+  <p:clrMapOvr>
+    <a:masterClrMapping/>
+  </p:clrMapOvr>
+</p:notes>
+</file>
+
+<file path=ppt/notesSlides/notesSlide17.xml><?xml version="1.0" encoding="utf-8"?>
+<p:notes xmlns:a="http://schemas.openxmlformats.org/drawingml/2006/main" xmlns:p="http://schemas.openxmlformats.org/presentationml/2006/main" xmlns:r="http://schemas.openxmlformats.org/officeDocument/2006/relationships">
+  <p:cSld>
+    <p:spTree>
+      <p:nvGrpSpPr>
+        <p:cNvPr id="1" name=""/>
+        <p:cNvGrpSpPr/>
+        <p:nvPr/>
+      </p:nvGrpSpPr>
+      <p:grpSpPr>
+        <a:xfrm>
+          <a:off x="0" y="0"/>
+          <a:ext cx="0" cy="0"/>
+          <a:chOff x="0" y="0"/>
+          <a:chExt cx="0" cy="0"/>
+        </a:xfrm>
+      </p:grpSpPr>
+      <p:sp>
+        <p:nvSpPr>
+          <p:cNvPr id="2" name="Notes Placeholder 1"/>
+          <p:cNvSpPr>
+            <a:spLocks noGrp="1"/>
+          </p:cNvSpPr>
+          <p:nvPr>
+            <p:ph type="body" idx="1"/>
+          </p:nvPr>
+        </p:nvSpPr>
+        <p:spPr/>
+        <p:txBody>
+          <a:bodyPr/>
+          <a:lstStyle/>
+          <a:p>
+            <a:r>
+              <a:t>S9 · 7:20–7:25 · LEAD: CONTENT PRESENTER</a:t>
+            </a:r>
+          </a:p>
+          <a:p>
+            <a:r>
+              <a:t>BEATS: 1. The room round, 2 minutes: 'How did you know?' Collect the answers aloud; the container holder writes them on a sheet. 2. Then the slide: line the room's answers up with the checks — most will already be there. Name any the room found that the slide does not have; they count. 3. Scripture first: it is the court, and the others confirm. No one check is enough on its own — and peace can be faked by wanting something badly. 4. Obedience: 'What happened when you obeyed?' Obeying what you hear opens you to hear more. 5. Bridge: 'Tonight in the garden, notice — don't conclude. On your returns you will test what you noticed. The card in your take-home has these checks.'</a:t>
+            </a:r>
+          </a:p>
+          <a:p>
+            <a:r>
+              <a:t>CUES: A practice, not a lecture — the room's list leads and the slide confirms. Five minutes; the garden needs its time.</a:t>
+            </a:r>
+          </a:p>
+          <a:p>
+            <a:r>
+              <a:t>GUARD: No one tests someone else's hearing aloud tonight. Each person tests their own, in company they choose.</a:t>
+            </a:r>
+          </a:p>
+          <a:p>
+            <a:r>
+              <a:t>FROM: the Four Connects deck (FotH, September 2025), 'Hearing God — What If?': how do you know something is from the Lord? It lines up with Scripture, reason, the witness of the Spirit, peace, community, circumstances.</a:t>
             </a:r>
           </a:p>
         </p:txBody>
@@ -5050,7 +5177,7 @@
           <a:p>
             <a:pPr algn="r"/>
             <a:r>
-              <a:t>G10</a:t>
+              <a:t>G12</a:t>
             </a:r>
             <a:endParaRPr sz="1000" b="1">
               <a:solidFill>
@@ -5180,7 +5307,7 @@
               </a:spcAft>
             </a:pPr>
             <a:r>
-              <a:rPr sz="2000" b="1" i="0">
+              <a:rPr sz="1900" b="1" i="0">
                 <a:solidFill>
                   <a:srgbClr val="97BC62"/>
                 </a:solidFill>
@@ -5189,7 +5316,7 @@
               <a:t>•  </a:t>
             </a:r>
             <a:r>
-              <a:rPr sz="2000" b="0" i="0">
+              <a:rPr sz="1900" b="0" i="0">
                 <a:solidFill>
                   <a:srgbClr val="222B22"/>
                 </a:solidFill>
@@ -5205,7 +5332,7 @@
               </a:spcAft>
             </a:pPr>
             <a:r>
-              <a:rPr sz="2000" b="1" i="0">
+              <a:rPr sz="1900" b="1" i="0">
                 <a:solidFill>
                   <a:srgbClr val="97BC62"/>
                 </a:solidFill>
@@ -5214,7 +5341,7 @@
               <a:t>•  </a:t>
             </a:r>
             <a:r>
-              <a:rPr sz="2000" b="0" i="0">
+              <a:rPr sz="1900" b="0" i="0">
                 <a:solidFill>
                   <a:srgbClr val="222B22"/>
                 </a:solidFill>
@@ -5230,7 +5357,7 @@
               </a:spcAft>
             </a:pPr>
             <a:r>
-              <a:rPr sz="2000" b="1" i="0">
+              <a:rPr sz="1900" b="1" i="0">
                 <a:solidFill>
                   <a:srgbClr val="97BC62"/>
                 </a:solidFill>
@@ -5239,7 +5366,7 @@
               <a:t>•  </a:t>
             </a:r>
             <a:r>
-              <a:rPr sz="2000" b="0" i="0">
+              <a:rPr sz="1900" b="0" i="0">
                 <a:solidFill>
                   <a:srgbClr val="222B22"/>
                 </a:solidFill>
@@ -5255,7 +5382,7 @@
               </a:spcAft>
             </a:pPr>
             <a:r>
-              <a:rPr sz="2000" b="1" i="0">
+              <a:rPr sz="1900" b="1" i="0">
                 <a:solidFill>
                   <a:srgbClr val="97BC62"/>
                 </a:solidFill>
@@ -5264,12 +5391,37 @@
               <a:t>•  </a:t>
             </a:r>
             <a:r>
-              <a:rPr sz="2000" b="0" i="0">
+              <a:rPr sz="1900" b="0" i="0">
                 <a:solidFill>
                   <a:srgbClr val="222B22"/>
                 </a:solidFill>
                 <a:latin typeface="Calibri"/>
               </a:rPr>
+              <a:t>After each return, test what you noticed — does it fit Scripture? Who could I tell? (the How Did You Know? card)</a:t>
+            </a:r>
+          </a:p>
+          <a:p>
+            <a:pPr marL="274320" indent="-274320">
+              <a:spcAft>
+                <a:spcPts val="750"/>
+              </a:spcAft>
+            </a:pPr>
+            <a:r>
+              <a:rPr sz="1900" b="1" i="0">
+                <a:solidFill>
+                  <a:srgbClr val="97BC62"/>
+                </a:solidFill>
+                <a:latin typeface="Calibri"/>
+              </a:rPr>
+              <a:t>•  </a:t>
+            </a:r>
+            <a:r>
+              <a:rPr sz="1900" b="0" i="0">
+                <a:solidFill>
+                  <a:srgbClr val="222B22"/>
+                </a:solidFill>
+                <a:latin typeface="Calibri"/>
+              </a:rPr>
               <a:t>Pick three days and a time — morning before the day starts is often best</a:t>
             </a:r>
           </a:p>
@@ -5280,7 +5432,7 @@
               </a:spcAft>
             </a:pPr>
             <a:r>
-              <a:rPr sz="2000" b="1" i="0">
+              <a:rPr sz="1900" b="1" i="0">
                 <a:solidFill>
                   <a:srgbClr val="97BC62"/>
                 </a:solidFill>
@@ -5289,7 +5441,7 @@
               <a:t>•  </a:t>
             </a:r>
             <a:r>
-              <a:rPr sz="2000" b="0" i="0">
+              <a:rPr sz="1900" b="0" i="0">
                 <a:solidFill>
                   <a:srgbClr val="222B22"/>
                 </a:solidFill>
@@ -5305,7 +5457,7 @@
               </a:spcAft>
             </a:pPr>
             <a:r>
-              <a:rPr sz="2000" b="1" i="0">
+              <a:rPr sz="1900" b="1" i="0">
                 <a:solidFill>
                   <a:srgbClr val="97BC62"/>
                 </a:solidFill>
@@ -5314,7 +5466,7 @@
               <a:t>•  </a:t>
             </a:r>
             <a:r>
-              <a:rPr sz="2000" b="0" i="0">
+              <a:rPr sz="1900" b="0" i="0">
                 <a:solidFill>
                   <a:srgbClr val="222B22"/>
                 </a:solidFill>
@@ -5347,7 +5499,7 @@
           <a:p>
             <a:pPr algn="r"/>
             <a:r>
-              <a:t>G11</a:t>
+              <a:t>G13</a:t>
             </a:r>
             <a:endParaRPr sz="1000" b="1">
               <a:solidFill>
@@ -5575,7 +5727,7 @@
           <a:p>
             <a:pPr algn="r"/>
             <a:r>
-              <a:t>G12</a:t>
+              <a:t>G14</a:t>
             </a:r>
             <a:endParaRPr sz="1000" b="1">
               <a:solidFill>
@@ -5767,7 +5919,7 @@
           <a:p>
             <a:pPr algn="r"/>
             <a:r>
-              <a:t>G13</a:t>
+              <a:t>G15</a:t>
             </a:r>
             <a:endParaRPr sz="1000" b="1">
               <a:solidFill>
@@ -6064,7 +6216,7 @@
           <a:p>
             <a:pPr algn="r"/>
             <a:r>
-              <a:t>G14</a:t>
+              <a:t>G16</a:t>
             </a:r>
             <a:endParaRPr sz="1000" b="1">
               <a:solidFill>
@@ -6509,7 +6661,747 @@
           <a:p>
             <a:pPr algn="r"/>
             <a:r>
-              <a:t>G15</a:t>
+              <a:t>G17</a:t>
+            </a:r>
+            <a:endParaRPr sz="1000" b="1">
+              <a:solidFill>
+                <a:srgbClr val="7A8A6E"/>
+              </a:solidFill>
+              <a:latin typeface="Calibri"/>
+            </a:endParaRPr>
+          </a:p>
+        </p:txBody>
+      </p:sp>
+    </p:spTree>
+  </p:cSld>
+  <p:clrMapOvr>
+    <a:masterClrMapping/>
+  </p:clrMapOvr>
+</p:sld>
+</file>
+
+<file path=ppt/slides/slide16.xml><?xml version="1.0" encoding="utf-8"?>
+<p:sld xmlns:a="http://schemas.openxmlformats.org/drawingml/2006/main" xmlns:p="http://schemas.openxmlformats.org/presentationml/2006/main" xmlns:r="http://schemas.openxmlformats.org/officeDocument/2006/relationships">
+  <p:cSld>
+    <p:spTree>
+      <p:nvGrpSpPr>
+        <p:cNvPr id="1" name=""/>
+        <p:cNvGrpSpPr/>
+        <p:nvPr/>
+      </p:nvGrpSpPr>
+      <p:grpSpPr/>
+      <p:sp>
+        <p:nvSpPr>
+          <p:cNvPr id="2" name="Rectangle 1"/>
+          <p:cNvSpPr/>
+          <p:nvPr/>
+        </p:nvSpPr>
+        <p:spPr>
+          <a:xfrm>
+            <a:off x="0" y="0"/>
+            <a:ext cx="12191695" cy="6858000"/>
+          </a:xfrm>
+          <a:prstGeom prst="rect">
+            <a:avLst/>
+          </a:prstGeom>
+          <a:solidFill>
+            <a:srgbClr val="FFFFFF"/>
+          </a:solidFill>
+          <a:ln>
+            <a:noFill/>
+          </a:ln>
+        </p:spPr>
+        <p:txBody>
+          <a:bodyPr/>
+          <a:lstStyle/>
+          <a:p>
+            <a:endParaRPr/>
+          </a:p>
+        </p:txBody>
+      </p:sp>
+      <p:sp>
+        <p:nvSpPr>
+          <p:cNvPr id="3" name="TextBox 2"/>
+          <p:cNvSpPr txBox="1"/>
+          <p:nvPr/>
+        </p:nvSpPr>
+        <p:spPr>
+          <a:xfrm>
+            <a:off x="822960" y="502920"/>
+            <a:ext cx="10515600" cy="822960"/>
+          </a:xfrm>
+          <a:prstGeom prst="rect">
+            <a:avLst/>
+          </a:prstGeom>
+          <a:noFill/>
+        </p:spPr>
+        <p:txBody>
+          <a:bodyPr wrap="square">
+            <a:spAutoFit/>
+          </a:bodyPr>
+          <a:lstStyle/>
+          <a:p>
+            <a:pPr algn="l">
+              <a:spcAft>
+                <a:spcPts val="600"/>
+              </a:spcAft>
+            </a:pPr>
+            <a:r>
+              <a:rPr sz="2800" b="1" i="0">
+                <a:solidFill>
+                  <a:srgbClr val="2C5F2D"/>
+                </a:solidFill>
+                <a:latin typeface="Cambria"/>
+              </a:rPr>
+              <a:t>When Have You Really Heard?</a:t>
+            </a:r>
+          </a:p>
+        </p:txBody>
+      </p:sp>
+      <p:sp>
+        <p:nvSpPr>
+          <p:cNvPr id="4" name="TextBox 4"/>
+          <p:cNvSpPr txBox="1"/>
+          <p:nvPr/>
+        </p:nvSpPr>
+        <p:spPr>
+          <a:xfrm>
+            <a:off x="822960" y="1600200"/>
+            <a:ext cx="5669280" cy="4572000"/>
+          </a:xfrm>
+          <a:prstGeom prst="rect">
+            <a:avLst/>
+          </a:prstGeom>
+          <a:noFill/>
+        </p:spPr>
+        <p:txBody>
+          <a:bodyPr wrap="square" lIns="91440" tIns="91440" rIns="91440" bIns="91440"/>
+          <a:lstStyle/>
+          <a:p>
+            <a:pPr marL="274320" indent="-274320">
+              <a:spcAft>
+                <a:spcPts val="650"/>
+              </a:spcAft>
+            </a:pPr>
+            <a:r>
+              <a:rPr sz="1800" b="1" i="0">
+                <a:solidFill>
+                  <a:srgbClr val="97BC62"/>
+                </a:solidFill>
+                <a:latin typeface="Calibri"/>
+              </a:rPr>
+              <a:t>•  </a:t>
+            </a:r>
+            <a:r>
+              <a:rPr sz="1800" b="0" i="0">
+                <a:solidFill>
+                  <a:srgbClr val="222B22"/>
+                </a:solidFill>
+                <a:latin typeface="Calibri"/>
+              </a:rPr>
+              <a:t>Remember one time you really heard God — a verse that jumped off the page, a nudge, a word through someone, a quiet knowing</a:t>
+            </a:r>
+          </a:p>
+          <a:p>
+            <a:pPr marL="274320" indent="-274320">
+              <a:spcAft>
+                <a:spcPts val="650"/>
+              </a:spcAft>
+            </a:pPr>
+            <a:r>
+              <a:rPr sz="1800" b="1" i="0">
+                <a:solidFill>
+                  <a:srgbClr val="97BC62"/>
+                </a:solidFill>
+                <a:latin typeface="Calibri"/>
+              </a:rPr>
+              <a:t>•  </a:t>
+            </a:r>
+            <a:r>
+              <a:rPr sz="1800" b="0" i="0">
+                <a:solidFill>
+                  <a:srgbClr val="222B22"/>
+                </a:solidFill>
+                <a:latin typeface="Calibri"/>
+              </a:rPr>
+              <a:t>Where were you, and what was going on? Reading, worship, a conversation, outdoors, a hard day</a:t>
+            </a:r>
+          </a:p>
+          <a:p>
+            <a:pPr marL="274320" indent="-274320">
+              <a:spcAft>
+                <a:spcPts val="650"/>
+              </a:spcAft>
+            </a:pPr>
+            <a:r>
+              <a:rPr sz="1800" b="1" i="0">
+                <a:solidFill>
+                  <a:srgbClr val="97BC62"/>
+                </a:solidFill>
+                <a:latin typeface="Calibri"/>
+              </a:rPr>
+              <a:t>•  </a:t>
+            </a:r>
+            <a:r>
+              <a:rPr sz="1800" b="0" i="0">
+                <a:solidFill>
+                  <a:srgbClr val="222B22"/>
+                </a:solidFill>
+                <a:latin typeface="Calibri"/>
+              </a:rPr>
+              <a:t>What did it look like, sound like, feel like? Write it down — make it fuller</a:t>
+            </a:r>
+          </a:p>
+          <a:p>
+            <a:pPr marL="274320" indent="-274320">
+              <a:spcAft>
+                <a:spcPts val="650"/>
+              </a:spcAft>
+            </a:pPr>
+            <a:r>
+              <a:rPr sz="1800" b="1" i="0">
+                <a:solidFill>
+                  <a:srgbClr val="97BC62"/>
+                </a:solidFill>
+                <a:latin typeface="Calibri"/>
+              </a:rPr>
+              <a:t>•  </a:t>
+            </a:r>
+            <a:r>
+              <a:rPr sz="1800" b="0" i="0">
+                <a:solidFill>
+                  <a:srgbClr val="222B22"/>
+                </a:solidFill>
+                <a:latin typeface="Calibri"/>
+              </a:rPr>
+              <a:t>What did you do with it — and what happened?</a:t>
+            </a:r>
+          </a:p>
+          <a:p>
+            <a:pPr marL="274320" indent="-274320">
+              <a:spcAft>
+                <a:spcPts val="650"/>
+              </a:spcAft>
+            </a:pPr>
+            <a:r>
+              <a:rPr sz="1800" b="1" i="0">
+                <a:solidFill>
+                  <a:srgbClr val="97BC62"/>
+                </a:solidFill>
+                <a:latin typeface="Calibri"/>
+              </a:rPr>
+              <a:t>•  </a:t>
+            </a:r>
+            <a:r>
+              <a:rPr sz="1800" b="0" i="0">
+                <a:solidFill>
+                  <a:srgbClr val="222B22"/>
+                </a:solidFill>
+                <a:latin typeface="Calibri"/>
+              </a:rPr>
+              <a:t>Can’t think of one? A time creation stopped you in your tracks counts — God speaks through what he has made (Rom. 1:20)</a:t>
+            </a:r>
+          </a:p>
+          <a:p>
+            <a:pPr marL="274320" indent="-274320">
+              <a:spcAft>
+                <a:spcPts val="650"/>
+              </a:spcAft>
+            </a:pPr>
+            <a:r>
+              <a:rPr sz="1800" b="1" i="0">
+                <a:solidFill>
+                  <a:srgbClr val="97BC62"/>
+                </a:solidFill>
+                <a:latin typeface="Calibri"/>
+              </a:rPr>
+              <a:t>•  </a:t>
+            </a:r>
+            <a:r>
+              <a:rPr sz="1800" b="0" i="0">
+                <a:solidFill>
+                  <a:srgbClr val="222B22"/>
+                </a:solidFill>
+                <a:latin typeface="Calibri"/>
+              </a:rPr>
+              <a:t>Pairs, by invitation — your partner asks one question: “How did you know?”</a:t>
+            </a:r>
+          </a:p>
+        </p:txBody>
+      </p:sp>
+      <p:sp>
+        <p:nvSpPr>
+          <p:cNvPr id="6" name="TextBox 6"/>
+          <p:cNvSpPr txBox="1"/>
+          <p:nvPr/>
+        </p:nvSpPr>
+        <p:spPr>
+          <a:xfrm>
+            <a:off x="6766560" y="1737360"/>
+            <a:ext cx="4663440" cy="2194560"/>
+          </a:xfrm>
+          <a:prstGeom prst="rect">
+            <a:avLst/>
+          </a:prstGeom>
+          <a:solidFill>
+            <a:srgbClr val="F1F6EC"/>
+          </a:solidFill>
+        </p:spPr>
+        <p:txBody>
+          <a:bodyPr wrap="square" lIns="91440" tIns="91440" rIns="91440" bIns="91440" anchor="ctr"/>
+          <a:lstStyle/>
+          <a:p>
+            <a:pPr>
+              <a:spcAft>
+                <a:spcPts val="900"/>
+              </a:spcAft>
+            </a:pPr>
+            <a:r>
+              <a:rPr sz="1200" b="1" i="0">
+                <a:solidFill>
+                  <a:srgbClr val="97BC62"/>
+                </a:solidFill>
+                <a:latin typeface="Calibri"/>
+              </a:rPr>
+              <a:t>JOHN 10:27</a:t>
+            </a:r>
+          </a:p>
+          <a:p>
+            <a:pPr>
+              <a:spcAft>
+                <a:spcPts val="600"/>
+              </a:spcAft>
+            </a:pPr>
+            <a:r>
+              <a:rPr sz="2400" b="0" i="1">
+                <a:solidFill>
+                  <a:srgbClr val="222B22"/>
+                </a:solidFill>
+                <a:latin typeface="Cambria"/>
+              </a:rPr>
+              <a:t>“My sheep hear my voice, and I know them, and they follow me.”</a:t>
+            </a:r>
+          </a:p>
+        </p:txBody>
+      </p:sp>
+      <p:sp>
+        <p:nvSpPr>
+          <p:cNvPr id="90" name="SlideNum"/>
+          <p:cNvSpPr txBox="1"/>
+          <p:nvPr/>
+        </p:nvSpPr>
+        <p:spPr>
+          <a:xfrm>
+            <a:off x="11384280" y="6446520"/>
+            <a:ext cx="640080" cy="292608"/>
+          </a:xfrm>
+          <a:prstGeom prst="rect">
+            <a:avLst/>
+          </a:prstGeom>
+          <a:noFill/>
+        </p:spPr>
+        <p:txBody>
+          <a:bodyPr wrap="none" lIns="0" tIns="0" rIns="45720" bIns="0" anchor="ctr"/>
+          <a:lstStyle/>
+          <a:p>
+            <a:pPr algn="r"/>
+            <a:r>
+              <a:t>G7</a:t>
+            </a:r>
+            <a:endParaRPr sz="1000" b="1">
+              <a:solidFill>
+                <a:srgbClr val="7A8A6E"/>
+              </a:solidFill>
+              <a:latin typeface="Calibri"/>
+            </a:endParaRPr>
+          </a:p>
+        </p:txBody>
+      </p:sp>
+    </p:spTree>
+  </p:cSld>
+  <p:clrMapOvr>
+    <a:masterClrMapping/>
+  </p:clrMapOvr>
+</p:sld>
+</file>
+
+<file path=ppt/slides/slide17.xml><?xml version="1.0" encoding="utf-8"?>
+<p:sld xmlns:a="http://schemas.openxmlformats.org/drawingml/2006/main" xmlns:p="http://schemas.openxmlformats.org/presentationml/2006/main" xmlns:r="http://schemas.openxmlformats.org/officeDocument/2006/relationships">
+  <p:cSld>
+    <p:spTree>
+      <p:nvGrpSpPr>
+        <p:cNvPr id="1" name=""/>
+        <p:cNvGrpSpPr/>
+        <p:nvPr/>
+      </p:nvGrpSpPr>
+      <p:grpSpPr/>
+      <p:sp>
+        <p:nvSpPr>
+          <p:cNvPr id="2" name="Rectangle 1"/>
+          <p:cNvSpPr/>
+          <p:nvPr/>
+        </p:nvSpPr>
+        <p:spPr>
+          <a:xfrm>
+            <a:off x="0" y="0"/>
+            <a:ext cx="12191695" cy="6858000"/>
+          </a:xfrm>
+          <a:prstGeom prst="rect">
+            <a:avLst/>
+          </a:prstGeom>
+          <a:solidFill>
+            <a:srgbClr val="FFFFFF"/>
+          </a:solidFill>
+          <a:ln>
+            <a:noFill/>
+          </a:ln>
+        </p:spPr>
+        <p:txBody>
+          <a:bodyPr/>
+          <a:lstStyle/>
+          <a:p>
+            <a:endParaRPr/>
+          </a:p>
+        </p:txBody>
+      </p:sp>
+      <p:sp>
+        <p:nvSpPr>
+          <p:cNvPr id="3" name="TextBox 2"/>
+          <p:cNvSpPr txBox="1"/>
+          <p:nvPr/>
+        </p:nvSpPr>
+        <p:spPr>
+          <a:xfrm>
+            <a:off x="822960" y="502920"/>
+            <a:ext cx="10515600" cy="822960"/>
+          </a:xfrm>
+          <a:prstGeom prst="rect">
+            <a:avLst/>
+          </a:prstGeom>
+          <a:noFill/>
+        </p:spPr>
+        <p:txBody>
+          <a:bodyPr wrap="square">
+            <a:spAutoFit/>
+          </a:bodyPr>
+          <a:lstStyle/>
+          <a:p>
+            <a:pPr algn="l">
+              <a:spcAft>
+                <a:spcPts val="600"/>
+              </a:spcAft>
+            </a:pPr>
+            <a:r>
+              <a:rPr sz="2800" b="1" i="0">
+                <a:solidFill>
+                  <a:srgbClr val="2C5F2D"/>
+                </a:solidFill>
+                <a:latin typeface="Cambria"/>
+              </a:rPr>
+              <a:t>How Did You Know? — Testing What You Hear</a:t>
+            </a:r>
+          </a:p>
+        </p:txBody>
+      </p:sp>
+      <p:sp>
+        <p:nvSpPr>
+          <p:cNvPr id="4" name="TextBox 4"/>
+          <p:cNvSpPr txBox="1"/>
+          <p:nvPr/>
+        </p:nvSpPr>
+        <p:spPr>
+          <a:xfrm>
+            <a:off x="822960" y="1600200"/>
+            <a:ext cx="5669280" cy="4572000"/>
+          </a:xfrm>
+          <a:prstGeom prst="rect">
+            <a:avLst/>
+          </a:prstGeom>
+          <a:noFill/>
+        </p:spPr>
+        <p:txBody>
+          <a:bodyPr wrap="square" lIns="91440" tIns="91440" rIns="91440" bIns="91440"/>
+          <a:lstStyle/>
+          <a:p>
+            <a:pPr marL="274320" indent="-274320">
+              <a:spcAft>
+                <a:spcPts val="650"/>
+              </a:spcAft>
+            </a:pPr>
+            <a:r>
+              <a:rPr sz="1700" b="1" i="0">
+                <a:solidFill>
+                  <a:srgbClr val="97BC62"/>
+                </a:solidFill>
+                <a:latin typeface="Calibri"/>
+              </a:rPr>
+              <a:t>•  </a:t>
+            </a:r>
+            <a:r>
+              <a:rPr sz="1700" b="0" i="0">
+                <a:solidFill>
+                  <a:srgbClr val="222B22"/>
+                </a:solidFill>
+                <a:latin typeface="Calibri"/>
+              </a:rPr>
+              <a:t>Scripture first — does it line up with what God has already said? Scripture is the court; the rest confirm</a:t>
+            </a:r>
+          </a:p>
+          <a:p>
+            <a:pPr marL="274320" indent="-274320">
+              <a:spcAft>
+                <a:spcPts val="650"/>
+              </a:spcAft>
+            </a:pPr>
+            <a:r>
+              <a:rPr sz="1700" b="1" i="0">
+                <a:solidFill>
+                  <a:srgbClr val="97BC62"/>
+                </a:solidFill>
+                <a:latin typeface="Calibri"/>
+              </a:rPr>
+              <a:t>•  </a:t>
+            </a:r>
+            <a:r>
+              <a:rPr sz="1700" b="0" i="0">
+                <a:solidFill>
+                  <a:srgbClr val="222B22"/>
+                </a:solidFill>
+                <a:latin typeface="Calibri"/>
+              </a:rPr>
+              <a:t>Sense — does it make sense, or does it ask you to switch your mind off?</a:t>
+            </a:r>
+          </a:p>
+          <a:p>
+            <a:pPr marL="274320" indent="-274320">
+              <a:spcAft>
+                <a:spcPts val="650"/>
+              </a:spcAft>
+            </a:pPr>
+            <a:r>
+              <a:rPr sz="1700" b="1" i="0">
+                <a:solidFill>
+                  <a:srgbClr val="97BC62"/>
+                </a:solidFill>
+                <a:latin typeface="Calibri"/>
+              </a:rPr>
+              <a:t>•  </a:t>
+            </a:r>
+            <a:r>
+              <a:rPr sz="1700" b="0" i="0">
+                <a:solidFill>
+                  <a:srgbClr val="222B22"/>
+                </a:solidFill>
+                <a:latin typeface="Calibri"/>
+              </a:rPr>
+              <a:t>The Spirit’s witness — an inner “yes” that rings true (Rom. 8:16)</a:t>
+            </a:r>
+          </a:p>
+          <a:p>
+            <a:pPr marL="274320" indent="-274320">
+              <a:spcAft>
+                <a:spcPts val="650"/>
+              </a:spcAft>
+            </a:pPr>
+            <a:r>
+              <a:rPr sz="1700" b="1" i="0">
+                <a:solidFill>
+                  <a:srgbClr val="97BC62"/>
+                </a:solidFill>
+                <a:latin typeface="Calibri"/>
+              </a:rPr>
+              <a:t>•  </a:t>
+            </a:r>
+            <a:r>
+              <a:rPr sz="1700" b="0" i="0">
+                <a:solidFill>
+                  <a:srgbClr val="222B22"/>
+                </a:solidFill>
+                <a:latin typeface="Calibri"/>
+              </a:rPr>
+              <a:t>Peace — even when the word is hard (Col. 3:15)</a:t>
+            </a:r>
+          </a:p>
+          <a:p>
+            <a:pPr marL="274320" indent="-274320">
+              <a:spcAft>
+                <a:spcPts val="650"/>
+              </a:spcAft>
+            </a:pPr>
+            <a:r>
+              <a:rPr sz="1700" b="1" i="0">
+                <a:solidFill>
+                  <a:srgbClr val="97BC62"/>
+                </a:solidFill>
+                <a:latin typeface="Calibri"/>
+              </a:rPr>
+              <a:t>•  </a:t>
+            </a:r>
+            <a:r>
+              <a:rPr sz="1700" b="0" i="0">
+                <a:solidFill>
+                  <a:srgbClr val="222B22"/>
+                </a:solidFill>
+                <a:latin typeface="Calibri"/>
+              </a:rPr>
+              <a:t>Company — what do people who know you and know God see?</a:t>
+            </a:r>
+          </a:p>
+          <a:p>
+            <a:pPr marL="274320" indent="-274320">
+              <a:spcAft>
+                <a:spcPts val="650"/>
+              </a:spcAft>
+            </a:pPr>
+            <a:r>
+              <a:rPr sz="1700" b="1" i="0">
+                <a:solidFill>
+                  <a:srgbClr val="97BC62"/>
+                </a:solidFill>
+                <a:latin typeface="Calibri"/>
+              </a:rPr>
+              <a:t>•  </a:t>
+            </a:r>
+            <a:r>
+              <a:rPr sz="1700" b="0" i="0">
+                <a:solidFill>
+                  <a:srgbClr val="222B22"/>
+                </a:solidFill>
+                <a:latin typeface="Calibri"/>
+              </a:rPr>
+              <a:t>Circumstances — do doors open or close around it?</a:t>
+            </a:r>
+          </a:p>
+          <a:p>
+            <a:pPr marL="274320" indent="-274320">
+              <a:spcAft>
+                <a:spcPts val="650"/>
+              </a:spcAft>
+            </a:pPr>
+            <a:r>
+              <a:rPr sz="1700" b="1" i="0">
+                <a:solidFill>
+                  <a:srgbClr val="97BC62"/>
+                </a:solidFill>
+                <a:latin typeface="Calibri"/>
+              </a:rPr>
+              <a:t>•  </a:t>
+            </a:r>
+            <a:r>
+              <a:rPr sz="1700" b="0" i="0">
+                <a:solidFill>
+                  <a:srgbClr val="222B22"/>
+                </a:solidFill>
+                <a:latin typeface="Calibri"/>
+              </a:rPr>
+              <a:t>Over time — obeying what you hear opens you to hear more</a:t>
+            </a:r>
+          </a:p>
+          <a:p>
+            <a:pPr marL="274320" indent="-274320">
+              <a:spcAft>
+                <a:spcPts val="650"/>
+              </a:spcAft>
+            </a:pPr>
+            <a:r>
+              <a:rPr sz="1700" b="1" i="0">
+                <a:solidFill>
+                  <a:srgbClr val="97BC62"/>
+                </a:solidFill>
+                <a:latin typeface="Calibri"/>
+              </a:rPr>
+              <a:t>•  </a:t>
+            </a:r>
+            <a:r>
+              <a:rPr sz="1700" b="0" i="0">
+                <a:solidFill>
+                  <a:srgbClr val="222B22"/>
+                </a:solidFill>
+                <a:latin typeface="Calibri"/>
+              </a:rPr>
+              <a:t>Tonight in the garden: notice, don’t conclude — you will test it on your returns</a:t>
+            </a:r>
+          </a:p>
+        </p:txBody>
+      </p:sp>
+      <p:sp>
+        <p:nvSpPr>
+          <p:cNvPr id="6" name="TextBox 6"/>
+          <p:cNvSpPr txBox="1"/>
+          <p:nvPr/>
+        </p:nvSpPr>
+        <p:spPr>
+          <a:xfrm>
+            <a:off x="6766560" y="1737360"/>
+            <a:ext cx="4663440" cy="2194560"/>
+          </a:xfrm>
+          <a:prstGeom prst="rect">
+            <a:avLst/>
+          </a:prstGeom>
+          <a:solidFill>
+            <a:srgbClr val="F1F6EC"/>
+          </a:solidFill>
+        </p:spPr>
+        <p:txBody>
+          <a:bodyPr wrap="square" lIns="91440" tIns="91440" rIns="91440" bIns="91440" anchor="ctr"/>
+          <a:lstStyle/>
+          <a:p>
+            <a:pPr>
+              <a:spcAft>
+                <a:spcPts val="900"/>
+              </a:spcAft>
+            </a:pPr>
+            <a:r>
+              <a:rPr sz="1200" b="1" i="0">
+                <a:solidFill>
+                  <a:srgbClr val="97BC62"/>
+                </a:solidFill>
+                <a:latin typeface="Calibri"/>
+              </a:rPr>
+              <a:t>1 THESSALONIANS 5:20–21</a:t>
+            </a:r>
+          </a:p>
+          <a:p>
+            <a:pPr>
+              <a:spcAft>
+                <a:spcPts val="600"/>
+              </a:spcAft>
+            </a:pPr>
+            <a:r>
+              <a:rPr sz="2400" b="0" i="1">
+                <a:solidFill>
+                  <a:srgbClr val="222B22"/>
+                </a:solidFill>
+                <a:latin typeface="Cambria"/>
+              </a:rPr>
+              <a:t>“Do not despise prophecies, but test everything; hold fast what is good.”</a:t>
+            </a:r>
+          </a:p>
+        </p:txBody>
+      </p:sp>
+      <p:sp>
+        <p:nvSpPr>
+          <p:cNvPr id="90" name="SlideNum"/>
+          <p:cNvSpPr txBox="1"/>
+          <p:nvPr/>
+        </p:nvSpPr>
+        <p:spPr>
+          <a:xfrm>
+            <a:off x="11384280" y="6446520"/>
+            <a:ext cx="640080" cy="292608"/>
+          </a:xfrm>
+          <a:prstGeom prst="rect">
+            <a:avLst/>
+          </a:prstGeom>
+          <a:noFill/>
+        </p:spPr>
+        <p:txBody>
+          <a:bodyPr wrap="none" lIns="0" tIns="0" rIns="45720" bIns="0" anchor="ctr"/>
+          <a:lstStyle/>
+          <a:p>
+            <a:pPr algn="r"/>
+            <a:r>
+              <a:t>G8</a:t>
             </a:r>
             <a:endParaRPr sz="1000" b="1">
               <a:solidFill>
@@ -7111,7 +8003,7 @@
               </a:spcAft>
             </a:pPr>
             <a:r>
-              <a:rPr sz="2800" b="1">
+              <a:rPr sz="2400" b="1">
                 <a:solidFill>
                   <a:srgbClr val="97BC62"/>
                 </a:solidFill>
@@ -7120,7 +8012,7 @@
               <a:t>1   </a:t>
             </a:r>
             <a:r>
-              <a:rPr sz="2800">
+              <a:rPr sz="2400">
                 <a:solidFill>
                   <a:srgbClr val="222B22"/>
                 </a:solidFill>
@@ -7136,7 +8028,7 @@
               </a:spcAft>
             </a:pPr>
             <a:r>
-              <a:rPr sz="2800" b="1">
+              <a:rPr sz="2400" b="1">
                 <a:solidFill>
                   <a:srgbClr val="97BC62"/>
                 </a:solidFill>
@@ -7145,7 +8037,7 @@
               <a:t>2   </a:t>
             </a:r>
             <a:r>
-              <a:rPr sz="2800">
+              <a:rPr sz="2400">
                 <a:solidFill>
                   <a:srgbClr val="222B22"/>
                 </a:solidFill>
@@ -7161,7 +8053,7 @@
               </a:spcAft>
             </a:pPr>
             <a:r>
-              <a:rPr sz="2800" b="1">
+              <a:rPr sz="2400" b="1">
                 <a:solidFill>
                   <a:srgbClr val="97BC62"/>
                 </a:solidFill>
@@ -7170,12 +8062,37 @@
               <a:t>3   </a:t>
             </a:r>
             <a:r>
-              <a:rPr sz="2800">
+              <a:rPr sz="2400">
                 <a:solidFill>
                   <a:srgbClr val="222B22"/>
                 </a:solidFill>
                 <a:latin typeface="Calibri"/>
               </a:rPr>
+              <a:t>When have you heard God? How did you know?</a:t>
+            </a:r>
+          </a:p>
+          <a:p>
+            <a:pPr>
+              <a:spcAft>
+                <a:spcPts val="500"/>
+              </a:spcAft>
+            </a:pPr>
+            <a:r>
+              <a:rPr sz="2400" b="1">
+                <a:solidFill>
+                  <a:srgbClr val="97BC62"/>
+                </a:solidFill>
+                <a:latin typeface="Calibri"/>
+              </a:rPr>
+              <a:t>4   </a:t>
+            </a:r>
+            <a:r>
+              <a:rPr sz="2400">
+                <a:solidFill>
+                  <a:srgbClr val="222B22"/>
+                </a:solidFill>
+                <a:latin typeface="Calibri"/>
+              </a:rPr>
               <a:t>Scripture and framing</a:t>
             </a:r>
           </a:p>
@@ -7186,16 +8103,16 @@
               </a:spcAft>
             </a:pPr>
             <a:r>
-              <a:rPr sz="2800" b="1">
+              <a:rPr sz="2400" b="1">
                 <a:solidFill>
                   <a:srgbClr val="97BC62"/>
                 </a:solidFill>
                 <a:latin typeface="Calibri"/>
               </a:rPr>
-              <a:t>4   </a:t>
-            </a:r>
-            <a:r>
-              <a:rPr sz="2800">
+              <a:t>5   </a:t>
+            </a:r>
+            <a:r>
+              <a:rPr sz="2400">
                 <a:solidFill>
                   <a:srgbClr val="222B22"/>
                 </a:solidFill>
@@ -7211,16 +8128,16 @@
               </a:spcAft>
             </a:pPr>
             <a:r>
-              <a:rPr sz="2800" b="1">
+              <a:rPr sz="2400" b="1">
                 <a:solidFill>
                   <a:srgbClr val="97BC62"/>
                 </a:solidFill>
                 <a:latin typeface="Calibri"/>
               </a:rPr>
-              <a:t>5   </a:t>
-            </a:r>
-            <a:r>
-              <a:rPr sz="2800">
+              <a:t>6   </a:t>
+            </a:r>
+            <a:r>
+              <a:rPr sz="2400">
                 <a:solidFill>
                   <a:srgbClr val="222B22"/>
                 </a:solidFill>
@@ -7236,16 +8153,16 @@
               </a:spcAft>
             </a:pPr>
             <a:r>
-              <a:rPr sz="2800" b="1">
+              <a:rPr sz="2400" b="1">
                 <a:solidFill>
                   <a:srgbClr val="97BC62"/>
                 </a:solidFill>
                 <a:latin typeface="Calibri"/>
               </a:rPr>
-              <a:t>6   </a:t>
-            </a:r>
-            <a:r>
-              <a:rPr sz="2800">
+              <a:t>7   </a:t>
+            </a:r>
+            <a:r>
+              <a:rPr sz="2400">
                 <a:solidFill>
                   <a:srgbClr val="222B22"/>
                 </a:solidFill>
@@ -7261,22 +8178,22 @@
               </a:spcAft>
             </a:pPr>
             <a:r>
-              <a:rPr sz="2800" b="1">
+              <a:rPr sz="2400" b="1">
                 <a:solidFill>
                   <a:srgbClr val="97BC62"/>
                 </a:solidFill>
                 <a:latin typeface="Calibri"/>
               </a:rPr>
-              <a:t>7   </a:t>
-            </a:r>
-            <a:r>
-              <a:rPr sz="2800">
+              <a:t>8   </a:t>
+            </a:r>
+            <a:r>
+              <a:rPr sz="2400">
                 <a:solidFill>
                   <a:srgbClr val="222B22"/>
                 </a:solidFill>
                 <a:latin typeface="Calibri"/>
               </a:rPr>
-              <a:t>Homework commissioning — handout + check-in partners</a:t>
+              <a:t>Homework — handout, card, check-in partners</a:t>
             </a:r>
           </a:p>
           <a:p>
@@ -7286,16 +8203,16 @@
               </a:spcAft>
             </a:pPr>
             <a:r>
-              <a:rPr sz="2800" b="1">
+              <a:rPr sz="2400" b="1">
                 <a:solidFill>
                   <a:srgbClr val="97BC62"/>
                 </a:solidFill>
                 <a:latin typeface="Calibri"/>
               </a:rPr>
-              <a:t>8   </a:t>
-            </a:r>
-            <a:r>
-              <a:rPr sz="2800">
+              <a:t>9   </a:t>
+            </a:r>
+            <a:r>
+              <a:rPr sz="2400">
                 <a:solidFill>
                   <a:srgbClr val="222B22"/>
                 </a:solidFill>
@@ -7311,16 +8228,16 @@
               </a:spcAft>
             </a:pPr>
             <a:r>
-              <a:rPr sz="2800" b="1">
+              <a:rPr sz="2400" b="1">
                 <a:solidFill>
                   <a:srgbClr val="97BC62"/>
                 </a:solidFill>
                 <a:latin typeface="Calibri"/>
               </a:rPr>
-              <a:t>9   </a:t>
-            </a:r>
-            <a:r>
-              <a:rPr sz="2800">
+              <a:t>10  </a:t>
+            </a:r>
+            <a:r>
+              <a:rPr sz="2400">
                 <a:solidFill>
                   <a:srgbClr val="222B22"/>
                 </a:solidFill>
@@ -8164,7 +9081,7 @@
                 </a:solidFill>
                 <a:latin typeface="Calibri"/>
               </a:rPr>
-              <a:t>Two passages, read slowly — Psalm 23 and John 15:1–11 — “Listen as if you have not heard it.”</a:t>
+              <a:t>John 15:1–11, read slowly — “Listen as if you have not heard it.” Then Psalm 23:1–3</a:t>
             </a:r>
           </a:p>
           <a:p>
@@ -8371,7 +9288,7 @@
           <a:p>
             <a:pPr algn="r"/>
             <a:r>
-              <a:t>G7</a:t>
+              <a:t>G9</a:t>
             </a:r>
             <a:endParaRPr sz="1000" b="1">
               <a:solidFill>
@@ -8537,7 +9454,7 @@
               </a:spcAft>
             </a:pPr>
             <a:r>
-              <a:rPr sz="2400" b="1" i="0">
+              <a:rPr sz="2200" b="1" i="0">
                 <a:solidFill>
                   <a:srgbClr val="97BC62"/>
                 </a:solidFill>
@@ -8546,7 +9463,7 @@
               <a:t>•  </a:t>
             </a:r>
             <a:r>
-              <a:rPr sz="2400" b="0" i="0">
+              <a:rPr sz="2200" b="0" i="0">
                 <a:solidFill>
                   <a:srgbClr val="222B22"/>
                 </a:solidFill>
@@ -8562,7 +9479,7 @@
               </a:spcAft>
             </a:pPr>
             <a:r>
-              <a:rPr sz="2400" b="1" i="0">
+              <a:rPr sz="2200" b="1" i="0">
                 <a:solidFill>
                   <a:srgbClr val="97BC62"/>
                 </a:solidFill>
@@ -8571,7 +9488,7 @@
               <a:t>•  </a:t>
             </a:r>
             <a:r>
-              <a:rPr sz="2400" b="0" i="0">
+              <a:rPr sz="2200" b="0" i="0">
                 <a:solidFill>
                   <a:srgbClr val="222B22"/>
                 </a:solidFill>
@@ -8587,7 +9504,7 @@
               </a:spcAft>
             </a:pPr>
             <a:r>
-              <a:rPr sz="2400" b="1" i="0">
+              <a:rPr sz="2200" b="1" i="0">
                 <a:solidFill>
                   <a:srgbClr val="97BC62"/>
                 </a:solidFill>
@@ -8596,7 +9513,7 @@
               <a:t>•  </a:t>
             </a:r>
             <a:r>
-              <a:rPr sz="2400" b="0" i="0">
+              <a:rPr sz="2200" b="0" i="0">
                 <a:solidFill>
                   <a:srgbClr val="222B22"/>
                 </a:solidFill>
@@ -8612,7 +9529,7 @@
               </a:spcAft>
             </a:pPr>
             <a:r>
-              <a:rPr sz="2400" b="1" i="0">
+              <a:rPr sz="2200" b="1" i="0">
                 <a:solidFill>
                   <a:srgbClr val="97BC62"/>
                 </a:solidFill>
@@ -8621,7 +9538,7 @@
               <a:t>•  </a:t>
             </a:r>
             <a:r>
-              <a:rPr sz="2400" b="0" i="0">
+              <a:rPr sz="2200" b="0" i="0">
                 <a:solidFill>
                   <a:srgbClr val="222B22"/>
                 </a:solidFill>
@@ -8637,7 +9554,7 @@
               </a:spcAft>
             </a:pPr>
             <a:r>
-              <a:rPr sz="2400" b="1" i="0">
+              <a:rPr sz="2200" b="1" i="0">
                 <a:solidFill>
                   <a:srgbClr val="97BC62"/>
                 </a:solidFill>
@@ -8646,7 +9563,32 @@
               <a:t>•  </a:t>
             </a:r>
             <a:r>
-              <a:rPr sz="2400" b="0" i="0">
+              <a:rPr sz="2200" b="0" i="0">
+                <a:solidFill>
+                  <a:srgbClr val="222B22"/>
+                </a:solidFill>
+                <a:latin typeface="Calibri"/>
+              </a:rPr>
+              <a:t>Notice, don’t conclude — what you notice tonight, you hold loosely and test on your returns</a:t>
+            </a:r>
+          </a:p>
+          <a:p>
+            <a:pPr marL="274320" indent="-274320">
+              <a:spcAft>
+                <a:spcPts val="900"/>
+              </a:spcAft>
+            </a:pPr>
+            <a:r>
+              <a:rPr sz="2200" b="1" i="0">
+                <a:solidFill>
+                  <a:srgbClr val="97BC62"/>
+                </a:solidFill>
+                <a:latin typeface="Calibri"/>
+              </a:rPr>
+              <a:t>•  </a:t>
+            </a:r>
+            <a:r>
+              <a:rPr sz="2200" b="0" i="0">
                 <a:solidFill>
                   <a:srgbClr val="222B22"/>
                 </a:solidFill>
@@ -8679,7 +9621,7 @@
           <a:p>
             <a:pPr algn="r"/>
             <a:r>
-              <a:t>G8</a:t>
+              <a:t>G10</a:t>
             </a:r>
             <a:endParaRPr sz="1000" b="1">
               <a:solidFill>
@@ -8976,7 +9918,7 @@
           <a:p>
             <a:pPr algn="r"/>
             <a:r>
-              <a:t>G9</a:t>
+              <a:t>G11</a:t>
             </a:r>
             <a:endParaRPr sz="1000" b="1">
               <a:solidFill>

</xml_diff>

<commit_message>
v2.31 (John's word, 13 October): Sessions 9-10 - the garden in two rounds
Round one: picture your heart as a garden, write, share (Jesus not yet
invited). Round two: go back, invite Jesus in and give him permission to do
or say anything he wishes, return, write, share. The garden slide becomes
Round One and Round Two (deck G1-G18), bridge and road name the rounds,
leader notes rebuilt; new Reading Card (H9.1 split at the gate, one round
per page) synced to Leader Notes; run sheet garden row split, still two pages.

Co-Authored-By: Claude Opus 5.5 <noreply@anthropic.com>
</commit_message>
<xml_diff>
--- a/_implementation-notes/evening-series/FotH Evening Session 9-10 Combined Slides DRAFT v1.pptx
+++ b/_implementation-notes/evening-series/FotH Evening Session 9-10 Combined Slides DRAFT v1.pptx
@@ -19,6 +19,7 @@
     <p:sldId id="403" r:id="rId119"/>
     <p:sldId id="404" r:id="rId120"/>
     <p:sldId id="405" r:id="rId121"/>
+    <p:sldId id="538" r:id="rId26"/>
     <p:sldId id="406" r:id="rId122"/>
     <p:sldId id="407" r:id="rId123"/>
     <p:sldId id="534" r:id="rId23"/>
@@ -853,7 +854,7 @@
           </a:p>
           <a:p>
             <a:r>
-              <a:t>2. Shape: open, a short check-in, remembering a real hearing and how we knew (the tests, before the garden), Scripture and framing (John 15; Psalm 23), bridge and settle, the guided run — a senior reads the walk-through, two words per second, the pauses are where the work happens; adults hold the sharing — journaling, pair sharing by invitation, merge, the returns commissioned, feedback, gentle close.</a:t>
+              <a:t>2. Shape: open, a short check-in, remembering a real hearing and how we knew (the tests, before the garden), Scripture and framing (John 15; Psalm 23), bridge and settle, the garden in two rounds — round one the garden, round two Jesus invited in with permission to do or say anything he wishes; a senior reads, two words per second, the pauses are where the work happens; write and share in pairs after each round, the adults holding the sharing; merge, the returns commissioned, feedback, gentle close.</a:t>
             </a:r>
           </a:p>
           <a:p>
@@ -1082,7 +1083,7 @@
           </a:p>
           <a:p>
             <a:r>
-              <a:t>BEATS: 1. Preview the shape: guided prayer 12–15 min, whole room, eyes open or closed, your own family beside you; then 5 min silent journaling; then pairs for sharing by invitation only — silence is a complete answer. 2. Room about ten or fewer: name it now — sharing happens right in this circle, no moving. 3. One line from the testing slide: notice, don't conclude — tonight is for noticing; the returns are for testing. 4. Pray the bridge prayer: where it is hard, be tender; where it is closed, be patient; where it is opening, be present.</a:t>
+              <a:t>BEATS: 1. Preview the shape: two rounds. Round one, the garden — read, write, share. Round two, go back and invite Jesus in, giving him permission to do or say anything he wishes — read, write, share. Whole room, eyes open or closed, your own family beside you; sharing by invitation only — silence is a complete answer. 2. Room about ten or fewer: name it now — sharing happens right in this circle, no moving. 3. One line from the testing slide: notice, don't conclude — tonight is for noticing; the returns are for testing. 4. Pray the bridge prayer: where it is hard, be tender; where it is closed, be patient; where it is opening, be present.</a:t>
             </a:r>
           </a:p>
         </p:txBody>
@@ -1128,17 +1129,17 @@
           <a:lstStyle/>
           <a:p>
             <a:r>
-              <a:t>S9 · 7:35–8:07 · LEAD: CONTENT PRESENTER</a:t>
-            </a:r>
-          </a:p>
-          <a:p>
-            <a:r>
-              <a:t>BEATS: 1. Settle 2 min. Guided prayer 12–15 min: read H9.1 slowly — two words per second, not three; every (pause) is a full 30 seconds, every (longer pause) 60. The pauses are where the work happens. 2. Silent journaling 5 min. 3. Then pairs for sharing by invitation, 8–10 min: the Companion models two plain sentences first, the arranged parent opens — receive without interpreting; never 'God was telling you...'.</a:t>
-            </a:r>
-          </a:p>
-          <a:p>
-            <a:r>
-              <a:t>CUES: Soft tears — do not stop; the tears are often the work. Never cold-call a teen; pass-anytime holds.</a:t>
+              <a:t>S9 · 7:35–7:48 · LEAD: CONTENT PRESENTER</a:t>
+            </a:r>
+          </a:p>
+          <a:p>
+            <a:r>
+              <a:t>BEATS: 1. Settle, 1 minute. 2. ROUND ONE — the reader reads Round One of the Garden Reading Card: picture your heart as a garden, walk in, notice. Two words per second, not three; every (pause) is a full 30 seconds, every (longer pause) 60 — the pauses are where the work happens. About 5 minutes. Jesus is not invited yet; this round is only the garden. 3. Write, 3 minutes: 'What does your garden look like? What is growing; what feels alive, what feels closed?' 4. Share in pairs, 4 minutes, by invitation: the arranged parent opens — receive without interpreting.</a:t>
+            </a:r>
+          </a:p>
+          <a:p>
+            <a:r>
+              <a:t>CUES: Never cold-call a teen; pass-anytime holds. Keep the clock: round two needs its full time.</a:t>
             </a:r>
           </a:p>
           <a:p>
@@ -1148,7 +1149,7 @@
           </a:p>
           <a:p>
             <a:r>
-              <a:t>COMBINED FORM: a Companion-in-Formation reads the walk-through from H10.1's pacing — two words per second, (pause) = 30 full seconds, (longer pause) = 60; the adults hold the sharing and anything that surfaces. The bright line governs throughout.</a:t>
+              <a:t>COMBINED FORM: a Companion-in-Formation reads from the Garden Reading Card (pacing as H10.1: two words per second, (pause) = 30 seconds, (longer pause) = 60); the adults hold the sharing and anything that surfaces. The bright line governs throughout.</a:t>
             </a:r>
           </a:p>
         </p:txBody>
@@ -1713,6 +1714,72 @@
           <a:p>
             <a:r>
               <a:t>FROM: the Four Connects deck (FotH, September 2025), 'Hearing God — What If?': how do you know something is from the Lord? It lines up with Scripture, reason, the witness of the Spirit, peace, community, circumstances.</a:t>
+            </a:r>
+          </a:p>
+        </p:txBody>
+      </p:sp>
+    </p:spTree>
+  </p:cSld>
+  <p:clrMapOvr>
+    <a:masterClrMapping/>
+  </p:clrMapOvr>
+</p:notes>
+</file>
+
+<file path=ppt/notesSlides/notesSlide18.xml><?xml version="1.0" encoding="utf-8"?>
+<p:notes xmlns:a="http://schemas.openxmlformats.org/drawingml/2006/main" xmlns:p="http://schemas.openxmlformats.org/presentationml/2006/main" xmlns:r="http://schemas.openxmlformats.org/officeDocument/2006/relationships">
+  <p:cSld>
+    <p:spTree>
+      <p:nvGrpSpPr>
+        <p:cNvPr id="1" name=""/>
+        <p:cNvGrpSpPr/>
+        <p:nvPr/>
+      </p:nvGrpSpPr>
+      <p:grpSpPr>
+        <a:xfrm>
+          <a:off x="0" y="0"/>
+          <a:ext cx="0" cy="0"/>
+          <a:chOff x="0" y="0"/>
+          <a:chExt cx="0" cy="0"/>
+        </a:xfrm>
+      </p:grpSpPr>
+      <p:sp>
+        <p:nvSpPr>
+          <p:cNvPr id="2" name="Notes Placeholder 1"/>
+          <p:cNvSpPr>
+            <a:spLocks noGrp="1"/>
+          </p:cNvSpPr>
+          <p:nvPr>
+            <p:ph type="body" idx="1"/>
+          </p:nvPr>
+        </p:nvSpPr>
+        <p:spPr/>
+        <p:txBody>
+          <a:bodyPr/>
+          <a:lstStyle/>
+          <a:p>
+            <a:r>
+              <a:t>S9 · 7:48–8:07 · LEAD: CONTENT PRESENTER</a:t>
+            </a:r>
+          </a:p>
+          <a:p>
+            <a:r>
+              <a:t>BEATS: 1. ROUND TWO — the reader reads Round Two of the Garden Reading Card: go back to the garden; Jesus is at the entrance; invite him in and give him permission to do or say anything he wishes; watch where he goes and what he does; listen for a word; then return — thank him, tell him you will be back, open your eyes. About 8 minutes with the pauses. 2. Write, 4 minutes: what did he do, where did he go, did he say anything? 'Nothing happened' is honest. 3. Share in pairs, 6 minutes, by invitation: the Companion models two plain sentences first, the arranged parent opens — receive without interpreting; never 'God was telling you...'. Notice, don't conclude: the returns are for testing.</a:t>
+            </a:r>
+          </a:p>
+          <a:p>
+            <a:r>
+              <a:t>CUES: Soft tears — do not stop; the tears are often the work. Never cold-call a teen; pass-anytime holds.</a:t>
+            </a:r>
+          </a:p>
+          <a:p>
+            <a:r>
+              <a:t>GUARD: If overwhelm goes past quiet reassurance, run the Settle Protocol — stop for THEM, not for the circle: plain directive words, back to the room, breathe and anchor, no return to the exercise today; nobody leaves activated.</a:t>
+            </a:r>
+          </a:p>
+          <a:p>
+            <a:r>
+              <a:t>FROM: the Four Connects deck (FotH, September 2025), 'Hearing God — The How': invite in Jesus, give him permission to do his thing; share with the group.</a:t>
             </a:r>
           </a:p>
         </p:txBody>
@@ -5004,7 +5071,7 @@
                 </a:solidFill>
                 <a:latin typeface="Cambria"/>
               </a:rPr>
-              <a:t>Merge and One-Word Landing</a:t>
+              <a:t>Bridge into the Exercise</a:t>
             </a:r>
           </a:p>
         </p:txBody>
@@ -5035,7 +5102,7 @@
               </a:spcAft>
             </a:pPr>
             <a:r>
-              <a:rPr sz="2800" b="1" i="0">
+              <a:rPr sz="2200" b="1" i="0">
                 <a:solidFill>
                   <a:srgbClr val="97BC62"/>
                 </a:solidFill>
@@ -5044,13 +5111,13 @@
               <a:t>•  </a:t>
             </a:r>
             <a:r>
-              <a:rPr sz="2800" b="0" i="0">
+              <a:rPr sz="2200" b="0" i="0">
                 <a:solidFill>
                   <a:srgbClr val="222B22"/>
                 </a:solidFill>
                 <a:latin typeface="Calibri"/>
               </a:rPr>
-              <a:t>“What happened in your pair stays in your pair.”</a:t>
+              <a:t>We stay right here, together, as one room — the garden in two rounds, read slowly</a:t>
             </a:r>
           </a:p>
           <a:p>
@@ -5060,7 +5127,7 @@
               </a:spcAft>
             </a:pPr>
             <a:r>
-              <a:rPr sz="2800" b="1" i="0">
+              <a:rPr sz="2200" b="1" i="0">
                 <a:solidFill>
                   <a:srgbClr val="97BC62"/>
                 </a:solidFill>
@@ -5069,38 +5136,38 @@
               <a:t>•  </a:t>
             </a:r>
             <a:r>
-              <a:rPr sz="2800" b="0" i="0">
+              <a:rPr sz="2200" b="0" i="0">
                 <a:solidFill>
                   <a:srgbClr val="222B22"/>
                 </a:solidFill>
                 <a:latin typeface="Calibri"/>
               </a:rPr>
-              <a:t>One word about tonight — not what was said, but what you noticed</a:t>
-            </a:r>
-          </a:p>
-          <a:p>
-            <a:pPr marL="685800" indent="-274320">
-              <a:spcAft>
-                <a:spcPts val="700"/>
-              </a:spcAft>
-            </a:pPr>
-            <a:r>
-              <a:rPr sz="2000" b="1" i="0">
+              <a:t>Round one: picture your heart as a garden — then write, then share</a:t>
+            </a:r>
+          </a:p>
+          <a:p>
+            <a:pPr marL="274320" indent="-274320">
+              <a:spcAft>
+                <a:spcPts val="900"/>
+              </a:spcAft>
+            </a:pPr>
+            <a:r>
+              <a:rPr sz="2200" b="1" i="0">
                 <a:solidFill>
                   <a:srgbClr val="97BC62"/>
                 </a:solidFill>
                 <a:latin typeface="Calibri"/>
               </a:rPr>
-              <a:t>–  </a:t>
-            </a:r>
-            <a:r>
-              <a:rPr sz="2000" b="0" i="1">
+              <a:t>•  </a:t>
+            </a:r>
+            <a:r>
+              <a:rPr sz="2200" b="0" i="0">
                 <a:solidFill>
                   <a:srgbClr val="222B22"/>
                 </a:solidFill>
                 <a:latin typeface="Calibri"/>
               </a:rPr>
-              <a:t>“Surprised.” “Tender.” “Empty.” “Found.” “Confused.” “Quiet.”</a:t>
+              <a:t>Round two: go back, invite Jesus in, and give him permission to do or say anything he wishes — then write, then share</a:t>
             </a:r>
           </a:p>
           <a:p>
@@ -5110,7 +5177,7 @@
               </a:spcAft>
             </a:pPr>
             <a:r>
-              <a:rPr sz="2800" b="1" i="0">
+              <a:rPr sz="2200" b="1" i="0">
                 <a:solidFill>
                   <a:srgbClr val="97BC62"/>
                 </a:solidFill>
@@ -5119,13 +5186,13 @@
               <a:t>•  </a:t>
             </a:r>
             <a:r>
-              <a:rPr sz="2800" b="0" i="0">
+              <a:rPr sz="2200" b="0" i="0">
                 <a:solidFill>
                   <a:srgbClr val="222B22"/>
                 </a:solidFill>
                 <a:latin typeface="Calibri"/>
               </a:rPr>
-              <a:t>A parent begins; anyone may pass — each word received without commentary</a:t>
+              <a:t>Eyes closed or open; your own family is beside you; sharing is by invitation — “Silence is a complete answer.”</a:t>
             </a:r>
           </a:p>
           <a:p>
@@ -5135,7 +5202,7 @@
               </a:spcAft>
             </a:pPr>
             <a:r>
-              <a:rPr sz="2800" b="1" i="0">
+              <a:rPr sz="2200" b="1" i="0">
                 <a:solidFill>
                   <a:srgbClr val="97BC62"/>
                 </a:solidFill>
@@ -5144,13 +5211,38 @@
               <a:t>•  </a:t>
             </a:r>
             <a:r>
-              <a:rPr sz="2800" b="0" i="0">
+              <a:rPr sz="2200" b="0" i="0">
                 <a:solidFill>
                   <a:srgbClr val="222B22"/>
                 </a:solidFill>
                 <a:latin typeface="Calibri"/>
               </a:rPr>
-              <a:t>“Whatever happened tonight is yours. Some of it will keep happening across the week.”</a:t>
+              <a:t>Notice, don’t conclude — what you notice tonight, you hold loosely and test on your returns</a:t>
+            </a:r>
+          </a:p>
+          <a:p>
+            <a:pPr marL="274320" indent="-274320">
+              <a:spcAft>
+                <a:spcPts val="900"/>
+              </a:spcAft>
+            </a:pPr>
+            <a:r>
+              <a:rPr sz="2200" b="1" i="0">
+                <a:solidFill>
+                  <a:srgbClr val="97BC62"/>
+                </a:solidFill>
+                <a:latin typeface="Calibri"/>
+              </a:rPr>
+              <a:t>•  </a:t>
+            </a:r>
+            <a:r>
+              <a:rPr sz="2200" b="0" i="0">
+                <a:solidFill>
+                  <a:srgbClr val="222B22"/>
+                </a:solidFill>
+                <a:latin typeface="Calibri"/>
+              </a:rPr>
+              <a:t>“Father, you are the vinedresser. … Where it is hard, be tender. Where it is closed, be patient. Where it is opening, be present.”</a:t>
             </a:r>
           </a:p>
         </p:txBody>
@@ -5177,7 +5269,7 @@
           <a:p>
             <a:pPr algn="r"/>
             <a:r>
-              <a:t>G12</a:t>
+              <a:t>G10</a:t>
             </a:r>
             <a:endParaRPr sz="1000" b="1">
               <a:solidFill>
@@ -5276,6 +5368,575 @@
                 </a:solidFill>
                 <a:latin typeface="Cambria"/>
               </a:rPr>
+              <a:t>The Garden — Round One: Your Heart as a Garden</a:t>
+            </a:r>
+          </a:p>
+        </p:txBody>
+      </p:sp>
+      <p:sp>
+        <p:nvSpPr>
+          <p:cNvPr id="4" name="TextBox 4"/>
+          <p:cNvSpPr txBox="1"/>
+          <p:nvPr/>
+        </p:nvSpPr>
+        <p:spPr>
+          <a:xfrm>
+            <a:off x="822960" y="1554480"/>
+            <a:ext cx="10515600" cy="4892040"/>
+          </a:xfrm>
+          <a:prstGeom prst="rect">
+            <a:avLst/>
+          </a:prstGeom>
+          <a:noFill/>
+        </p:spPr>
+        <p:txBody>
+          <a:bodyPr wrap="square" lIns="91440" tIns="91440" rIns="91440" bIns="91440"/>
+          <a:lstStyle/>
+          <a:p>
+            <a:pPr marL="342900" indent="-342900">
+              <a:spcAft>
+                <a:spcPts val="750"/>
+              </a:spcAft>
+            </a:pPr>
+            <a:r>
+              <a:rPr sz="2000" b="1" i="0">
+                <a:solidFill>
+                  <a:srgbClr val="97BC62"/>
+                </a:solidFill>
+                <a:latin typeface="Calibri"/>
+              </a:rPr>
+              <a:t>1   </a:t>
+            </a:r>
+            <a:r>
+              <a:rPr sz="2000" b="0" i="0">
+                <a:solidFill>
+                  <a:srgbClr val="222B22"/>
+                </a:solidFill>
+                <a:latin typeface="Calibri"/>
+              </a:rPr>
+              <a:t>Settle (1 min) — “Take a breath. Eyes open or closed. Whatever feels honest. We have time.”</a:t>
+            </a:r>
+          </a:p>
+          <a:p>
+            <a:pPr marL="342900" indent="-342900">
+              <a:spcAft>
+                <a:spcPts val="750"/>
+              </a:spcAft>
+            </a:pPr>
+            <a:r>
+              <a:rPr sz="2000" b="1" i="0">
+                <a:solidFill>
+                  <a:srgbClr val="97BC62"/>
+                </a:solidFill>
+                <a:latin typeface="Calibri"/>
+              </a:rPr>
+              <a:t>2   </a:t>
+            </a:r>
+            <a:r>
+              <a:rPr sz="2000" b="0" i="0">
+                <a:solidFill>
+                  <a:srgbClr val="222B22"/>
+                </a:solidFill>
+                <a:latin typeface="Calibri"/>
+              </a:rPr>
+              <a:t>Imagine (5 min) — picture your heart as a garden and walk in: what is growing, the weather, the light, the season; what feels alive, what feels closed</a:t>
+            </a:r>
+          </a:p>
+          <a:p>
+            <a:pPr marL="342900" indent="-342900">
+              <a:spcAft>
+                <a:spcPts val="750"/>
+              </a:spcAft>
+            </a:pPr>
+            <a:r>
+              <a:rPr sz="2000" b="1" i="0">
+                <a:solidFill>
+                  <a:srgbClr val="97BC62"/>
+                </a:solidFill>
+                <a:latin typeface="Calibri"/>
+              </a:rPr>
+              <a:t>3   </a:t>
+            </a:r>
+            <a:r>
+              <a:rPr sz="2000" b="0" i="0">
+                <a:solidFill>
+                  <a:srgbClr val="222B22"/>
+                </a:solidFill>
+                <a:latin typeface="Calibri"/>
+              </a:rPr>
+              <a:t>Write (3 min) — what does your garden look like?</a:t>
+            </a:r>
+          </a:p>
+          <a:p>
+            <a:pPr marL="342900" indent="-342900">
+              <a:spcAft>
+                <a:spcPts val="750"/>
+              </a:spcAft>
+            </a:pPr>
+            <a:r>
+              <a:rPr sz="2000" b="1" i="0">
+                <a:solidFill>
+                  <a:srgbClr val="97BC62"/>
+                </a:solidFill>
+                <a:latin typeface="Calibri"/>
+              </a:rPr>
+              <a:t>4   </a:t>
+            </a:r>
+            <a:r>
+              <a:rPr sz="2000" b="0" i="0">
+                <a:solidFill>
+                  <a:srgbClr val="222B22"/>
+                </a:solidFill>
+                <a:latin typeface="Calibri"/>
+              </a:rPr>
+              <a:t>Share in pairs (4 min) — by invitation only; a parent opens; silence is a complete answer</a:t>
+            </a:r>
+          </a:p>
+          <a:p>
+            <a:pPr marL="342900" indent="-342900">
+              <a:spcAft>
+                <a:spcPts val="750"/>
+              </a:spcAft>
+            </a:pPr>
+            <a:r>
+              <a:rPr sz="2000" b="1" i="0">
+                <a:solidFill>
+                  <a:srgbClr val="97BC62"/>
+                </a:solidFill>
+                <a:latin typeface="Calibri"/>
+              </a:rPr>
+              <a:t>•  </a:t>
+            </a:r>
+            <a:r>
+              <a:rPr sz="2000" b="0" i="0">
+                <a:solidFill>
+                  <a:srgbClr val="222B22"/>
+                </a:solidFill>
+                <a:latin typeface="Calibri"/>
+              </a:rPr>
+              <a:t>Receive without interpreting — “Thank you for sharing that.”</a:t>
+            </a:r>
+          </a:p>
+          <a:p>
+            <a:pPr marL="342900" indent="-342900">
+              <a:spcAft>
+                <a:spcPts val="750"/>
+              </a:spcAft>
+            </a:pPr>
+            <a:r>
+              <a:rPr sz="2000" b="1" i="0">
+                <a:solidFill>
+                  <a:srgbClr val="97BC62"/>
+                </a:solidFill>
+                <a:latin typeface="Calibri"/>
+              </a:rPr>
+              <a:t>•  </a:t>
+            </a:r>
+            <a:r>
+              <a:rPr sz="2000" b="0" i="0">
+                <a:solidFill>
+                  <a:srgbClr val="222B22"/>
+                </a:solidFill>
+                <a:latin typeface="Calibri"/>
+              </a:rPr>
+              <a:t>Jesus is not invited yet — this round is only the garden</a:t>
+            </a:r>
+          </a:p>
+        </p:txBody>
+      </p:sp>
+      <p:sp>
+        <p:nvSpPr>
+          <p:cNvPr id="90" name="SlideNum"/>
+          <p:cNvSpPr txBox="1"/>
+          <p:nvPr/>
+        </p:nvSpPr>
+        <p:spPr>
+          <a:xfrm>
+            <a:off x="11384280" y="6446520"/>
+            <a:ext cx="640080" cy="292608"/>
+          </a:xfrm>
+          <a:prstGeom prst="rect">
+            <a:avLst/>
+          </a:prstGeom>
+          <a:noFill/>
+        </p:spPr>
+        <p:txBody>
+          <a:bodyPr wrap="none" lIns="0" tIns="0" rIns="45720" bIns="0" anchor="ctr"/>
+          <a:lstStyle/>
+          <a:p>
+            <a:pPr algn="r"/>
+            <a:r>
+              <a:t>G11</a:t>
+            </a:r>
+            <a:endParaRPr sz="1000" b="1">
+              <a:solidFill>
+                <a:srgbClr val="7A8A6E"/>
+              </a:solidFill>
+              <a:latin typeface="Calibri"/>
+            </a:endParaRPr>
+          </a:p>
+        </p:txBody>
+      </p:sp>
+    </p:spTree>
+  </p:cSld>
+  <p:clrMapOvr>
+    <a:masterClrMapping/>
+  </p:clrMapOvr>
+</p:sld>
+</file>
+
+<file path=ppt/slides/slide12.xml><?xml version="1.0" encoding="utf-8"?>
+<p:sld xmlns:a="http://schemas.openxmlformats.org/drawingml/2006/main" xmlns:r="http://schemas.openxmlformats.org/officeDocument/2006/relationships" xmlns:p="http://schemas.openxmlformats.org/presentationml/2006/main">
+  <p:cSld>
+    <p:spTree>
+      <p:nvGrpSpPr>
+        <p:cNvPr id="1" name=""/>
+        <p:cNvGrpSpPr/>
+        <p:nvPr/>
+      </p:nvGrpSpPr>
+      <p:grpSpPr>
+        <a:xfrm>
+          <a:off x="0" y="0"/>
+          <a:ext cx="0" cy="0"/>
+          <a:chOff x="0" y="0"/>
+          <a:chExt cx="0" cy="0"/>
+        </a:xfrm>
+      </p:grpSpPr>
+      <p:sp>
+        <p:nvSpPr>
+          <p:cNvPr id="2" name="Rectangle 1"/>
+          <p:cNvSpPr/>
+          <p:nvPr/>
+        </p:nvSpPr>
+        <p:spPr>
+          <a:xfrm>
+            <a:off x="0" y="0"/>
+            <a:ext cx="12191695" cy="6858000"/>
+          </a:xfrm>
+          <a:prstGeom prst="rect">
+            <a:avLst/>
+          </a:prstGeom>
+          <a:solidFill>
+            <a:srgbClr val="FFFFFF"/>
+          </a:solidFill>
+          <a:ln>
+            <a:noFill/>
+          </a:ln>
+        </p:spPr>
+        <p:txBody>
+          <a:bodyPr/>
+          <a:lstStyle/>
+          <a:p>
+            <a:endParaRPr/>
+          </a:p>
+        </p:txBody>
+      </p:sp>
+      <p:sp>
+        <p:nvSpPr>
+          <p:cNvPr id="3" name="TextBox 2"/>
+          <p:cNvSpPr txBox="1"/>
+          <p:nvPr/>
+        </p:nvSpPr>
+        <p:spPr>
+          <a:xfrm>
+            <a:off x="822960" y="502920"/>
+            <a:ext cx="10515600" cy="822960"/>
+          </a:xfrm>
+          <a:prstGeom prst="rect">
+            <a:avLst/>
+          </a:prstGeom>
+          <a:noFill/>
+        </p:spPr>
+        <p:txBody>
+          <a:bodyPr wrap="square">
+            <a:spAutoFit/>
+          </a:bodyPr>
+          <a:lstStyle/>
+          <a:p>
+            <a:pPr algn="l">
+              <a:spcAft>
+                <a:spcPts val="600"/>
+              </a:spcAft>
+            </a:pPr>
+            <a:r>
+              <a:rPr sz="2800" b="1" i="0">
+                <a:solidFill>
+                  <a:srgbClr val="2C5F2D"/>
+                </a:solidFill>
+                <a:latin typeface="Cambria"/>
+              </a:rPr>
+              <a:t>Merge and One-Word Landing</a:t>
+            </a:r>
+          </a:p>
+        </p:txBody>
+      </p:sp>
+      <p:sp>
+        <p:nvSpPr>
+          <p:cNvPr id="4" name="TextBox 4"/>
+          <p:cNvSpPr txBox="1"/>
+          <p:nvPr/>
+        </p:nvSpPr>
+        <p:spPr>
+          <a:xfrm>
+            <a:off x="822960" y="1554480"/>
+            <a:ext cx="10515600" cy="4892040"/>
+          </a:xfrm>
+          <a:prstGeom prst="rect">
+            <a:avLst/>
+          </a:prstGeom>
+          <a:noFill/>
+        </p:spPr>
+        <p:txBody>
+          <a:bodyPr wrap="square" lIns="91440" tIns="91440" rIns="91440" bIns="91440"/>
+          <a:lstStyle/>
+          <a:p>
+            <a:pPr marL="274320" indent="-274320">
+              <a:spcAft>
+                <a:spcPts val="900"/>
+              </a:spcAft>
+            </a:pPr>
+            <a:r>
+              <a:rPr sz="2800" b="1" i="0">
+                <a:solidFill>
+                  <a:srgbClr val="97BC62"/>
+                </a:solidFill>
+                <a:latin typeface="Calibri"/>
+              </a:rPr>
+              <a:t>•  </a:t>
+            </a:r>
+            <a:r>
+              <a:rPr sz="2800" b="0" i="0">
+                <a:solidFill>
+                  <a:srgbClr val="222B22"/>
+                </a:solidFill>
+                <a:latin typeface="Calibri"/>
+              </a:rPr>
+              <a:t>“What happened in your pair stays in your pair.”</a:t>
+            </a:r>
+          </a:p>
+          <a:p>
+            <a:pPr marL="274320" indent="-274320">
+              <a:spcAft>
+                <a:spcPts val="900"/>
+              </a:spcAft>
+            </a:pPr>
+            <a:r>
+              <a:rPr sz="2800" b="1" i="0">
+                <a:solidFill>
+                  <a:srgbClr val="97BC62"/>
+                </a:solidFill>
+                <a:latin typeface="Calibri"/>
+              </a:rPr>
+              <a:t>•  </a:t>
+            </a:r>
+            <a:r>
+              <a:rPr sz="2800" b="0" i="0">
+                <a:solidFill>
+                  <a:srgbClr val="222B22"/>
+                </a:solidFill>
+                <a:latin typeface="Calibri"/>
+              </a:rPr>
+              <a:t>One word about tonight — not what was said, but what you noticed</a:t>
+            </a:r>
+          </a:p>
+          <a:p>
+            <a:pPr marL="685800" indent="-274320">
+              <a:spcAft>
+                <a:spcPts val="700"/>
+              </a:spcAft>
+            </a:pPr>
+            <a:r>
+              <a:rPr sz="2000" b="1" i="0">
+                <a:solidFill>
+                  <a:srgbClr val="97BC62"/>
+                </a:solidFill>
+                <a:latin typeface="Calibri"/>
+              </a:rPr>
+              <a:t>–  </a:t>
+            </a:r>
+            <a:r>
+              <a:rPr sz="2000" b="0" i="1">
+                <a:solidFill>
+                  <a:srgbClr val="222B22"/>
+                </a:solidFill>
+                <a:latin typeface="Calibri"/>
+              </a:rPr>
+              <a:t>“Surprised.” “Tender.” “Empty.” “Found.” “Confused.” “Quiet.”</a:t>
+            </a:r>
+          </a:p>
+          <a:p>
+            <a:pPr marL="274320" indent="-274320">
+              <a:spcAft>
+                <a:spcPts val="900"/>
+              </a:spcAft>
+            </a:pPr>
+            <a:r>
+              <a:rPr sz="2800" b="1" i="0">
+                <a:solidFill>
+                  <a:srgbClr val="97BC62"/>
+                </a:solidFill>
+                <a:latin typeface="Calibri"/>
+              </a:rPr>
+              <a:t>•  </a:t>
+            </a:r>
+            <a:r>
+              <a:rPr sz="2800" b="0" i="0">
+                <a:solidFill>
+                  <a:srgbClr val="222B22"/>
+                </a:solidFill>
+                <a:latin typeface="Calibri"/>
+              </a:rPr>
+              <a:t>A parent begins; anyone may pass — each word received without commentary</a:t>
+            </a:r>
+          </a:p>
+          <a:p>
+            <a:pPr marL="274320" indent="-274320">
+              <a:spcAft>
+                <a:spcPts val="900"/>
+              </a:spcAft>
+            </a:pPr>
+            <a:r>
+              <a:rPr sz="2800" b="1" i="0">
+                <a:solidFill>
+                  <a:srgbClr val="97BC62"/>
+                </a:solidFill>
+                <a:latin typeface="Calibri"/>
+              </a:rPr>
+              <a:t>•  </a:t>
+            </a:r>
+            <a:r>
+              <a:rPr sz="2800" b="0" i="0">
+                <a:solidFill>
+                  <a:srgbClr val="222B22"/>
+                </a:solidFill>
+                <a:latin typeface="Calibri"/>
+              </a:rPr>
+              <a:t>“Whatever happened tonight is yours. Some of it will keep happening across the week.”</a:t>
+            </a:r>
+          </a:p>
+        </p:txBody>
+      </p:sp>
+      <p:sp>
+        <p:nvSpPr>
+          <p:cNvPr id="90" name="SlideNum"/>
+          <p:cNvSpPr txBox="1"/>
+          <p:nvPr/>
+        </p:nvSpPr>
+        <p:spPr>
+          <a:xfrm>
+            <a:off x="11384280" y="6446520"/>
+            <a:ext cx="640080" cy="292608"/>
+          </a:xfrm>
+          <a:prstGeom prst="rect">
+            <a:avLst/>
+          </a:prstGeom>
+          <a:noFill/>
+        </p:spPr>
+        <p:txBody>
+          <a:bodyPr wrap="none" lIns="0" tIns="0" rIns="45720" bIns="0" anchor="ctr"/>
+          <a:lstStyle/>
+          <a:p>
+            <a:pPr algn="r"/>
+            <a:r>
+              <a:t>G13</a:t>
+            </a:r>
+            <a:endParaRPr sz="1000" b="1">
+              <a:solidFill>
+                <a:srgbClr val="7A8A6E"/>
+              </a:solidFill>
+              <a:latin typeface="Calibri"/>
+            </a:endParaRPr>
+          </a:p>
+        </p:txBody>
+      </p:sp>
+    </p:spTree>
+  </p:cSld>
+  <p:clrMapOvr>
+    <a:masterClrMapping/>
+  </p:clrMapOvr>
+</p:sld>
+</file>
+
+<file path=ppt/slides/slide13.xml><?xml version="1.0" encoding="utf-8"?>
+<p:sld xmlns:a="http://schemas.openxmlformats.org/drawingml/2006/main" xmlns:r="http://schemas.openxmlformats.org/officeDocument/2006/relationships" xmlns:p="http://schemas.openxmlformats.org/presentationml/2006/main">
+  <p:cSld>
+    <p:spTree>
+      <p:nvGrpSpPr>
+        <p:cNvPr id="1" name=""/>
+        <p:cNvGrpSpPr/>
+        <p:nvPr/>
+      </p:nvGrpSpPr>
+      <p:grpSpPr>
+        <a:xfrm>
+          <a:off x="0" y="0"/>
+          <a:ext cx="0" cy="0"/>
+          <a:chOff x="0" y="0"/>
+          <a:chExt cx="0" cy="0"/>
+        </a:xfrm>
+      </p:grpSpPr>
+      <p:sp>
+        <p:nvSpPr>
+          <p:cNvPr id="2" name="Rectangle 1"/>
+          <p:cNvSpPr/>
+          <p:nvPr/>
+        </p:nvSpPr>
+        <p:spPr>
+          <a:xfrm>
+            <a:off x="0" y="0"/>
+            <a:ext cx="12191695" cy="6858000"/>
+          </a:xfrm>
+          <a:prstGeom prst="rect">
+            <a:avLst/>
+          </a:prstGeom>
+          <a:solidFill>
+            <a:srgbClr val="FFFFFF"/>
+          </a:solidFill>
+          <a:ln>
+            <a:noFill/>
+          </a:ln>
+        </p:spPr>
+        <p:txBody>
+          <a:bodyPr/>
+          <a:lstStyle/>
+          <a:p>
+            <a:endParaRPr/>
+          </a:p>
+        </p:txBody>
+      </p:sp>
+      <p:sp>
+        <p:nvSpPr>
+          <p:cNvPr id="3" name="TextBox 2"/>
+          <p:cNvSpPr txBox="1"/>
+          <p:nvPr/>
+        </p:nvSpPr>
+        <p:spPr>
+          <a:xfrm>
+            <a:off x="822960" y="502920"/>
+            <a:ext cx="10515600" cy="822960"/>
+          </a:xfrm>
+          <a:prstGeom prst="rect">
+            <a:avLst/>
+          </a:prstGeom>
+          <a:noFill/>
+        </p:spPr>
+        <p:txBody>
+          <a:bodyPr wrap="square">
+            <a:spAutoFit/>
+          </a:bodyPr>
+          <a:lstStyle/>
+          <a:p>
+            <a:pPr algn="l">
+              <a:spcAft>
+                <a:spcPts val="600"/>
+              </a:spcAft>
+            </a:pPr>
+            <a:r>
+              <a:rPr sz="2800" b="1" i="0">
+                <a:solidFill>
+                  <a:srgbClr val="2C5F2D"/>
+                </a:solidFill>
+                <a:latin typeface="Cambria"/>
+              </a:rPr>
               <a:t>Homework — Two Weeks, Four Parts</a:t>
             </a:r>
           </a:p>
@@ -5499,7 +6160,7 @@
           <a:p>
             <a:pPr algn="r"/>
             <a:r>
-              <a:t>G13</a:t>
+              <a:t>G14</a:t>
             </a:r>
             <a:endParaRPr sz="1000" b="1">
               <a:solidFill>
@@ -5554,7 +6215,7 @@
 </p:sld>
 </file>
 
-<file path=ppt/slides/slide12.xml><?xml version="1.0" encoding="utf-8"?>
+<file path=ppt/slides/slide14.xml><?xml version="1.0" encoding="utf-8"?>
 <p:sld xmlns:a="http://schemas.openxmlformats.org/drawingml/2006/main" xmlns:p="http://schemas.openxmlformats.org/presentationml/2006/main" xmlns:r="http://schemas.openxmlformats.org/officeDocument/2006/relationships">
   <p:cSld>
     <p:spTree>
@@ -5727,7 +6388,7 @@
           <a:p>
             <a:pPr algn="r"/>
             <a:r>
-              <a:t>G14</a:t>
+              <a:t>G15</a:t>
             </a:r>
             <a:endParaRPr sz="1000" b="1">
               <a:solidFill>
@@ -5746,7 +6407,7 @@
 </p:sld>
 </file>
 
-<file path=ppt/slides/slide13.xml><?xml version="1.0" encoding="utf-8"?>
+<file path=ppt/slides/slide15.xml><?xml version="1.0" encoding="utf-8"?>
 <p:sld xmlns:a="http://schemas.openxmlformats.org/drawingml/2006/main" xmlns:p="http://schemas.openxmlformats.org/presentationml/2006/main" xmlns:r="http://schemas.openxmlformats.org/officeDocument/2006/relationships">
   <p:cSld>
     <p:spTree>
@@ -5919,7 +6580,7 @@
           <a:p>
             <a:pPr algn="r"/>
             <a:r>
-              <a:t>G15</a:t>
+              <a:t>G16</a:t>
             </a:r>
             <a:endParaRPr sz="1000" b="1">
               <a:solidFill>
@@ -5938,7 +6599,7 @@
 </p:sld>
 </file>
 
-<file path=ppt/slides/slide14.xml><?xml version="1.0" encoding="utf-8"?>
+<file path=ppt/slides/slide16.xml><?xml version="1.0" encoding="utf-8"?>
 <p:sld xmlns:a="http://schemas.openxmlformats.org/drawingml/2006/main" xmlns:r="http://schemas.openxmlformats.org/officeDocument/2006/relationships" xmlns:p="http://schemas.openxmlformats.org/presentationml/2006/main">
   <p:cSld>
     <p:spTree>
@@ -6216,7 +6877,7 @@
           <a:p>
             <a:pPr algn="r"/>
             <a:r>
-              <a:t>G16</a:t>
+              <a:t>G17</a:t>
             </a:r>
             <a:endParaRPr sz="1000" b="1">
               <a:solidFill>
@@ -6271,7 +6932,7 @@
 </p:sld>
 </file>
 
-<file path=ppt/slides/slide15.xml><?xml version="1.0" encoding="utf-8"?>
+<file path=ppt/slides/slide17.xml><?xml version="1.0" encoding="utf-8"?>
 <p:sld xmlns:a="http://schemas.openxmlformats.org/drawingml/2006/main" xmlns:r="http://schemas.openxmlformats.org/officeDocument/2006/relationships" xmlns:p="http://schemas.openxmlformats.org/presentationml/2006/main">
   <p:cSld>
     <p:spTree>
@@ -6661,7 +7322,7 @@
           <a:p>
             <a:pPr algn="r"/>
             <a:r>
-              <a:t>G17</a:t>
+              <a:t>G18</a:t>
             </a:r>
             <a:endParaRPr sz="1000" b="1">
               <a:solidFill>
@@ -6680,7 +7341,7 @@
 </p:sld>
 </file>
 
-<file path=ppt/slides/slide16.xml><?xml version="1.0" encoding="utf-8"?>
+<file path=ppt/slides/slide18.xml><?xml version="1.0" encoding="utf-8"?>
 <p:sld xmlns:a="http://schemas.openxmlformats.org/drawingml/2006/main" xmlns:p="http://schemas.openxmlformats.org/presentationml/2006/main" xmlns:r="http://schemas.openxmlformats.org/officeDocument/2006/relationships">
   <p:cSld>
     <p:spTree>
@@ -6753,7 +7414,7 @@
                 </a:solidFill>
                 <a:latin typeface="Cambria"/>
               </a:rPr>
-              <a:t>When Have You Really Heard?</a:t>
+              <a:t>The Garden — Round Two: Invite Jesus In</a:t>
             </a:r>
           </a:p>
         </p:txBody>
@@ -6766,8 +7427,8 @@
         </p:nvSpPr>
         <p:spPr>
           <a:xfrm>
-            <a:off x="822960" y="1600200"/>
-            <a:ext cx="5669280" cy="4572000"/>
+            <a:off x="822960" y="1554480"/>
+            <a:ext cx="10515600" cy="4892040"/>
           </a:xfrm>
           <a:prstGeom prst="rect">
             <a:avLst/>
@@ -6778,38 +7439,163 @@
           <a:bodyPr wrap="square" lIns="91440" tIns="91440" rIns="91440" bIns="91440"/>
           <a:lstStyle/>
           <a:p>
-            <a:pPr marL="274320" indent="-274320">
-              <a:spcAft>
-                <a:spcPts val="650"/>
-              </a:spcAft>
-            </a:pPr>
-            <a:r>
-              <a:rPr sz="1800" b="1" i="0">
+            <a:pPr marL="342900" indent="-342900">
+              <a:spcAft>
+                <a:spcPts val="750"/>
+              </a:spcAft>
+            </a:pPr>
+            <a:r>
+              <a:rPr sz="2000" b="1" i="0">
                 <a:solidFill>
                   <a:srgbClr val="97BC62"/>
                 </a:solidFill>
                 <a:latin typeface="Calibri"/>
               </a:rPr>
+              <a:t>1   </a:t>
+            </a:r>
+            <a:r>
+              <a:rPr sz="2000" b="0" i="0">
+                <a:solidFill>
+                  <a:srgbClr val="222B22"/>
+                </a:solidFill>
+                <a:latin typeface="Calibri"/>
+              </a:rPr>
+              <a:t>Go back to your garden — you know the way now</a:t>
+            </a:r>
+          </a:p>
+          <a:p>
+            <a:pPr marL="342900" indent="-342900">
+              <a:spcAft>
+                <a:spcPts val="750"/>
+              </a:spcAft>
+            </a:pPr>
+            <a:r>
+              <a:rPr sz="2000" b="1" i="0">
+                <a:solidFill>
+                  <a:srgbClr val="97BC62"/>
+                </a:solidFill>
+                <a:latin typeface="Calibri"/>
+              </a:rPr>
+              <a:t>2   </a:t>
+            </a:r>
+            <a:r>
+              <a:rPr sz="2000" b="0" i="0">
+                <a:solidFill>
+                  <a:srgbClr val="222B22"/>
+                </a:solidFill>
+                <a:latin typeface="Calibri"/>
+              </a:rPr>
+              <a:t>Invite Jesus in (8 min) — give him permission to do or say anything he wishes; then watch, and listen</a:t>
+            </a:r>
+          </a:p>
+          <a:p>
+            <a:pPr marL="342900" indent="-342900">
+              <a:spcAft>
+                <a:spcPts val="750"/>
+              </a:spcAft>
+            </a:pPr>
+            <a:r>
+              <a:rPr sz="2000" b="1" i="0">
+                <a:solidFill>
+                  <a:srgbClr val="97BC62"/>
+                </a:solidFill>
+                <a:latin typeface="Calibri"/>
+              </a:rPr>
+              <a:t>3   </a:t>
+            </a:r>
+            <a:r>
+              <a:rPr sz="2000" b="0" i="0">
+                <a:solidFill>
+                  <a:srgbClr val="222B22"/>
+                </a:solidFill>
+                <a:latin typeface="Calibri"/>
+              </a:rPr>
+              <a:t>Return — thank him, tell him you will be back, open your eyes</a:t>
+            </a:r>
+          </a:p>
+          <a:p>
+            <a:pPr marL="342900" indent="-342900">
+              <a:spcAft>
+                <a:spcPts val="750"/>
+              </a:spcAft>
+            </a:pPr>
+            <a:r>
+              <a:rPr sz="2000" b="1" i="0">
+                <a:solidFill>
+                  <a:srgbClr val="97BC62"/>
+                </a:solidFill>
+                <a:latin typeface="Calibri"/>
+              </a:rPr>
+              <a:t>4   </a:t>
+            </a:r>
+            <a:r>
+              <a:rPr sz="2000" b="0" i="0">
+                <a:solidFill>
+                  <a:srgbClr val="222B22"/>
+                </a:solidFill>
+                <a:latin typeface="Calibri"/>
+              </a:rPr>
+              <a:t>Write (4 min) — what did he do? Where did he go? Did he say anything? “Nothing happened” is honest</a:t>
+            </a:r>
+          </a:p>
+          <a:p>
+            <a:pPr marL="342900" indent="-342900">
+              <a:spcAft>
+                <a:spcPts val="750"/>
+              </a:spcAft>
+            </a:pPr>
+            <a:r>
+              <a:rPr sz="2000" b="1" i="0">
+                <a:solidFill>
+                  <a:srgbClr val="97BC62"/>
+                </a:solidFill>
+                <a:latin typeface="Calibri"/>
+              </a:rPr>
+              <a:t>5   </a:t>
+            </a:r>
+            <a:r>
+              <a:rPr sz="2000" b="0" i="0">
+                <a:solidFill>
+                  <a:srgbClr val="222B22"/>
+                </a:solidFill>
+                <a:latin typeface="Calibri"/>
+              </a:rPr>
+              <a:t>Share in pairs (6 min) — by invitation only; a parent opens; silence is a complete answer</a:t>
+            </a:r>
+          </a:p>
+          <a:p>
+            <a:pPr marL="342900" indent="-342900">
+              <a:spcAft>
+                <a:spcPts val="750"/>
+              </a:spcAft>
+            </a:pPr>
+            <a:r>
+              <a:rPr sz="2000" b="1" i="0">
+                <a:solidFill>
+                  <a:srgbClr val="97BC62"/>
+                </a:solidFill>
+                <a:latin typeface="Calibri"/>
+              </a:rPr>
               <a:t>•  </a:t>
             </a:r>
             <a:r>
-              <a:rPr sz="1800" b="0" i="0">
+              <a:rPr sz="2000" b="0" i="0">
                 <a:solidFill>
                   <a:srgbClr val="222B22"/>
                 </a:solidFill>
                 <a:latin typeface="Calibri"/>
               </a:rPr>
-              <a:t>Remember one time you really heard God — a verse that jumped off the page, a nudge, a word through someone, a quiet knowing</a:t>
-            </a:r>
-          </a:p>
-          <a:p>
-            <a:pPr marL="274320" indent="-274320">
-              <a:spcAft>
-                <a:spcPts val="650"/>
-              </a:spcAft>
-            </a:pPr>
-            <a:r>
-              <a:rPr sz="1800" b="1" i="0">
+              <a:t>Never “God was telling you _____.” Notice, don’t conclude — the returns are for testing</a:t>
+            </a:r>
+          </a:p>
+          <a:p>
+            <a:pPr marL="342900" indent="-342900">
+              <a:spcAft>
+                <a:spcPts val="750"/>
+              </a:spcAft>
+            </a:pPr>
+            <a:r>
+              <a:rPr sz="2000" b="1" i="0">
                 <a:solidFill>
                   <a:srgbClr val="97BC62"/>
                 </a:solidFill>
@@ -6818,168 +7604,13 @@
               <a:t>•  </a:t>
             </a:r>
             <a:r>
-              <a:rPr sz="1800" b="0" i="0">
+              <a:rPr sz="2000" b="0" i="0">
                 <a:solidFill>
                   <a:srgbClr val="222B22"/>
                 </a:solidFill>
                 <a:latin typeface="Calibri"/>
               </a:rPr>
-              <a:t>Where were you, and what was going on? Reading, worship, a conversation, outdoors, a hard day</a:t>
-            </a:r>
-          </a:p>
-          <a:p>
-            <a:pPr marL="274320" indent="-274320">
-              <a:spcAft>
-                <a:spcPts val="650"/>
-              </a:spcAft>
-            </a:pPr>
-            <a:r>
-              <a:rPr sz="1800" b="1" i="0">
-                <a:solidFill>
-                  <a:srgbClr val="97BC62"/>
-                </a:solidFill>
-                <a:latin typeface="Calibri"/>
-              </a:rPr>
-              <a:t>•  </a:t>
-            </a:r>
-            <a:r>
-              <a:rPr sz="1800" b="0" i="0">
-                <a:solidFill>
-                  <a:srgbClr val="222B22"/>
-                </a:solidFill>
-                <a:latin typeface="Calibri"/>
-              </a:rPr>
-              <a:t>What did it look like, sound like, feel like? Write it down — make it fuller</a:t>
-            </a:r>
-          </a:p>
-          <a:p>
-            <a:pPr marL="274320" indent="-274320">
-              <a:spcAft>
-                <a:spcPts val="650"/>
-              </a:spcAft>
-            </a:pPr>
-            <a:r>
-              <a:rPr sz="1800" b="1" i="0">
-                <a:solidFill>
-                  <a:srgbClr val="97BC62"/>
-                </a:solidFill>
-                <a:latin typeface="Calibri"/>
-              </a:rPr>
-              <a:t>•  </a:t>
-            </a:r>
-            <a:r>
-              <a:rPr sz="1800" b="0" i="0">
-                <a:solidFill>
-                  <a:srgbClr val="222B22"/>
-                </a:solidFill>
-                <a:latin typeface="Calibri"/>
-              </a:rPr>
-              <a:t>What did you do with it — and what happened?</a:t>
-            </a:r>
-          </a:p>
-          <a:p>
-            <a:pPr marL="274320" indent="-274320">
-              <a:spcAft>
-                <a:spcPts val="650"/>
-              </a:spcAft>
-            </a:pPr>
-            <a:r>
-              <a:rPr sz="1800" b="1" i="0">
-                <a:solidFill>
-                  <a:srgbClr val="97BC62"/>
-                </a:solidFill>
-                <a:latin typeface="Calibri"/>
-              </a:rPr>
-              <a:t>•  </a:t>
-            </a:r>
-            <a:r>
-              <a:rPr sz="1800" b="0" i="0">
-                <a:solidFill>
-                  <a:srgbClr val="222B22"/>
-                </a:solidFill>
-                <a:latin typeface="Calibri"/>
-              </a:rPr>
-              <a:t>Can’t think of one? A time creation stopped you in your tracks counts — God speaks through what he has made (Rom. 1:20)</a:t>
-            </a:r>
-          </a:p>
-          <a:p>
-            <a:pPr marL="274320" indent="-274320">
-              <a:spcAft>
-                <a:spcPts val="650"/>
-              </a:spcAft>
-            </a:pPr>
-            <a:r>
-              <a:rPr sz="1800" b="1" i="0">
-                <a:solidFill>
-                  <a:srgbClr val="97BC62"/>
-                </a:solidFill>
-                <a:latin typeface="Calibri"/>
-              </a:rPr>
-              <a:t>•  </a:t>
-            </a:r>
-            <a:r>
-              <a:rPr sz="1800" b="0" i="0">
-                <a:solidFill>
-                  <a:srgbClr val="222B22"/>
-                </a:solidFill>
-                <a:latin typeface="Calibri"/>
-              </a:rPr>
-              <a:t>Pairs, by invitation — your partner asks one question: “How did you know?”</a:t>
-            </a:r>
-          </a:p>
-        </p:txBody>
-      </p:sp>
-      <p:sp>
-        <p:nvSpPr>
-          <p:cNvPr id="6" name="TextBox 6"/>
-          <p:cNvSpPr txBox="1"/>
-          <p:nvPr/>
-        </p:nvSpPr>
-        <p:spPr>
-          <a:xfrm>
-            <a:off x="6766560" y="1737360"/>
-            <a:ext cx="4663440" cy="2194560"/>
-          </a:xfrm>
-          <a:prstGeom prst="rect">
-            <a:avLst/>
-          </a:prstGeom>
-          <a:solidFill>
-            <a:srgbClr val="F1F6EC"/>
-          </a:solidFill>
-        </p:spPr>
-        <p:txBody>
-          <a:bodyPr wrap="square" lIns="91440" tIns="91440" rIns="91440" bIns="91440" anchor="ctr"/>
-          <a:lstStyle/>
-          <a:p>
-            <a:pPr>
-              <a:spcAft>
-                <a:spcPts val="900"/>
-              </a:spcAft>
-            </a:pPr>
-            <a:r>
-              <a:rPr sz="1200" b="1" i="0">
-                <a:solidFill>
-                  <a:srgbClr val="97BC62"/>
-                </a:solidFill>
-                <a:latin typeface="Calibri"/>
-              </a:rPr>
-              <a:t>JOHN 10:27</a:t>
-            </a:r>
-          </a:p>
-          <a:p>
-            <a:pPr>
-              <a:spcAft>
-                <a:spcPts val="600"/>
-              </a:spcAft>
-            </a:pPr>
-            <a:r>
-              <a:rPr sz="2400" b="0" i="1">
-                <a:solidFill>
-                  <a:srgbClr val="222B22"/>
-                </a:solidFill>
-                <a:latin typeface="Cambria"/>
-              </a:rPr>
-              <a:t>“My sheep hear my voice, and I know them, and they follow me.”</a:t>
+              <a:t>If something painful surfaces — bless it: “I hear that. May Jesus stay with you in that place this week.”</a:t>
             </a:r>
           </a:p>
         </p:txBody>
@@ -7006,402 +7637,7 @@
           <a:p>
             <a:pPr algn="r"/>
             <a:r>
-              <a:t>G7</a:t>
-            </a:r>
-            <a:endParaRPr sz="1000" b="1">
-              <a:solidFill>
-                <a:srgbClr val="7A8A6E"/>
-              </a:solidFill>
-              <a:latin typeface="Calibri"/>
-            </a:endParaRPr>
-          </a:p>
-        </p:txBody>
-      </p:sp>
-    </p:spTree>
-  </p:cSld>
-  <p:clrMapOvr>
-    <a:masterClrMapping/>
-  </p:clrMapOvr>
-</p:sld>
-</file>
-
-<file path=ppt/slides/slide17.xml><?xml version="1.0" encoding="utf-8"?>
-<p:sld xmlns:a="http://schemas.openxmlformats.org/drawingml/2006/main" xmlns:p="http://schemas.openxmlformats.org/presentationml/2006/main" xmlns:r="http://schemas.openxmlformats.org/officeDocument/2006/relationships">
-  <p:cSld>
-    <p:spTree>
-      <p:nvGrpSpPr>
-        <p:cNvPr id="1" name=""/>
-        <p:cNvGrpSpPr/>
-        <p:nvPr/>
-      </p:nvGrpSpPr>
-      <p:grpSpPr/>
-      <p:sp>
-        <p:nvSpPr>
-          <p:cNvPr id="2" name="Rectangle 1"/>
-          <p:cNvSpPr/>
-          <p:nvPr/>
-        </p:nvSpPr>
-        <p:spPr>
-          <a:xfrm>
-            <a:off x="0" y="0"/>
-            <a:ext cx="12191695" cy="6858000"/>
-          </a:xfrm>
-          <a:prstGeom prst="rect">
-            <a:avLst/>
-          </a:prstGeom>
-          <a:solidFill>
-            <a:srgbClr val="FFFFFF"/>
-          </a:solidFill>
-          <a:ln>
-            <a:noFill/>
-          </a:ln>
-        </p:spPr>
-        <p:txBody>
-          <a:bodyPr/>
-          <a:lstStyle/>
-          <a:p>
-            <a:endParaRPr/>
-          </a:p>
-        </p:txBody>
-      </p:sp>
-      <p:sp>
-        <p:nvSpPr>
-          <p:cNvPr id="3" name="TextBox 2"/>
-          <p:cNvSpPr txBox="1"/>
-          <p:nvPr/>
-        </p:nvSpPr>
-        <p:spPr>
-          <a:xfrm>
-            <a:off x="822960" y="502920"/>
-            <a:ext cx="10515600" cy="822960"/>
-          </a:xfrm>
-          <a:prstGeom prst="rect">
-            <a:avLst/>
-          </a:prstGeom>
-          <a:noFill/>
-        </p:spPr>
-        <p:txBody>
-          <a:bodyPr wrap="square">
-            <a:spAutoFit/>
-          </a:bodyPr>
-          <a:lstStyle/>
-          <a:p>
-            <a:pPr algn="l">
-              <a:spcAft>
-                <a:spcPts val="600"/>
-              </a:spcAft>
-            </a:pPr>
-            <a:r>
-              <a:rPr sz="2800" b="1" i="0">
-                <a:solidFill>
-                  <a:srgbClr val="2C5F2D"/>
-                </a:solidFill>
-                <a:latin typeface="Cambria"/>
-              </a:rPr>
-              <a:t>How Did You Know? — Testing What You Hear</a:t>
-            </a:r>
-          </a:p>
-        </p:txBody>
-      </p:sp>
-      <p:sp>
-        <p:nvSpPr>
-          <p:cNvPr id="4" name="TextBox 4"/>
-          <p:cNvSpPr txBox="1"/>
-          <p:nvPr/>
-        </p:nvSpPr>
-        <p:spPr>
-          <a:xfrm>
-            <a:off x="822960" y="1600200"/>
-            <a:ext cx="5669280" cy="4572000"/>
-          </a:xfrm>
-          <a:prstGeom prst="rect">
-            <a:avLst/>
-          </a:prstGeom>
-          <a:noFill/>
-        </p:spPr>
-        <p:txBody>
-          <a:bodyPr wrap="square" lIns="91440" tIns="91440" rIns="91440" bIns="91440"/>
-          <a:lstStyle/>
-          <a:p>
-            <a:pPr marL="274320" indent="-274320">
-              <a:spcAft>
-                <a:spcPts val="650"/>
-              </a:spcAft>
-            </a:pPr>
-            <a:r>
-              <a:rPr sz="1700" b="1" i="0">
-                <a:solidFill>
-                  <a:srgbClr val="97BC62"/>
-                </a:solidFill>
-                <a:latin typeface="Calibri"/>
-              </a:rPr>
-              <a:t>•  </a:t>
-            </a:r>
-            <a:r>
-              <a:rPr sz="1700" b="0" i="0">
-                <a:solidFill>
-                  <a:srgbClr val="222B22"/>
-                </a:solidFill>
-                <a:latin typeface="Calibri"/>
-              </a:rPr>
-              <a:t>Scripture first — does it line up with what God has already said? Scripture is the court; the rest confirm</a:t>
-            </a:r>
-          </a:p>
-          <a:p>
-            <a:pPr marL="274320" indent="-274320">
-              <a:spcAft>
-                <a:spcPts val="650"/>
-              </a:spcAft>
-            </a:pPr>
-            <a:r>
-              <a:rPr sz="1700" b="1" i="0">
-                <a:solidFill>
-                  <a:srgbClr val="97BC62"/>
-                </a:solidFill>
-                <a:latin typeface="Calibri"/>
-              </a:rPr>
-              <a:t>•  </a:t>
-            </a:r>
-            <a:r>
-              <a:rPr sz="1700" b="0" i="0">
-                <a:solidFill>
-                  <a:srgbClr val="222B22"/>
-                </a:solidFill>
-                <a:latin typeface="Calibri"/>
-              </a:rPr>
-              <a:t>Sense — does it make sense, or does it ask you to switch your mind off?</a:t>
-            </a:r>
-          </a:p>
-          <a:p>
-            <a:pPr marL="274320" indent="-274320">
-              <a:spcAft>
-                <a:spcPts val="650"/>
-              </a:spcAft>
-            </a:pPr>
-            <a:r>
-              <a:rPr sz="1700" b="1" i="0">
-                <a:solidFill>
-                  <a:srgbClr val="97BC62"/>
-                </a:solidFill>
-                <a:latin typeface="Calibri"/>
-              </a:rPr>
-              <a:t>•  </a:t>
-            </a:r>
-            <a:r>
-              <a:rPr sz="1700" b="0" i="0">
-                <a:solidFill>
-                  <a:srgbClr val="222B22"/>
-                </a:solidFill>
-                <a:latin typeface="Calibri"/>
-              </a:rPr>
-              <a:t>The Spirit’s witness — an inner “yes” that rings true (Rom. 8:16)</a:t>
-            </a:r>
-          </a:p>
-          <a:p>
-            <a:pPr marL="274320" indent="-274320">
-              <a:spcAft>
-                <a:spcPts val="650"/>
-              </a:spcAft>
-            </a:pPr>
-            <a:r>
-              <a:rPr sz="1700" b="1" i="0">
-                <a:solidFill>
-                  <a:srgbClr val="97BC62"/>
-                </a:solidFill>
-                <a:latin typeface="Calibri"/>
-              </a:rPr>
-              <a:t>•  </a:t>
-            </a:r>
-            <a:r>
-              <a:rPr sz="1700" b="0" i="0">
-                <a:solidFill>
-                  <a:srgbClr val="222B22"/>
-                </a:solidFill>
-                <a:latin typeface="Calibri"/>
-              </a:rPr>
-              <a:t>Peace — even when the word is hard (Col. 3:15)</a:t>
-            </a:r>
-          </a:p>
-          <a:p>
-            <a:pPr marL="274320" indent="-274320">
-              <a:spcAft>
-                <a:spcPts val="650"/>
-              </a:spcAft>
-            </a:pPr>
-            <a:r>
-              <a:rPr sz="1700" b="1" i="0">
-                <a:solidFill>
-                  <a:srgbClr val="97BC62"/>
-                </a:solidFill>
-                <a:latin typeface="Calibri"/>
-              </a:rPr>
-              <a:t>•  </a:t>
-            </a:r>
-            <a:r>
-              <a:rPr sz="1700" b="0" i="0">
-                <a:solidFill>
-                  <a:srgbClr val="222B22"/>
-                </a:solidFill>
-                <a:latin typeface="Calibri"/>
-              </a:rPr>
-              <a:t>Company — what do people who know you and know God see?</a:t>
-            </a:r>
-          </a:p>
-          <a:p>
-            <a:pPr marL="274320" indent="-274320">
-              <a:spcAft>
-                <a:spcPts val="650"/>
-              </a:spcAft>
-            </a:pPr>
-            <a:r>
-              <a:rPr sz="1700" b="1" i="0">
-                <a:solidFill>
-                  <a:srgbClr val="97BC62"/>
-                </a:solidFill>
-                <a:latin typeface="Calibri"/>
-              </a:rPr>
-              <a:t>•  </a:t>
-            </a:r>
-            <a:r>
-              <a:rPr sz="1700" b="0" i="0">
-                <a:solidFill>
-                  <a:srgbClr val="222B22"/>
-                </a:solidFill>
-                <a:latin typeface="Calibri"/>
-              </a:rPr>
-              <a:t>Circumstances — do doors open or close around it?</a:t>
-            </a:r>
-          </a:p>
-          <a:p>
-            <a:pPr marL="274320" indent="-274320">
-              <a:spcAft>
-                <a:spcPts val="650"/>
-              </a:spcAft>
-            </a:pPr>
-            <a:r>
-              <a:rPr sz="1700" b="1" i="0">
-                <a:solidFill>
-                  <a:srgbClr val="97BC62"/>
-                </a:solidFill>
-                <a:latin typeface="Calibri"/>
-              </a:rPr>
-              <a:t>•  </a:t>
-            </a:r>
-            <a:r>
-              <a:rPr sz="1700" b="0" i="0">
-                <a:solidFill>
-                  <a:srgbClr val="222B22"/>
-                </a:solidFill>
-                <a:latin typeface="Calibri"/>
-              </a:rPr>
-              <a:t>Over time — obeying what you hear opens you to hear more</a:t>
-            </a:r>
-          </a:p>
-          <a:p>
-            <a:pPr marL="274320" indent="-274320">
-              <a:spcAft>
-                <a:spcPts val="650"/>
-              </a:spcAft>
-            </a:pPr>
-            <a:r>
-              <a:rPr sz="1700" b="1" i="0">
-                <a:solidFill>
-                  <a:srgbClr val="97BC62"/>
-                </a:solidFill>
-                <a:latin typeface="Calibri"/>
-              </a:rPr>
-              <a:t>•  </a:t>
-            </a:r>
-            <a:r>
-              <a:rPr sz="1700" b="0" i="0">
-                <a:solidFill>
-                  <a:srgbClr val="222B22"/>
-                </a:solidFill>
-                <a:latin typeface="Calibri"/>
-              </a:rPr>
-              <a:t>Tonight in the garden: notice, don’t conclude — you will test it on your returns</a:t>
-            </a:r>
-          </a:p>
-        </p:txBody>
-      </p:sp>
-      <p:sp>
-        <p:nvSpPr>
-          <p:cNvPr id="6" name="TextBox 6"/>
-          <p:cNvSpPr txBox="1"/>
-          <p:nvPr/>
-        </p:nvSpPr>
-        <p:spPr>
-          <a:xfrm>
-            <a:off x="6766560" y="1737360"/>
-            <a:ext cx="4663440" cy="2194560"/>
-          </a:xfrm>
-          <a:prstGeom prst="rect">
-            <a:avLst/>
-          </a:prstGeom>
-          <a:solidFill>
-            <a:srgbClr val="F1F6EC"/>
-          </a:solidFill>
-        </p:spPr>
-        <p:txBody>
-          <a:bodyPr wrap="square" lIns="91440" tIns="91440" rIns="91440" bIns="91440" anchor="ctr"/>
-          <a:lstStyle/>
-          <a:p>
-            <a:pPr>
-              <a:spcAft>
-                <a:spcPts val="900"/>
-              </a:spcAft>
-            </a:pPr>
-            <a:r>
-              <a:rPr sz="1200" b="1" i="0">
-                <a:solidFill>
-                  <a:srgbClr val="97BC62"/>
-                </a:solidFill>
-                <a:latin typeface="Calibri"/>
-              </a:rPr>
-              <a:t>1 THESSALONIANS 5:20–21</a:t>
-            </a:r>
-          </a:p>
-          <a:p>
-            <a:pPr>
-              <a:spcAft>
-                <a:spcPts val="600"/>
-              </a:spcAft>
-            </a:pPr>
-            <a:r>
-              <a:rPr sz="2400" b="0" i="1">
-                <a:solidFill>
-                  <a:srgbClr val="222B22"/>
-                </a:solidFill>
-                <a:latin typeface="Cambria"/>
-              </a:rPr>
-              <a:t>“Do not despise prophecies, but test everything; hold fast what is good.”</a:t>
-            </a:r>
-          </a:p>
-        </p:txBody>
-      </p:sp>
-      <p:sp>
-        <p:nvSpPr>
-          <p:cNvPr id="90" name="SlideNum"/>
-          <p:cNvSpPr txBox="1"/>
-          <p:nvPr/>
-        </p:nvSpPr>
-        <p:spPr>
-          <a:xfrm>
-            <a:off x="11384280" y="6446520"/>
-            <a:ext cx="640080" cy="292608"/>
-          </a:xfrm>
-          <a:prstGeom prst="rect">
-            <a:avLst/>
-          </a:prstGeom>
-          <a:noFill/>
-        </p:spPr>
-        <p:txBody>
-          <a:bodyPr wrap="none" lIns="0" tIns="0" rIns="45720" bIns="0" anchor="ctr"/>
-          <a:lstStyle/>
-          <a:p>
-            <a:pPr algn="r"/>
-            <a:r>
-              <a:t>G8</a:t>
+              <a:t>G12</a:t>
             </a:r>
             <a:endParaRPr sz="1000" b="1">
               <a:solidFill>
@@ -8143,7 +8379,7 @@
                 </a:solidFill>
                 <a:latin typeface="Calibri"/>
               </a:rPr>
-              <a:t>The Garden exercise — whole room, then pairs</a:t>
+              <a:t>The Garden — two rounds, write and share each</a:t>
             </a:r>
           </a:p>
           <a:p>
@@ -8956,6 +9192,746 @@
 </file>
 
 <file path=ppt/slides/slide7.xml><?xml version="1.0" encoding="utf-8"?>
+<p:sld xmlns:a="http://schemas.openxmlformats.org/drawingml/2006/main" xmlns:p="http://schemas.openxmlformats.org/presentationml/2006/main" xmlns:r="http://schemas.openxmlformats.org/officeDocument/2006/relationships">
+  <p:cSld>
+    <p:spTree>
+      <p:nvGrpSpPr>
+        <p:cNvPr id="1" name=""/>
+        <p:cNvGrpSpPr/>
+        <p:nvPr/>
+      </p:nvGrpSpPr>
+      <p:grpSpPr/>
+      <p:sp>
+        <p:nvSpPr>
+          <p:cNvPr id="2" name="Rectangle 1"/>
+          <p:cNvSpPr/>
+          <p:nvPr/>
+        </p:nvSpPr>
+        <p:spPr>
+          <a:xfrm>
+            <a:off x="0" y="0"/>
+            <a:ext cx="12191695" cy="6858000"/>
+          </a:xfrm>
+          <a:prstGeom prst="rect">
+            <a:avLst/>
+          </a:prstGeom>
+          <a:solidFill>
+            <a:srgbClr val="FFFFFF"/>
+          </a:solidFill>
+          <a:ln>
+            <a:noFill/>
+          </a:ln>
+        </p:spPr>
+        <p:txBody>
+          <a:bodyPr/>
+          <a:lstStyle/>
+          <a:p>
+            <a:endParaRPr/>
+          </a:p>
+        </p:txBody>
+      </p:sp>
+      <p:sp>
+        <p:nvSpPr>
+          <p:cNvPr id="3" name="TextBox 2"/>
+          <p:cNvSpPr txBox="1"/>
+          <p:nvPr/>
+        </p:nvSpPr>
+        <p:spPr>
+          <a:xfrm>
+            <a:off x="822960" y="502920"/>
+            <a:ext cx="10515600" cy="822960"/>
+          </a:xfrm>
+          <a:prstGeom prst="rect">
+            <a:avLst/>
+          </a:prstGeom>
+          <a:noFill/>
+        </p:spPr>
+        <p:txBody>
+          <a:bodyPr wrap="square">
+            <a:spAutoFit/>
+          </a:bodyPr>
+          <a:lstStyle/>
+          <a:p>
+            <a:pPr algn="l">
+              <a:spcAft>
+                <a:spcPts val="600"/>
+              </a:spcAft>
+            </a:pPr>
+            <a:r>
+              <a:rPr sz="2800" b="1" i="0">
+                <a:solidFill>
+                  <a:srgbClr val="2C5F2D"/>
+                </a:solidFill>
+                <a:latin typeface="Cambria"/>
+              </a:rPr>
+              <a:t>When Have You Really Heard?</a:t>
+            </a:r>
+          </a:p>
+        </p:txBody>
+      </p:sp>
+      <p:sp>
+        <p:nvSpPr>
+          <p:cNvPr id="4" name="TextBox 4"/>
+          <p:cNvSpPr txBox="1"/>
+          <p:nvPr/>
+        </p:nvSpPr>
+        <p:spPr>
+          <a:xfrm>
+            <a:off x="822960" y="1600200"/>
+            <a:ext cx="5669280" cy="4572000"/>
+          </a:xfrm>
+          <a:prstGeom prst="rect">
+            <a:avLst/>
+          </a:prstGeom>
+          <a:noFill/>
+        </p:spPr>
+        <p:txBody>
+          <a:bodyPr wrap="square" lIns="91440" tIns="91440" rIns="91440" bIns="91440"/>
+          <a:lstStyle/>
+          <a:p>
+            <a:pPr marL="274320" indent="-274320">
+              <a:spcAft>
+                <a:spcPts val="650"/>
+              </a:spcAft>
+            </a:pPr>
+            <a:r>
+              <a:rPr sz="1800" b="1" i="0">
+                <a:solidFill>
+                  <a:srgbClr val="97BC62"/>
+                </a:solidFill>
+                <a:latin typeface="Calibri"/>
+              </a:rPr>
+              <a:t>•  </a:t>
+            </a:r>
+            <a:r>
+              <a:rPr sz="1800" b="0" i="0">
+                <a:solidFill>
+                  <a:srgbClr val="222B22"/>
+                </a:solidFill>
+                <a:latin typeface="Calibri"/>
+              </a:rPr>
+              <a:t>Remember one time you really heard God — a verse that jumped off the page, a nudge, a word through someone, a quiet knowing</a:t>
+            </a:r>
+          </a:p>
+          <a:p>
+            <a:pPr marL="274320" indent="-274320">
+              <a:spcAft>
+                <a:spcPts val="650"/>
+              </a:spcAft>
+            </a:pPr>
+            <a:r>
+              <a:rPr sz="1800" b="1" i="0">
+                <a:solidFill>
+                  <a:srgbClr val="97BC62"/>
+                </a:solidFill>
+                <a:latin typeface="Calibri"/>
+              </a:rPr>
+              <a:t>•  </a:t>
+            </a:r>
+            <a:r>
+              <a:rPr sz="1800" b="0" i="0">
+                <a:solidFill>
+                  <a:srgbClr val="222B22"/>
+                </a:solidFill>
+                <a:latin typeface="Calibri"/>
+              </a:rPr>
+              <a:t>Where were you, and what was going on? Reading, worship, a conversation, outdoors, a hard day</a:t>
+            </a:r>
+          </a:p>
+          <a:p>
+            <a:pPr marL="274320" indent="-274320">
+              <a:spcAft>
+                <a:spcPts val="650"/>
+              </a:spcAft>
+            </a:pPr>
+            <a:r>
+              <a:rPr sz="1800" b="1" i="0">
+                <a:solidFill>
+                  <a:srgbClr val="97BC62"/>
+                </a:solidFill>
+                <a:latin typeface="Calibri"/>
+              </a:rPr>
+              <a:t>•  </a:t>
+            </a:r>
+            <a:r>
+              <a:rPr sz="1800" b="0" i="0">
+                <a:solidFill>
+                  <a:srgbClr val="222B22"/>
+                </a:solidFill>
+                <a:latin typeface="Calibri"/>
+              </a:rPr>
+              <a:t>What did it look like, sound like, feel like? Write it down — make it fuller</a:t>
+            </a:r>
+          </a:p>
+          <a:p>
+            <a:pPr marL="274320" indent="-274320">
+              <a:spcAft>
+                <a:spcPts val="650"/>
+              </a:spcAft>
+            </a:pPr>
+            <a:r>
+              <a:rPr sz="1800" b="1" i="0">
+                <a:solidFill>
+                  <a:srgbClr val="97BC62"/>
+                </a:solidFill>
+                <a:latin typeface="Calibri"/>
+              </a:rPr>
+              <a:t>•  </a:t>
+            </a:r>
+            <a:r>
+              <a:rPr sz="1800" b="0" i="0">
+                <a:solidFill>
+                  <a:srgbClr val="222B22"/>
+                </a:solidFill>
+                <a:latin typeface="Calibri"/>
+              </a:rPr>
+              <a:t>What did you do with it — and what happened?</a:t>
+            </a:r>
+          </a:p>
+          <a:p>
+            <a:pPr marL="274320" indent="-274320">
+              <a:spcAft>
+                <a:spcPts val="650"/>
+              </a:spcAft>
+            </a:pPr>
+            <a:r>
+              <a:rPr sz="1800" b="1" i="0">
+                <a:solidFill>
+                  <a:srgbClr val="97BC62"/>
+                </a:solidFill>
+                <a:latin typeface="Calibri"/>
+              </a:rPr>
+              <a:t>•  </a:t>
+            </a:r>
+            <a:r>
+              <a:rPr sz="1800" b="0" i="0">
+                <a:solidFill>
+                  <a:srgbClr val="222B22"/>
+                </a:solidFill>
+                <a:latin typeface="Calibri"/>
+              </a:rPr>
+              <a:t>Can’t think of one? A time creation stopped you in your tracks counts — God speaks through what he has made (Rom. 1:20)</a:t>
+            </a:r>
+          </a:p>
+          <a:p>
+            <a:pPr marL="274320" indent="-274320">
+              <a:spcAft>
+                <a:spcPts val="650"/>
+              </a:spcAft>
+            </a:pPr>
+            <a:r>
+              <a:rPr sz="1800" b="1" i="0">
+                <a:solidFill>
+                  <a:srgbClr val="97BC62"/>
+                </a:solidFill>
+                <a:latin typeface="Calibri"/>
+              </a:rPr>
+              <a:t>•  </a:t>
+            </a:r>
+            <a:r>
+              <a:rPr sz="1800" b="0" i="0">
+                <a:solidFill>
+                  <a:srgbClr val="222B22"/>
+                </a:solidFill>
+                <a:latin typeface="Calibri"/>
+              </a:rPr>
+              <a:t>Pairs, by invitation — your partner asks one question: “How did you know?”</a:t>
+            </a:r>
+          </a:p>
+        </p:txBody>
+      </p:sp>
+      <p:sp>
+        <p:nvSpPr>
+          <p:cNvPr id="6" name="TextBox 6"/>
+          <p:cNvSpPr txBox="1"/>
+          <p:nvPr/>
+        </p:nvSpPr>
+        <p:spPr>
+          <a:xfrm>
+            <a:off x="6766560" y="1737360"/>
+            <a:ext cx="4663440" cy="2194560"/>
+          </a:xfrm>
+          <a:prstGeom prst="rect">
+            <a:avLst/>
+          </a:prstGeom>
+          <a:solidFill>
+            <a:srgbClr val="F1F6EC"/>
+          </a:solidFill>
+        </p:spPr>
+        <p:txBody>
+          <a:bodyPr wrap="square" lIns="91440" tIns="91440" rIns="91440" bIns="91440" anchor="ctr"/>
+          <a:lstStyle/>
+          <a:p>
+            <a:pPr>
+              <a:spcAft>
+                <a:spcPts val="900"/>
+              </a:spcAft>
+            </a:pPr>
+            <a:r>
+              <a:rPr sz="1200" b="1" i="0">
+                <a:solidFill>
+                  <a:srgbClr val="97BC62"/>
+                </a:solidFill>
+                <a:latin typeface="Calibri"/>
+              </a:rPr>
+              <a:t>JOHN 10:27</a:t>
+            </a:r>
+          </a:p>
+          <a:p>
+            <a:pPr>
+              <a:spcAft>
+                <a:spcPts val="600"/>
+              </a:spcAft>
+            </a:pPr>
+            <a:r>
+              <a:rPr sz="2400" b="0" i="1">
+                <a:solidFill>
+                  <a:srgbClr val="222B22"/>
+                </a:solidFill>
+                <a:latin typeface="Cambria"/>
+              </a:rPr>
+              <a:t>“My sheep hear my voice, and I know them, and they follow me.”</a:t>
+            </a:r>
+          </a:p>
+        </p:txBody>
+      </p:sp>
+      <p:sp>
+        <p:nvSpPr>
+          <p:cNvPr id="90" name="SlideNum"/>
+          <p:cNvSpPr txBox="1"/>
+          <p:nvPr/>
+        </p:nvSpPr>
+        <p:spPr>
+          <a:xfrm>
+            <a:off x="11384280" y="6446520"/>
+            <a:ext cx="640080" cy="292608"/>
+          </a:xfrm>
+          <a:prstGeom prst="rect">
+            <a:avLst/>
+          </a:prstGeom>
+          <a:noFill/>
+        </p:spPr>
+        <p:txBody>
+          <a:bodyPr wrap="none" lIns="0" tIns="0" rIns="45720" bIns="0" anchor="ctr"/>
+          <a:lstStyle/>
+          <a:p>
+            <a:pPr algn="r"/>
+            <a:r>
+              <a:t>G7</a:t>
+            </a:r>
+            <a:endParaRPr sz="1000" b="1">
+              <a:solidFill>
+                <a:srgbClr val="7A8A6E"/>
+              </a:solidFill>
+              <a:latin typeface="Calibri"/>
+            </a:endParaRPr>
+          </a:p>
+        </p:txBody>
+      </p:sp>
+    </p:spTree>
+  </p:cSld>
+  <p:clrMapOvr>
+    <a:masterClrMapping/>
+  </p:clrMapOvr>
+</p:sld>
+</file>
+
+<file path=ppt/slides/slide8.xml><?xml version="1.0" encoding="utf-8"?>
+<p:sld xmlns:a="http://schemas.openxmlformats.org/drawingml/2006/main" xmlns:p="http://schemas.openxmlformats.org/presentationml/2006/main" xmlns:r="http://schemas.openxmlformats.org/officeDocument/2006/relationships">
+  <p:cSld>
+    <p:spTree>
+      <p:nvGrpSpPr>
+        <p:cNvPr id="1" name=""/>
+        <p:cNvGrpSpPr/>
+        <p:nvPr/>
+      </p:nvGrpSpPr>
+      <p:grpSpPr/>
+      <p:sp>
+        <p:nvSpPr>
+          <p:cNvPr id="2" name="Rectangle 1"/>
+          <p:cNvSpPr/>
+          <p:nvPr/>
+        </p:nvSpPr>
+        <p:spPr>
+          <a:xfrm>
+            <a:off x="0" y="0"/>
+            <a:ext cx="12191695" cy="6858000"/>
+          </a:xfrm>
+          <a:prstGeom prst="rect">
+            <a:avLst/>
+          </a:prstGeom>
+          <a:solidFill>
+            <a:srgbClr val="FFFFFF"/>
+          </a:solidFill>
+          <a:ln>
+            <a:noFill/>
+          </a:ln>
+        </p:spPr>
+        <p:txBody>
+          <a:bodyPr/>
+          <a:lstStyle/>
+          <a:p>
+            <a:endParaRPr/>
+          </a:p>
+        </p:txBody>
+      </p:sp>
+      <p:sp>
+        <p:nvSpPr>
+          <p:cNvPr id="3" name="TextBox 2"/>
+          <p:cNvSpPr txBox="1"/>
+          <p:nvPr/>
+        </p:nvSpPr>
+        <p:spPr>
+          <a:xfrm>
+            <a:off x="822960" y="502920"/>
+            <a:ext cx="10515600" cy="822960"/>
+          </a:xfrm>
+          <a:prstGeom prst="rect">
+            <a:avLst/>
+          </a:prstGeom>
+          <a:noFill/>
+        </p:spPr>
+        <p:txBody>
+          <a:bodyPr wrap="square">
+            <a:spAutoFit/>
+          </a:bodyPr>
+          <a:lstStyle/>
+          <a:p>
+            <a:pPr algn="l">
+              <a:spcAft>
+                <a:spcPts val="600"/>
+              </a:spcAft>
+            </a:pPr>
+            <a:r>
+              <a:rPr sz="2800" b="1" i="0">
+                <a:solidFill>
+                  <a:srgbClr val="2C5F2D"/>
+                </a:solidFill>
+                <a:latin typeface="Cambria"/>
+              </a:rPr>
+              <a:t>How Did You Know? — Testing What You Hear</a:t>
+            </a:r>
+          </a:p>
+        </p:txBody>
+      </p:sp>
+      <p:sp>
+        <p:nvSpPr>
+          <p:cNvPr id="4" name="TextBox 4"/>
+          <p:cNvSpPr txBox="1"/>
+          <p:nvPr/>
+        </p:nvSpPr>
+        <p:spPr>
+          <a:xfrm>
+            <a:off x="822960" y="1600200"/>
+            <a:ext cx="5669280" cy="4572000"/>
+          </a:xfrm>
+          <a:prstGeom prst="rect">
+            <a:avLst/>
+          </a:prstGeom>
+          <a:noFill/>
+        </p:spPr>
+        <p:txBody>
+          <a:bodyPr wrap="square" lIns="91440" tIns="91440" rIns="91440" bIns="91440"/>
+          <a:lstStyle/>
+          <a:p>
+            <a:pPr marL="274320" indent="-274320">
+              <a:spcAft>
+                <a:spcPts val="650"/>
+              </a:spcAft>
+            </a:pPr>
+            <a:r>
+              <a:rPr sz="1700" b="1" i="0">
+                <a:solidFill>
+                  <a:srgbClr val="97BC62"/>
+                </a:solidFill>
+                <a:latin typeface="Calibri"/>
+              </a:rPr>
+              <a:t>•  </a:t>
+            </a:r>
+            <a:r>
+              <a:rPr sz="1700" b="0" i="0">
+                <a:solidFill>
+                  <a:srgbClr val="222B22"/>
+                </a:solidFill>
+                <a:latin typeface="Calibri"/>
+              </a:rPr>
+              <a:t>Scripture first — does it line up with what God has already said? Scripture is the court; the rest confirm</a:t>
+            </a:r>
+          </a:p>
+          <a:p>
+            <a:pPr marL="274320" indent="-274320">
+              <a:spcAft>
+                <a:spcPts val="650"/>
+              </a:spcAft>
+            </a:pPr>
+            <a:r>
+              <a:rPr sz="1700" b="1" i="0">
+                <a:solidFill>
+                  <a:srgbClr val="97BC62"/>
+                </a:solidFill>
+                <a:latin typeface="Calibri"/>
+              </a:rPr>
+              <a:t>•  </a:t>
+            </a:r>
+            <a:r>
+              <a:rPr sz="1700" b="0" i="0">
+                <a:solidFill>
+                  <a:srgbClr val="222B22"/>
+                </a:solidFill>
+                <a:latin typeface="Calibri"/>
+              </a:rPr>
+              <a:t>Sense — does it make sense, or does it ask you to switch your mind off?</a:t>
+            </a:r>
+          </a:p>
+          <a:p>
+            <a:pPr marL="274320" indent="-274320">
+              <a:spcAft>
+                <a:spcPts val="650"/>
+              </a:spcAft>
+            </a:pPr>
+            <a:r>
+              <a:rPr sz="1700" b="1" i="0">
+                <a:solidFill>
+                  <a:srgbClr val="97BC62"/>
+                </a:solidFill>
+                <a:latin typeface="Calibri"/>
+              </a:rPr>
+              <a:t>•  </a:t>
+            </a:r>
+            <a:r>
+              <a:rPr sz="1700" b="0" i="0">
+                <a:solidFill>
+                  <a:srgbClr val="222B22"/>
+                </a:solidFill>
+                <a:latin typeface="Calibri"/>
+              </a:rPr>
+              <a:t>The Spirit’s witness — an inner “yes” that rings true (Rom. 8:16)</a:t>
+            </a:r>
+          </a:p>
+          <a:p>
+            <a:pPr marL="274320" indent="-274320">
+              <a:spcAft>
+                <a:spcPts val="650"/>
+              </a:spcAft>
+            </a:pPr>
+            <a:r>
+              <a:rPr sz="1700" b="1" i="0">
+                <a:solidFill>
+                  <a:srgbClr val="97BC62"/>
+                </a:solidFill>
+                <a:latin typeface="Calibri"/>
+              </a:rPr>
+              <a:t>•  </a:t>
+            </a:r>
+            <a:r>
+              <a:rPr sz="1700" b="0" i="0">
+                <a:solidFill>
+                  <a:srgbClr val="222B22"/>
+                </a:solidFill>
+                <a:latin typeface="Calibri"/>
+              </a:rPr>
+              <a:t>Peace — even when the word is hard (Col. 3:15)</a:t>
+            </a:r>
+          </a:p>
+          <a:p>
+            <a:pPr marL="274320" indent="-274320">
+              <a:spcAft>
+                <a:spcPts val="650"/>
+              </a:spcAft>
+            </a:pPr>
+            <a:r>
+              <a:rPr sz="1700" b="1" i="0">
+                <a:solidFill>
+                  <a:srgbClr val="97BC62"/>
+                </a:solidFill>
+                <a:latin typeface="Calibri"/>
+              </a:rPr>
+              <a:t>•  </a:t>
+            </a:r>
+            <a:r>
+              <a:rPr sz="1700" b="0" i="0">
+                <a:solidFill>
+                  <a:srgbClr val="222B22"/>
+                </a:solidFill>
+                <a:latin typeface="Calibri"/>
+              </a:rPr>
+              <a:t>Company — what do people who know you and know God see?</a:t>
+            </a:r>
+          </a:p>
+          <a:p>
+            <a:pPr marL="274320" indent="-274320">
+              <a:spcAft>
+                <a:spcPts val="650"/>
+              </a:spcAft>
+            </a:pPr>
+            <a:r>
+              <a:rPr sz="1700" b="1" i="0">
+                <a:solidFill>
+                  <a:srgbClr val="97BC62"/>
+                </a:solidFill>
+                <a:latin typeface="Calibri"/>
+              </a:rPr>
+              <a:t>•  </a:t>
+            </a:r>
+            <a:r>
+              <a:rPr sz="1700" b="0" i="0">
+                <a:solidFill>
+                  <a:srgbClr val="222B22"/>
+                </a:solidFill>
+                <a:latin typeface="Calibri"/>
+              </a:rPr>
+              <a:t>Circumstances — do doors open or close around it?</a:t>
+            </a:r>
+          </a:p>
+          <a:p>
+            <a:pPr marL="274320" indent="-274320">
+              <a:spcAft>
+                <a:spcPts val="650"/>
+              </a:spcAft>
+            </a:pPr>
+            <a:r>
+              <a:rPr sz="1700" b="1" i="0">
+                <a:solidFill>
+                  <a:srgbClr val="97BC62"/>
+                </a:solidFill>
+                <a:latin typeface="Calibri"/>
+              </a:rPr>
+              <a:t>•  </a:t>
+            </a:r>
+            <a:r>
+              <a:rPr sz="1700" b="0" i="0">
+                <a:solidFill>
+                  <a:srgbClr val="222B22"/>
+                </a:solidFill>
+                <a:latin typeface="Calibri"/>
+              </a:rPr>
+              <a:t>Over time — obeying what you hear opens you to hear more</a:t>
+            </a:r>
+          </a:p>
+          <a:p>
+            <a:pPr marL="274320" indent="-274320">
+              <a:spcAft>
+                <a:spcPts val="650"/>
+              </a:spcAft>
+            </a:pPr>
+            <a:r>
+              <a:rPr sz="1700" b="1" i="0">
+                <a:solidFill>
+                  <a:srgbClr val="97BC62"/>
+                </a:solidFill>
+                <a:latin typeface="Calibri"/>
+              </a:rPr>
+              <a:t>•  </a:t>
+            </a:r>
+            <a:r>
+              <a:rPr sz="1700" b="0" i="0">
+                <a:solidFill>
+                  <a:srgbClr val="222B22"/>
+                </a:solidFill>
+                <a:latin typeface="Calibri"/>
+              </a:rPr>
+              <a:t>Tonight in the garden: notice, don’t conclude — you will test it on your returns</a:t>
+            </a:r>
+          </a:p>
+        </p:txBody>
+      </p:sp>
+      <p:sp>
+        <p:nvSpPr>
+          <p:cNvPr id="6" name="TextBox 6"/>
+          <p:cNvSpPr txBox="1"/>
+          <p:nvPr/>
+        </p:nvSpPr>
+        <p:spPr>
+          <a:xfrm>
+            <a:off x="6766560" y="1737360"/>
+            <a:ext cx="4663440" cy="2194560"/>
+          </a:xfrm>
+          <a:prstGeom prst="rect">
+            <a:avLst/>
+          </a:prstGeom>
+          <a:solidFill>
+            <a:srgbClr val="F1F6EC"/>
+          </a:solidFill>
+        </p:spPr>
+        <p:txBody>
+          <a:bodyPr wrap="square" lIns="91440" tIns="91440" rIns="91440" bIns="91440" anchor="ctr"/>
+          <a:lstStyle/>
+          <a:p>
+            <a:pPr>
+              <a:spcAft>
+                <a:spcPts val="900"/>
+              </a:spcAft>
+            </a:pPr>
+            <a:r>
+              <a:rPr sz="1200" b="1" i="0">
+                <a:solidFill>
+                  <a:srgbClr val="97BC62"/>
+                </a:solidFill>
+                <a:latin typeface="Calibri"/>
+              </a:rPr>
+              <a:t>1 THESSALONIANS 5:20–21</a:t>
+            </a:r>
+          </a:p>
+          <a:p>
+            <a:pPr>
+              <a:spcAft>
+                <a:spcPts val="600"/>
+              </a:spcAft>
+            </a:pPr>
+            <a:r>
+              <a:rPr sz="2400" b="0" i="1">
+                <a:solidFill>
+                  <a:srgbClr val="222B22"/>
+                </a:solidFill>
+                <a:latin typeface="Cambria"/>
+              </a:rPr>
+              <a:t>“Do not despise prophecies, but test everything; hold fast what is good.”</a:t>
+            </a:r>
+          </a:p>
+        </p:txBody>
+      </p:sp>
+      <p:sp>
+        <p:nvSpPr>
+          <p:cNvPr id="90" name="SlideNum"/>
+          <p:cNvSpPr txBox="1"/>
+          <p:nvPr/>
+        </p:nvSpPr>
+        <p:spPr>
+          <a:xfrm>
+            <a:off x="11384280" y="6446520"/>
+            <a:ext cx="640080" cy="292608"/>
+          </a:xfrm>
+          <a:prstGeom prst="rect">
+            <a:avLst/>
+          </a:prstGeom>
+          <a:noFill/>
+        </p:spPr>
+        <p:txBody>
+          <a:bodyPr wrap="none" lIns="0" tIns="0" rIns="45720" bIns="0" anchor="ctr"/>
+          <a:lstStyle/>
+          <a:p>
+            <a:pPr algn="r"/>
+            <a:r>
+              <a:t>G8</a:t>
+            </a:r>
+            <a:endParaRPr sz="1000" b="1">
+              <a:solidFill>
+                <a:srgbClr val="7A8A6E"/>
+              </a:solidFill>
+              <a:latin typeface="Calibri"/>
+            </a:endParaRPr>
+          </a:p>
+        </p:txBody>
+      </p:sp>
+    </p:spTree>
+  </p:cSld>
+  <p:clrMapOvr>
+    <a:masterClrMapping/>
+  </p:clrMapOvr>
+</p:sld>
+</file>
+
+<file path=ppt/slides/slide9.xml><?xml version="1.0" encoding="utf-8"?>
 <p:sld xmlns:a="http://schemas.openxmlformats.org/drawingml/2006/main" xmlns:r="http://schemas.openxmlformats.org/officeDocument/2006/relationships" xmlns:p="http://schemas.openxmlformats.org/presentationml/2006/main">
   <p:cSld>
     <p:spTree>
@@ -9335,600 +10311,6 @@
           </a:effectLst>
         </p:spPr>
       </p:pic>
-    </p:spTree>
-  </p:cSld>
-  <p:clrMapOvr>
-    <a:masterClrMapping/>
-  </p:clrMapOvr>
-</p:sld>
-</file>
-
-<file path=ppt/slides/slide8.xml><?xml version="1.0" encoding="utf-8"?>
-<p:sld xmlns:a="http://schemas.openxmlformats.org/drawingml/2006/main" xmlns:r="http://schemas.openxmlformats.org/officeDocument/2006/relationships" xmlns:p="http://schemas.openxmlformats.org/presentationml/2006/main">
-  <p:cSld>
-    <p:spTree>
-      <p:nvGrpSpPr>
-        <p:cNvPr id="1" name=""/>
-        <p:cNvGrpSpPr/>
-        <p:nvPr/>
-      </p:nvGrpSpPr>
-      <p:grpSpPr>
-        <a:xfrm>
-          <a:off x="0" y="0"/>
-          <a:ext cx="0" cy="0"/>
-          <a:chOff x="0" y="0"/>
-          <a:chExt cx="0" cy="0"/>
-        </a:xfrm>
-      </p:grpSpPr>
-      <p:sp>
-        <p:nvSpPr>
-          <p:cNvPr id="2" name="Rectangle 1"/>
-          <p:cNvSpPr/>
-          <p:nvPr/>
-        </p:nvSpPr>
-        <p:spPr>
-          <a:xfrm>
-            <a:off x="0" y="0"/>
-            <a:ext cx="12191695" cy="6858000"/>
-          </a:xfrm>
-          <a:prstGeom prst="rect">
-            <a:avLst/>
-          </a:prstGeom>
-          <a:solidFill>
-            <a:srgbClr val="FFFFFF"/>
-          </a:solidFill>
-          <a:ln>
-            <a:noFill/>
-          </a:ln>
-        </p:spPr>
-        <p:txBody>
-          <a:bodyPr/>
-          <a:lstStyle/>
-          <a:p>
-            <a:endParaRPr/>
-          </a:p>
-        </p:txBody>
-      </p:sp>
-      <p:sp>
-        <p:nvSpPr>
-          <p:cNvPr id="3" name="TextBox 2"/>
-          <p:cNvSpPr txBox="1"/>
-          <p:nvPr/>
-        </p:nvSpPr>
-        <p:spPr>
-          <a:xfrm>
-            <a:off x="822960" y="502920"/>
-            <a:ext cx="10515600" cy="822960"/>
-          </a:xfrm>
-          <a:prstGeom prst="rect">
-            <a:avLst/>
-          </a:prstGeom>
-          <a:noFill/>
-        </p:spPr>
-        <p:txBody>
-          <a:bodyPr wrap="square">
-            <a:spAutoFit/>
-          </a:bodyPr>
-          <a:lstStyle/>
-          <a:p>
-            <a:pPr algn="l">
-              <a:spcAft>
-                <a:spcPts val="600"/>
-              </a:spcAft>
-            </a:pPr>
-            <a:r>
-              <a:rPr sz="2800" b="1" i="0">
-                <a:solidFill>
-                  <a:srgbClr val="2C5F2D"/>
-                </a:solidFill>
-                <a:latin typeface="Cambria"/>
-              </a:rPr>
-              <a:t>Bridge into the Exercise</a:t>
-            </a:r>
-          </a:p>
-        </p:txBody>
-      </p:sp>
-      <p:sp>
-        <p:nvSpPr>
-          <p:cNvPr id="4" name="TextBox 4"/>
-          <p:cNvSpPr txBox="1"/>
-          <p:nvPr/>
-        </p:nvSpPr>
-        <p:spPr>
-          <a:xfrm>
-            <a:off x="822960" y="1554480"/>
-            <a:ext cx="10515600" cy="4892040"/>
-          </a:xfrm>
-          <a:prstGeom prst="rect">
-            <a:avLst/>
-          </a:prstGeom>
-          <a:noFill/>
-        </p:spPr>
-        <p:txBody>
-          <a:bodyPr wrap="square" lIns="91440" tIns="91440" rIns="91440" bIns="91440"/>
-          <a:lstStyle/>
-          <a:p>
-            <a:pPr marL="274320" indent="-274320">
-              <a:spcAft>
-                <a:spcPts val="900"/>
-              </a:spcAft>
-            </a:pPr>
-            <a:r>
-              <a:rPr sz="2200" b="1" i="0">
-                <a:solidFill>
-                  <a:srgbClr val="97BC62"/>
-                </a:solidFill>
-                <a:latin typeface="Calibri"/>
-              </a:rPr>
-              <a:t>•  </a:t>
-            </a:r>
-            <a:r>
-              <a:rPr sz="2200" b="0" i="0">
-                <a:solidFill>
-                  <a:srgbClr val="222B22"/>
-                </a:solidFill>
-                <a:latin typeface="Calibri"/>
-              </a:rPr>
-              <a:t>We stay right here, together, as one room — a guided imaginative prayer, twelve to fifteen minutes, read slowly</a:t>
-            </a:r>
-          </a:p>
-          <a:p>
-            <a:pPr marL="274320" indent="-274320">
-              <a:spcAft>
-                <a:spcPts val="900"/>
-              </a:spcAft>
-            </a:pPr>
-            <a:r>
-              <a:rPr sz="2200" b="1" i="0">
-                <a:solidFill>
-                  <a:srgbClr val="97BC62"/>
-                </a:solidFill>
-                <a:latin typeface="Calibri"/>
-              </a:rPr>
-              <a:t>•  </a:t>
-            </a:r>
-            <a:r>
-              <a:rPr sz="2200" b="0" i="0">
-                <a:solidFill>
-                  <a:srgbClr val="222B22"/>
-                </a:solidFill>
-                <a:latin typeface="Calibri"/>
-              </a:rPr>
-              <a:t>Eyes closed or open — either is fine; your own family is beside you the whole time</a:t>
-            </a:r>
-          </a:p>
-          <a:p>
-            <a:pPr marL="274320" indent="-274320">
-              <a:spcAft>
-                <a:spcPts val="900"/>
-              </a:spcAft>
-            </a:pPr>
-            <a:r>
-              <a:rPr sz="2200" b="1" i="0">
-                <a:solidFill>
-                  <a:srgbClr val="97BC62"/>
-                </a:solidFill>
-                <a:latin typeface="Calibri"/>
-              </a:rPr>
-              <a:t>•  </a:t>
-            </a:r>
-            <a:r>
-              <a:rPr sz="2200" b="0" i="0">
-                <a:solidFill>
-                  <a:srgbClr val="222B22"/>
-                </a:solidFill>
-                <a:latin typeface="Calibri"/>
-              </a:rPr>
-              <a:t>Then five minutes with your journal, then pairs for sharing — by invitation only</a:t>
-            </a:r>
-          </a:p>
-          <a:p>
-            <a:pPr marL="274320" indent="-274320">
-              <a:spcAft>
-                <a:spcPts val="900"/>
-              </a:spcAft>
-            </a:pPr>
-            <a:r>
-              <a:rPr sz="2200" b="1" i="0">
-                <a:solidFill>
-                  <a:srgbClr val="97BC62"/>
-                </a:solidFill>
-                <a:latin typeface="Calibri"/>
-              </a:rPr>
-              <a:t>•  </a:t>
-            </a:r>
-            <a:r>
-              <a:rPr sz="2200" b="0" i="0">
-                <a:solidFill>
-                  <a:srgbClr val="222B22"/>
-                </a:solidFill>
-                <a:latin typeface="Calibri"/>
-              </a:rPr>
-              <a:t>A parent will open each round — “Silence is a complete answer.”</a:t>
-            </a:r>
-          </a:p>
-          <a:p>
-            <a:pPr marL="274320" indent="-274320">
-              <a:spcAft>
-                <a:spcPts val="900"/>
-              </a:spcAft>
-            </a:pPr>
-            <a:r>
-              <a:rPr sz="2200" b="1" i="0">
-                <a:solidFill>
-                  <a:srgbClr val="97BC62"/>
-                </a:solidFill>
-                <a:latin typeface="Calibri"/>
-              </a:rPr>
-              <a:t>•  </a:t>
-            </a:r>
-            <a:r>
-              <a:rPr sz="2200" b="0" i="0">
-                <a:solidFill>
-                  <a:srgbClr val="222B22"/>
-                </a:solidFill>
-                <a:latin typeface="Calibri"/>
-              </a:rPr>
-              <a:t>Notice, don’t conclude — what you notice tonight, you hold loosely and test on your returns</a:t>
-            </a:r>
-          </a:p>
-          <a:p>
-            <a:pPr marL="274320" indent="-274320">
-              <a:spcAft>
-                <a:spcPts val="900"/>
-              </a:spcAft>
-            </a:pPr>
-            <a:r>
-              <a:rPr sz="2200" b="1" i="0">
-                <a:solidFill>
-                  <a:srgbClr val="97BC62"/>
-                </a:solidFill>
-                <a:latin typeface="Calibri"/>
-              </a:rPr>
-              <a:t>•  </a:t>
-            </a:r>
-            <a:r>
-              <a:rPr sz="2200" b="0" i="0">
-                <a:solidFill>
-                  <a:srgbClr val="222B22"/>
-                </a:solidFill>
-                <a:latin typeface="Calibri"/>
-              </a:rPr>
-              <a:t>“Father, you are the vinedresser. … Where it is hard, be tender. Where it is closed, be patient. Where it is opening, be present.”</a:t>
-            </a:r>
-          </a:p>
-        </p:txBody>
-      </p:sp>
-      <p:sp>
-        <p:nvSpPr>
-          <p:cNvPr id="90" name="SlideNum"/>
-          <p:cNvSpPr txBox="1"/>
-          <p:nvPr/>
-        </p:nvSpPr>
-        <p:spPr>
-          <a:xfrm>
-            <a:off x="11384280" y="6446520"/>
-            <a:ext cx="640080" cy="292608"/>
-          </a:xfrm>
-          <a:prstGeom prst="rect">
-            <a:avLst/>
-          </a:prstGeom>
-          <a:noFill/>
-        </p:spPr>
-        <p:txBody>
-          <a:bodyPr wrap="none" lIns="0" tIns="0" rIns="45720" bIns="0" anchor="ctr"/>
-          <a:lstStyle/>
-          <a:p>
-            <a:pPr algn="r"/>
-            <a:r>
-              <a:t>G10</a:t>
-            </a:r>
-            <a:endParaRPr sz="1000" b="1">
-              <a:solidFill>
-                <a:srgbClr val="7A8A6E"/>
-              </a:solidFill>
-              <a:latin typeface="Calibri"/>
-            </a:endParaRPr>
-          </a:p>
-        </p:txBody>
-      </p:sp>
-    </p:spTree>
-  </p:cSld>
-  <p:clrMapOvr>
-    <a:masterClrMapping/>
-  </p:clrMapOvr>
-</p:sld>
-</file>
-
-<file path=ppt/slides/slide9.xml><?xml version="1.0" encoding="utf-8"?>
-<p:sld xmlns:a="http://schemas.openxmlformats.org/drawingml/2006/main" xmlns:r="http://schemas.openxmlformats.org/officeDocument/2006/relationships" xmlns:p="http://schemas.openxmlformats.org/presentationml/2006/main">
-  <p:cSld>
-    <p:spTree>
-      <p:nvGrpSpPr>
-        <p:cNvPr id="1" name=""/>
-        <p:cNvGrpSpPr/>
-        <p:nvPr/>
-      </p:nvGrpSpPr>
-      <p:grpSpPr>
-        <a:xfrm>
-          <a:off x="0" y="0"/>
-          <a:ext cx="0" cy="0"/>
-          <a:chOff x="0" y="0"/>
-          <a:chExt cx="0" cy="0"/>
-        </a:xfrm>
-      </p:grpSpPr>
-      <p:sp>
-        <p:nvSpPr>
-          <p:cNvPr id="2" name="Rectangle 1"/>
-          <p:cNvSpPr/>
-          <p:nvPr/>
-        </p:nvSpPr>
-        <p:spPr>
-          <a:xfrm>
-            <a:off x="0" y="0"/>
-            <a:ext cx="12191695" cy="6858000"/>
-          </a:xfrm>
-          <a:prstGeom prst="rect">
-            <a:avLst/>
-          </a:prstGeom>
-          <a:solidFill>
-            <a:srgbClr val="FFFFFF"/>
-          </a:solidFill>
-          <a:ln>
-            <a:noFill/>
-          </a:ln>
-        </p:spPr>
-        <p:txBody>
-          <a:bodyPr/>
-          <a:lstStyle/>
-          <a:p>
-            <a:endParaRPr/>
-          </a:p>
-        </p:txBody>
-      </p:sp>
-      <p:sp>
-        <p:nvSpPr>
-          <p:cNvPr id="3" name="TextBox 2"/>
-          <p:cNvSpPr txBox="1"/>
-          <p:nvPr/>
-        </p:nvSpPr>
-        <p:spPr>
-          <a:xfrm>
-            <a:off x="822960" y="502920"/>
-            <a:ext cx="10515600" cy="822960"/>
-          </a:xfrm>
-          <a:prstGeom prst="rect">
-            <a:avLst/>
-          </a:prstGeom>
-          <a:noFill/>
-        </p:spPr>
-        <p:txBody>
-          <a:bodyPr wrap="square">
-            <a:spAutoFit/>
-          </a:bodyPr>
-          <a:lstStyle/>
-          <a:p>
-            <a:pPr algn="l">
-              <a:spcAft>
-                <a:spcPts val="600"/>
-              </a:spcAft>
-            </a:pPr>
-            <a:r>
-              <a:rPr sz="2800" b="1" i="0">
-                <a:solidFill>
-                  <a:srgbClr val="2C5F2D"/>
-                </a:solidFill>
-                <a:latin typeface="Cambria"/>
-              </a:rPr>
-              <a:t>The Garden Exercise — Whole Room, then pairs</a:t>
-            </a:r>
-          </a:p>
-        </p:txBody>
-      </p:sp>
-      <p:sp>
-        <p:nvSpPr>
-          <p:cNvPr id="4" name="TextBox 4"/>
-          <p:cNvSpPr txBox="1"/>
-          <p:nvPr/>
-        </p:nvSpPr>
-        <p:spPr>
-          <a:xfrm>
-            <a:off x="822960" y="1554480"/>
-            <a:ext cx="10515600" cy="4892040"/>
-          </a:xfrm>
-          <a:prstGeom prst="rect">
-            <a:avLst/>
-          </a:prstGeom>
-          <a:noFill/>
-        </p:spPr>
-        <p:txBody>
-          <a:bodyPr wrap="square" lIns="91440" tIns="91440" rIns="91440" bIns="91440"/>
-          <a:lstStyle/>
-          <a:p>
-            <a:pPr marL="342900" indent="-342900">
-              <a:spcAft>
-                <a:spcPts val="750"/>
-              </a:spcAft>
-            </a:pPr>
-            <a:r>
-              <a:rPr sz="2200" b="1" i="0">
-                <a:solidFill>
-                  <a:srgbClr val="97BC62"/>
-                </a:solidFill>
-                <a:latin typeface="Calibri"/>
-              </a:rPr>
-              <a:t>1   </a:t>
-            </a:r>
-            <a:r>
-              <a:rPr sz="2200" b="0" i="0">
-                <a:solidFill>
-                  <a:srgbClr val="222B22"/>
-                </a:solidFill>
-                <a:latin typeface="Calibri"/>
-              </a:rPr>
-              <a:t>Settle (2 min) — “Take a breath. Settle. Eyes open or closed. Whatever feels honest. We have time.”</a:t>
-            </a:r>
-          </a:p>
-          <a:p>
-            <a:pPr marL="342900" indent="-342900">
-              <a:spcAft>
-                <a:spcPts val="750"/>
-              </a:spcAft>
-            </a:pPr>
-            <a:r>
-              <a:rPr sz="2200" b="1" i="0">
-                <a:solidFill>
-                  <a:srgbClr val="97BC62"/>
-                </a:solidFill>
-                <a:latin typeface="Calibri"/>
-              </a:rPr>
-              <a:t>2   </a:t>
-            </a:r>
-            <a:r>
-              <a:rPr sz="2200" b="0" i="0">
-                <a:solidFill>
-                  <a:srgbClr val="222B22"/>
-                </a:solidFill>
-                <a:latin typeface="Calibri"/>
-              </a:rPr>
-              <a:t>Guided prayer (12–15 min) — a senior reads, two words per second; the pauses are not optional — they are where the work happens</a:t>
-            </a:r>
-          </a:p>
-          <a:p>
-            <a:pPr marL="342900" indent="-342900">
-              <a:spcAft>
-                <a:spcPts val="750"/>
-              </a:spcAft>
-            </a:pPr>
-            <a:r>
-              <a:rPr sz="2200" b="1" i="0">
-                <a:solidFill>
-                  <a:srgbClr val="97BC62"/>
-                </a:solidFill>
-                <a:latin typeface="Calibri"/>
-              </a:rPr>
-              <a:t>3   </a:t>
-            </a:r>
-            <a:r>
-              <a:rPr sz="2200" b="0" i="0">
-                <a:solidFill>
-                  <a:srgbClr val="222B22"/>
-                </a:solidFill>
-                <a:latin typeface="Calibri"/>
-              </a:rPr>
-              <a:t>Silent journaling (5 min) — “Write in your Week 9 journal page what you noticed. Whatever you noticed.”</a:t>
-            </a:r>
-          </a:p>
-          <a:p>
-            <a:pPr marL="342900" indent="-342900">
-              <a:spcAft>
-                <a:spcPts val="750"/>
-              </a:spcAft>
-            </a:pPr>
-            <a:r>
-              <a:rPr sz="2200" b="1" i="0">
-                <a:solidFill>
-                  <a:srgbClr val="97BC62"/>
-                </a:solidFill>
-                <a:latin typeface="Calibri"/>
-              </a:rPr>
-              <a:t>4   </a:t>
-            </a:r>
-            <a:r>
-              <a:rPr sz="2200" b="0" i="0">
-                <a:solidFill>
-                  <a:srgbClr val="222B22"/>
-                </a:solidFill>
-                <a:latin typeface="Calibri"/>
-              </a:rPr>
-              <a:t>Sharing in pairs (8–10 min) — by invitation only; a parent opens; silence is a complete answer</a:t>
-            </a:r>
-          </a:p>
-          <a:p>
-            <a:pPr marL="274320" indent="-274320">
-              <a:spcAft>
-                <a:spcPts val="750"/>
-              </a:spcAft>
-            </a:pPr>
-            <a:r>
-              <a:rPr sz="2200" b="1" i="0">
-                <a:solidFill>
-                  <a:srgbClr val="97BC62"/>
-                </a:solidFill>
-                <a:latin typeface="Calibri"/>
-              </a:rPr>
-              <a:t>•  </a:t>
-            </a:r>
-            <a:r>
-              <a:rPr sz="2200" b="0" i="0">
-                <a:solidFill>
-                  <a:srgbClr val="222B22"/>
-                </a:solidFill>
-                <a:latin typeface="Calibri"/>
-              </a:rPr>
-              <a:t>Receive without interpreting — “Thank you for sharing that.” Never “God was telling you _____.”</a:t>
-            </a:r>
-          </a:p>
-          <a:p>
-            <a:pPr marL="274320" indent="-274320">
-              <a:spcAft>
-                <a:spcPts val="750"/>
-              </a:spcAft>
-            </a:pPr>
-            <a:r>
-              <a:rPr sz="2200" b="1" i="0">
-                <a:solidFill>
-                  <a:srgbClr val="97BC62"/>
-                </a:solidFill>
-                <a:latin typeface="Calibri"/>
-              </a:rPr>
-              <a:t>•  </a:t>
-            </a:r>
-            <a:r>
-              <a:rPr sz="2200" b="0" i="0">
-                <a:solidFill>
-                  <a:srgbClr val="222B22"/>
-                </a:solidFill>
-                <a:latin typeface="Calibri"/>
-              </a:rPr>
-              <a:t>If something painful surfaces — bless it: “I hear that. May Jesus stay with you in that place this week.”</a:t>
-            </a:r>
-          </a:p>
-        </p:txBody>
-      </p:sp>
-      <p:sp>
-        <p:nvSpPr>
-          <p:cNvPr id="90" name="SlideNum"/>
-          <p:cNvSpPr txBox="1"/>
-          <p:nvPr/>
-        </p:nvSpPr>
-        <p:spPr>
-          <a:xfrm>
-            <a:off x="11384280" y="6446520"/>
-            <a:ext cx="640080" cy="292608"/>
-          </a:xfrm>
-          <a:prstGeom prst="rect">
-            <a:avLst/>
-          </a:prstGeom>
-          <a:noFill/>
-        </p:spPr>
-        <p:txBody>
-          <a:bodyPr wrap="none" lIns="0" tIns="0" rIns="45720" bIns="0" anchor="ctr"/>
-          <a:lstStyle/>
-          <a:p>
-            <a:pPr algn="r"/>
-            <a:r>
-              <a:t>G11</a:t>
-            </a:r>
-            <a:endParaRPr sz="1000" b="1">
-              <a:solidFill>
-                <a:srgbClr val="7A8A6E"/>
-              </a:solidFill>
-              <a:latin typeface="Calibri"/>
-            </a:endParaRPr>
-          </a:p>
-        </p:txBody>
-      </p:sp>
     </p:spTree>
   </p:cSld>
   <p:clrMapOvr>

</xml_diff>

<commit_message>
v2.32 (John's word, 13 October): Sessions 9-10 garden checked against the Four Connects process
Relaxation before each round (breath, toes up, present to the great I AM;
back to the relaxed place for round two); write what you saw, heard,
smelled or felt; round two open as in the Four Connects (invite, permission
to do or say anything he wishes, about five minutes of silence); the merge
asks what changed with Jesus in the garden, each reading their own images;
the close asks "What will you do or say differently?". Slides, leader notes,
Reading Card and run sheet updated; garden keeps 7:35-8:07.

Co-Authored-By: Claude Opus 5.5 <noreply@anthropic.com>
</commit_message>
<xml_diff>
--- a/_implementation-notes/evening-series/FotH Evening Session 9-10 Combined Slides DRAFT v1.pptx
+++ b/_implementation-notes/evening-series/FotH Evening Session 9-10 Combined Slides DRAFT v1.pptx
@@ -1134,7 +1134,7 @@
           </a:p>
           <a:p>
             <a:r>
-              <a:t>BEATS: 1. Settle, 1 minute. 2. ROUND ONE — the reader reads Round One of the Garden Reading Card: picture your heart as a garden, walk in, notice. Two words per second, not three; every (pause) is a full 30 seconds, every (longer pause) 60 — the pauses are where the work happens. About 5 minutes. Jesus is not invited yet; this round is only the garden. 3. Write, 3 minutes: 'What does your garden look like? What is growing; what feels alive, what feels closed?' 4. Share in pairs, 4 minutes, by invitation: the arranged parent opens — receive without interpreting.</a:t>
+              <a:t>BEATS: 1. Pens and journals ready beforehand, then set aside. 2. RELAX, 2 minutes — the reader reads the Settle section of the Reading Card: breath focus, in and out, then relaxing from the toes up, stage by stage; relaxed and present, and so present to the great I AM. 3. ROUND ONE, about 4 minutes: picture your heart as a garden; let it sit a minute; make it clearer — the light, the temperature, the time of day; another minute; then come back to here. Two words per second; the pauses are where the work happens. Jesus is not invited yet. 4. Write, 3 minutes: what did you see, hear, smell, or feel there? 5. Share in pairs, 4 minutes, by invitation: the arranged parent opens — receive without interpreting.</a:t>
             </a:r>
           </a:p>
           <a:p>
@@ -1149,7 +1149,7 @@
           </a:p>
           <a:p>
             <a:r>
-              <a:t>COMBINED FORM: a Companion-in-Formation reads from the Garden Reading Card (pacing as H10.1: two words per second, (pause) = 30 seconds, (longer pause) = 60); the adults hold the sharing and anything that surfaces. The bright line governs throughout.</a:t>
+              <a:t>FROM: the Four Connects deck (FotH, September 2025), 'Garden of the Heart': prepare to write, relaxation to get present to the great I AM, the garden, record, share.</a:t>
             </a:r>
           </a:p>
         </p:txBody>
@@ -1200,12 +1200,17 @@
           </a:p>
           <a:p>
             <a:r>
-              <a:t>BEATS: 1. The room will be quieter than usual — honor it; wait before speaking. 2. What happened in the pairs stays there; ask only one word about today — 'surprised', 'tender', 'empty', 'found', 'quiet'. 3. Receive each word with eye contact and a slight nod; say nothing else. 4. Close: whatever happened today is yours; some of it will quietly do its work for a long time.</a:t>
+              <a:t>BEATS: 1. The room will be quieter than usual — honor it; wait before speaking. What happened in the pairs stays there. 2. The comparison, about 4 minutes, whole room, by invitation: 'Were there any differences between the garden and the garden with Jesus in it? What did they look like? What might your images tell you about yourself? About Jesus with you and in you?' Take one or two; time decides. 3. Each person reads their own images; no one interprets anyone else's. Receive with 'Thank you.' 4. Then one word about tonight, about 2 minutes — 'surprised', 'tender', 'empty', 'found', 'quiet' — received with a nod, nothing else. Close: whatever happened tonight is yours; some of it will keep happening across the week.</a:t>
             </a:r>
           </a:p>
           <a:p>
             <a:r>
               <a:t>CUES: Arranged parent begins; anyone may pass.</a:t>
+            </a:r>
+          </a:p>
+          <a:p>
+            <a:r>
+              <a:t>FROM: the Four Connects deck (FotH, September 2025), 'Garden of the Heart': after the small groups, ask if anyone wants to share — the differences, and what the images tell you.</a:t>
             </a:r>
           </a:p>
         </p:txBody>
@@ -1363,7 +1368,7 @@
           </a:p>
           <a:p>
             <a:r>
-              <a:t>BEATS: 1. 'What happened in your pair is yours. Carry it gently — don't debrief it on the way home unless your heart is fully ready.' 2. If something heavy surfaced, reach out — the team is walking with you. 3. Aaronic blessing; see you evenings.</a:t>
+              <a:t>BEATS: 0. Step 4 tonight asks the Four Connects impact question: 'What will you do or say differently?' — one sentence, committed aloud. 1. 'What happened in your pair is yours. Carry it gently — don't debrief it on the way home unless your heart is fully ready.' 2. If something heavy surfaced, reach out — the team is walking with you. 3. Aaronic blessing; see you evenings.</a:t>
             </a:r>
           </a:p>
           <a:p>
@@ -1764,7 +1769,7 @@
           </a:p>
           <a:p>
             <a:r>
-              <a:t>BEATS: 1. ROUND TWO — the reader reads Round Two of the Garden Reading Card: go back to the garden; Jesus is at the entrance; invite him in and give him permission to do or say anything he wishes; watch where he goes and what he does; listen for a word; then return — thank him, tell him you will be back, open your eyes. About 8 minutes with the pauses. 2. Write, 4 minutes: what did he do, where did he go, did he say anything? 'Nothing happened' is honest. 3. Share in pairs, 6 minutes, by invitation: the Companion models two plain sentences first, the arranged parent opens — receive without interpreting; never 'God was telling you...'. Notice, don't conclude: the returns are for testing.</a:t>
+              <a:t>BEATS: 1. Take them back to the relaxed state, 1 minute: breathe, relax, picture the garden again. 2. ROUND TWO: invite Jesus in; give him permission to do or say anything he wishes; ask him to do or say whatever he wants. Then the reader stops talking and holds the silence for about five minutes. Do not fill it; watch the clock, not the faces' patience. Then: 'When you are ready, come back to here, and open your eyes.' 3. Write, 4 minutes: what did you see, hear, smell, or feel? What did he do or say? 'Nothing happened' is honest. Everyone writes before anyone shares. 4. Share in pairs, 6 minutes, by invitation: the Companion models two plain sentences first, the arranged parent opens — receive without interpreting; never 'God was telling you...'. Notice, don't conclude: the returns are for testing.</a:t>
             </a:r>
           </a:p>
           <a:p>
@@ -1779,7 +1784,7 @@
           </a:p>
           <a:p>
             <a:r>
-              <a:t>FROM: the Four Connects deck (FotH, September 2025), 'Hearing God — The How': invite in Jesus, give him permission to do his thing; share with the group.</a:t>
+              <a:t>FROM: the Four Connects deck (FotH, September 2025), 'Garden of the Heart': take them back to that relaxed state; picture the heart again; invite Jesus in; suggest they ask him to do or say whatever he wants; let it sit a few minutes; return and record; then share.</a:t>
             </a:r>
           </a:p>
         </p:txBody>
@@ -5142,7 +5147,7 @@
                 </a:solidFill>
                 <a:latin typeface="Calibri"/>
               </a:rPr>
-              <a:t>Round one: picture your heart as a garden — then write, then share</a:t>
+              <a:t>Round one: relax, then picture your heart as a garden — then write, then share</a:t>
             </a:r>
           </a:p>
           <a:p>
@@ -5414,7 +5419,7 @@
                 </a:solidFill>
                 <a:latin typeface="Calibri"/>
               </a:rPr>
-              <a:t>Settle (1 min) — “Take a breath. Eyes open or closed. Whatever feels honest. We have time.”</a:t>
+              <a:t>Relax (2 min) — breathe in, breathe out; relax from your toes up; be present to the great I AM</a:t>
             </a:r>
           </a:p>
           <a:p>
@@ -5439,7 +5444,7 @@
                 </a:solidFill>
                 <a:latin typeface="Calibri"/>
               </a:rPr>
-              <a:t>Imagine (5 min) — picture your heart as a garden and walk in: what is growing, the weather, the light, the season; what feels alive, what feels closed</a:t>
+              <a:t>Imagine (4 min) — picture your heart as a garden and let it sit; then make it clearer: the light, the temperature, the time of day</a:t>
             </a:r>
           </a:p>
           <a:p>
@@ -5464,7 +5469,7 @@
                 </a:solidFill>
                 <a:latin typeface="Calibri"/>
               </a:rPr>
-              <a:t>Write (3 min) — what does your garden look like?</a:t>
+              <a:t>Write (3 min) — what did you see, hear, smell, or feel there?</a:t>
             </a:r>
           </a:p>
           <a:p>
@@ -5586,6 +5591,321 @@
 </file>
 
 <file path=ppt/slides/slide12.xml><?xml version="1.0" encoding="utf-8"?>
+<p:sld xmlns:a="http://schemas.openxmlformats.org/drawingml/2006/main" xmlns:p="http://schemas.openxmlformats.org/presentationml/2006/main" xmlns:r="http://schemas.openxmlformats.org/officeDocument/2006/relationships">
+  <p:cSld>
+    <p:spTree>
+      <p:nvGrpSpPr>
+        <p:cNvPr id="1" name=""/>
+        <p:cNvGrpSpPr/>
+        <p:nvPr/>
+      </p:nvGrpSpPr>
+      <p:grpSpPr/>
+      <p:sp>
+        <p:nvSpPr>
+          <p:cNvPr id="2" name="Rectangle 1"/>
+          <p:cNvSpPr/>
+          <p:nvPr/>
+        </p:nvSpPr>
+        <p:spPr>
+          <a:xfrm>
+            <a:off x="0" y="0"/>
+            <a:ext cx="12191695" cy="6858000"/>
+          </a:xfrm>
+          <a:prstGeom prst="rect">
+            <a:avLst/>
+          </a:prstGeom>
+          <a:solidFill>
+            <a:srgbClr val="FFFFFF"/>
+          </a:solidFill>
+          <a:ln>
+            <a:noFill/>
+          </a:ln>
+        </p:spPr>
+        <p:txBody>
+          <a:bodyPr/>
+          <a:lstStyle/>
+          <a:p>
+            <a:endParaRPr/>
+          </a:p>
+        </p:txBody>
+      </p:sp>
+      <p:sp>
+        <p:nvSpPr>
+          <p:cNvPr id="3" name="TextBox 2"/>
+          <p:cNvSpPr txBox="1"/>
+          <p:nvPr/>
+        </p:nvSpPr>
+        <p:spPr>
+          <a:xfrm>
+            <a:off x="822960" y="502920"/>
+            <a:ext cx="10515600" cy="822960"/>
+          </a:xfrm>
+          <a:prstGeom prst="rect">
+            <a:avLst/>
+          </a:prstGeom>
+          <a:noFill/>
+        </p:spPr>
+        <p:txBody>
+          <a:bodyPr wrap="square">
+            <a:spAutoFit/>
+          </a:bodyPr>
+          <a:lstStyle/>
+          <a:p>
+            <a:pPr algn="l">
+              <a:spcAft>
+                <a:spcPts val="600"/>
+              </a:spcAft>
+            </a:pPr>
+            <a:r>
+              <a:rPr sz="2800" b="1" i="0">
+                <a:solidFill>
+                  <a:srgbClr val="2C5F2D"/>
+                </a:solidFill>
+                <a:latin typeface="Cambria"/>
+              </a:rPr>
+              <a:t>The Garden — Round Two: Invite Jesus In</a:t>
+            </a:r>
+          </a:p>
+        </p:txBody>
+      </p:sp>
+      <p:sp>
+        <p:nvSpPr>
+          <p:cNvPr id="4" name="TextBox 4"/>
+          <p:cNvSpPr txBox="1"/>
+          <p:nvPr/>
+        </p:nvSpPr>
+        <p:spPr>
+          <a:xfrm>
+            <a:off x="822960" y="1554480"/>
+            <a:ext cx="10515600" cy="4892040"/>
+          </a:xfrm>
+          <a:prstGeom prst="rect">
+            <a:avLst/>
+          </a:prstGeom>
+          <a:noFill/>
+        </p:spPr>
+        <p:txBody>
+          <a:bodyPr wrap="square" lIns="91440" tIns="91440" rIns="91440" bIns="91440"/>
+          <a:lstStyle/>
+          <a:p>
+            <a:pPr marL="342900" indent="-342900">
+              <a:spcAft>
+                <a:spcPts val="750"/>
+              </a:spcAft>
+            </a:pPr>
+            <a:r>
+              <a:rPr sz="2000" b="1" i="0">
+                <a:solidFill>
+                  <a:srgbClr val="97BC62"/>
+                </a:solidFill>
+                <a:latin typeface="Calibri"/>
+              </a:rPr>
+              <a:t>1   </a:t>
+            </a:r>
+            <a:r>
+              <a:rPr sz="2000" b="0" i="0">
+                <a:solidFill>
+                  <a:srgbClr val="222B22"/>
+                </a:solidFill>
+                <a:latin typeface="Calibri"/>
+              </a:rPr>
+              <a:t>Go back to that relaxed place (1 min) — and picture your garden again</a:t>
+            </a:r>
+          </a:p>
+          <a:p>
+            <a:pPr marL="342900" indent="-342900">
+              <a:spcAft>
+                <a:spcPts val="750"/>
+              </a:spcAft>
+            </a:pPr>
+            <a:r>
+              <a:rPr sz="2000" b="1" i="0">
+                <a:solidFill>
+                  <a:srgbClr val="97BC62"/>
+                </a:solidFill>
+                <a:latin typeface="Calibri"/>
+              </a:rPr>
+              <a:t>2   </a:t>
+            </a:r>
+            <a:r>
+              <a:rPr sz="2000" b="0" i="0">
+                <a:solidFill>
+                  <a:srgbClr val="222B22"/>
+                </a:solidFill>
+                <a:latin typeface="Calibri"/>
+              </a:rPr>
+              <a:t>Invite Jesus in (8 min) — give him permission to do or say anything he wishes; then let it sit, in silence</a:t>
+            </a:r>
+          </a:p>
+          <a:p>
+            <a:pPr marL="342900" indent="-342900">
+              <a:spcAft>
+                <a:spcPts val="750"/>
+              </a:spcAft>
+            </a:pPr>
+            <a:r>
+              <a:rPr sz="2000" b="1" i="0">
+                <a:solidFill>
+                  <a:srgbClr val="97BC62"/>
+                </a:solidFill>
+                <a:latin typeface="Calibri"/>
+              </a:rPr>
+              <a:t>3   </a:t>
+            </a:r>
+            <a:r>
+              <a:rPr sz="2000" b="0" i="0">
+                <a:solidFill>
+                  <a:srgbClr val="222B22"/>
+                </a:solidFill>
+                <a:latin typeface="Calibri"/>
+              </a:rPr>
+              <a:t>Return — come back to here; open your eyes when you are ready</a:t>
+            </a:r>
+          </a:p>
+          <a:p>
+            <a:pPr marL="342900" indent="-342900">
+              <a:spcAft>
+                <a:spcPts val="750"/>
+              </a:spcAft>
+            </a:pPr>
+            <a:r>
+              <a:rPr sz="2000" b="1" i="0">
+                <a:solidFill>
+                  <a:srgbClr val="97BC62"/>
+                </a:solidFill>
+                <a:latin typeface="Calibri"/>
+              </a:rPr>
+              <a:t>4   </a:t>
+            </a:r>
+            <a:r>
+              <a:rPr sz="2000" b="0" i="0">
+                <a:solidFill>
+                  <a:srgbClr val="222B22"/>
+                </a:solidFill>
+                <a:latin typeface="Calibri"/>
+              </a:rPr>
+              <a:t>Write (4 min) — what did you see, hear, smell, or feel? What did he do or say? “Nothing happened” is honest</a:t>
+            </a:r>
+          </a:p>
+          <a:p>
+            <a:pPr marL="342900" indent="-342900">
+              <a:spcAft>
+                <a:spcPts val="750"/>
+              </a:spcAft>
+            </a:pPr>
+            <a:r>
+              <a:rPr sz="2000" b="1" i="0">
+                <a:solidFill>
+                  <a:srgbClr val="97BC62"/>
+                </a:solidFill>
+                <a:latin typeface="Calibri"/>
+              </a:rPr>
+              <a:t>5   </a:t>
+            </a:r>
+            <a:r>
+              <a:rPr sz="2000" b="0" i="0">
+                <a:solidFill>
+                  <a:srgbClr val="222B22"/>
+                </a:solidFill>
+                <a:latin typeface="Calibri"/>
+              </a:rPr>
+              <a:t>Share in pairs (6 min) — by invitation only; a parent opens; silence is a complete answer</a:t>
+            </a:r>
+          </a:p>
+          <a:p>
+            <a:pPr marL="342900" indent="-342900">
+              <a:spcAft>
+                <a:spcPts val="750"/>
+              </a:spcAft>
+            </a:pPr>
+            <a:r>
+              <a:rPr sz="2000" b="1" i="0">
+                <a:solidFill>
+                  <a:srgbClr val="97BC62"/>
+                </a:solidFill>
+                <a:latin typeface="Calibri"/>
+              </a:rPr>
+              <a:t>•  </a:t>
+            </a:r>
+            <a:r>
+              <a:rPr sz="2000" b="0" i="0">
+                <a:solidFill>
+                  <a:srgbClr val="222B22"/>
+                </a:solidFill>
+                <a:latin typeface="Calibri"/>
+              </a:rPr>
+              <a:t>Never “God was telling you _____.” Notice, don’t conclude — the returns are for testing</a:t>
+            </a:r>
+          </a:p>
+          <a:p>
+            <a:pPr marL="342900" indent="-342900">
+              <a:spcAft>
+                <a:spcPts val="750"/>
+              </a:spcAft>
+            </a:pPr>
+            <a:r>
+              <a:rPr sz="2000" b="1" i="0">
+                <a:solidFill>
+                  <a:srgbClr val="97BC62"/>
+                </a:solidFill>
+                <a:latin typeface="Calibri"/>
+              </a:rPr>
+              <a:t>•  </a:t>
+            </a:r>
+            <a:r>
+              <a:rPr sz="2000" b="0" i="0">
+                <a:solidFill>
+                  <a:srgbClr val="222B22"/>
+                </a:solidFill>
+                <a:latin typeface="Calibri"/>
+              </a:rPr>
+              <a:t>If something painful surfaces — bless it: “I hear that. May Jesus stay with you in that place this week.”</a:t>
+            </a:r>
+          </a:p>
+        </p:txBody>
+      </p:sp>
+      <p:sp>
+        <p:nvSpPr>
+          <p:cNvPr id="90" name="SlideNum"/>
+          <p:cNvSpPr txBox="1"/>
+          <p:nvPr/>
+        </p:nvSpPr>
+        <p:spPr>
+          <a:xfrm>
+            <a:off x="11384280" y="6446520"/>
+            <a:ext cx="640080" cy="292608"/>
+          </a:xfrm>
+          <a:prstGeom prst="rect">
+            <a:avLst/>
+          </a:prstGeom>
+          <a:noFill/>
+        </p:spPr>
+        <p:txBody>
+          <a:bodyPr wrap="none" lIns="0" tIns="0" rIns="45720" bIns="0" anchor="ctr"/>
+          <a:lstStyle/>
+          <a:p>
+            <a:pPr algn="r"/>
+            <a:r>
+              <a:t>G12</a:t>
+            </a:r>
+            <a:endParaRPr sz="1000" b="1">
+              <a:solidFill>
+                <a:srgbClr val="7A8A6E"/>
+              </a:solidFill>
+              <a:latin typeface="Calibri"/>
+            </a:endParaRPr>
+          </a:p>
+        </p:txBody>
+      </p:sp>
+    </p:spTree>
+  </p:cSld>
+  <p:clrMapOvr>
+    <a:masterClrMapping/>
+  </p:clrMapOvr>
+</p:sld>
+</file>
+
+<file path=ppt/slides/slide13.xml><?xml version="1.0" encoding="utf-8"?>
 <p:sld xmlns:a="http://schemas.openxmlformats.org/drawingml/2006/main" xmlns:r="http://schemas.openxmlformats.org/officeDocument/2006/relationships" xmlns:p="http://schemas.openxmlformats.org/presentationml/2006/main">
   <p:cSld>
     <p:spTree>
@@ -5665,7 +5985,7 @@
                 </a:solidFill>
                 <a:latin typeface="Cambria"/>
               </a:rPr>
-              <a:t>Merge and One-Word Landing</a:t>
+              <a:t>Merge — the Garden, and the Garden with Jesus in It</a:t>
             </a:r>
           </a:p>
         </p:txBody>
@@ -5696,7 +6016,7 @@
               </a:spcAft>
             </a:pPr>
             <a:r>
-              <a:rPr sz="2800" b="1" i="0">
+              <a:rPr sz="2400" b="1" i="0">
                 <a:solidFill>
                   <a:srgbClr val="97BC62"/>
                 </a:solidFill>
@@ -5705,7 +6025,7 @@
               <a:t>•  </a:t>
             </a:r>
             <a:r>
-              <a:rPr sz="2800" b="0" i="0">
+              <a:rPr sz="2400" b="0" i="0">
                 <a:solidFill>
                   <a:srgbClr val="222B22"/>
                 </a:solidFill>
@@ -5721,7 +6041,7 @@
               </a:spcAft>
             </a:pPr>
             <a:r>
-              <a:rPr sz="2800" b="1" i="0">
+              <a:rPr sz="2400" b="1" i="0">
                 <a:solidFill>
                   <a:srgbClr val="97BC62"/>
                 </a:solidFill>
@@ -5730,38 +6050,38 @@
               <a:t>•  </a:t>
             </a:r>
             <a:r>
-              <a:rPr sz="2800" b="0" i="0">
+              <a:rPr sz="2400" b="0" i="0">
                 <a:solidFill>
                   <a:srgbClr val="222B22"/>
                 </a:solidFill>
                 <a:latin typeface="Calibri"/>
               </a:rPr>
-              <a:t>One word about tonight — not what was said, but what you noticed</a:t>
-            </a:r>
-          </a:p>
-          <a:p>
-            <a:pPr marL="685800" indent="-274320">
-              <a:spcAft>
-                <a:spcPts val="700"/>
-              </a:spcAft>
-            </a:pPr>
-            <a:r>
-              <a:rPr sz="2000" b="1" i="0">
+              <a:t>Any differences between the garden and the garden with Jesus in it? What did they look like?</a:t>
+            </a:r>
+          </a:p>
+          <a:p>
+            <a:pPr marL="274320" indent="-274320">
+              <a:spcAft>
+                <a:spcPts val="900"/>
+              </a:spcAft>
+            </a:pPr>
+            <a:r>
+              <a:rPr sz="2400" b="1" i="0">
                 <a:solidFill>
                   <a:srgbClr val="97BC62"/>
                 </a:solidFill>
                 <a:latin typeface="Calibri"/>
               </a:rPr>
-              <a:t>–  </a:t>
-            </a:r>
-            <a:r>
-              <a:rPr sz="2000" b="0" i="1">
+              <a:t>•  </a:t>
+            </a:r>
+            <a:r>
+              <a:rPr sz="2400" b="0" i="0">
                 <a:solidFill>
                   <a:srgbClr val="222B22"/>
                 </a:solidFill>
                 <a:latin typeface="Calibri"/>
               </a:rPr>
-              <a:t>“Surprised.” “Tender.” “Empty.” “Found.” “Confused.” “Quiet.”</a:t>
+              <a:t>What might your images tell you about yourself? About Jesus with you and in you?</a:t>
             </a:r>
           </a:p>
           <a:p>
@@ -5771,7 +6091,7 @@
               </a:spcAft>
             </a:pPr>
             <a:r>
-              <a:rPr sz="2800" b="1" i="0">
+              <a:rPr sz="2400" b="1" i="0">
                 <a:solidFill>
                   <a:srgbClr val="97BC62"/>
                 </a:solidFill>
@@ -5780,13 +6100,13 @@
               <a:t>•  </a:t>
             </a:r>
             <a:r>
-              <a:rPr sz="2800" b="0" i="0">
+              <a:rPr sz="2400" b="0" i="0">
                 <a:solidFill>
                   <a:srgbClr val="222B22"/>
                 </a:solidFill>
                 <a:latin typeface="Calibri"/>
               </a:rPr>
-              <a:t>A parent begins; anyone may pass — each word received without commentary</a:t>
+              <a:t>Each of us reads our own images — no one interprets anyone else’s</a:t>
             </a:r>
           </a:p>
           <a:p>
@@ -5796,7 +6116,7 @@
               </a:spcAft>
             </a:pPr>
             <a:r>
-              <a:rPr sz="2800" b="1" i="0">
+              <a:rPr sz="2400" b="1" i="0">
                 <a:solidFill>
                   <a:srgbClr val="97BC62"/>
                 </a:solidFill>
@@ -5805,13 +6125,13 @@
               <a:t>•  </a:t>
             </a:r>
             <a:r>
-              <a:rPr sz="2800" b="0" i="0">
+              <a:rPr sz="2400" b="0" i="0">
                 <a:solidFill>
                   <a:srgbClr val="222B22"/>
                 </a:solidFill>
                 <a:latin typeface="Calibri"/>
               </a:rPr>
-              <a:t>“Whatever happened tonight is yours. Some of it will keep happening across the week.”</a:t>
+              <a:t>Then one word about tonight — a parent begins; anyone may pass</a:t>
             </a:r>
           </a:p>
         </p:txBody>
@@ -5857,7 +6177,7 @@
 </p:sld>
 </file>
 
-<file path=ppt/slides/slide13.xml><?xml version="1.0" encoding="utf-8"?>
+<file path=ppt/slides/slide14.xml><?xml version="1.0" encoding="utf-8"?>
 <p:sld xmlns:a="http://schemas.openxmlformats.org/drawingml/2006/main" xmlns:r="http://schemas.openxmlformats.org/officeDocument/2006/relationships" xmlns:p="http://schemas.openxmlformats.org/presentationml/2006/main">
   <p:cSld>
     <p:spTree>
@@ -6215,7 +6535,7 @@
 </p:sld>
 </file>
 
-<file path=ppt/slides/slide14.xml><?xml version="1.0" encoding="utf-8"?>
+<file path=ppt/slides/slide15.xml><?xml version="1.0" encoding="utf-8"?>
 <p:sld xmlns:a="http://schemas.openxmlformats.org/drawingml/2006/main" xmlns:p="http://schemas.openxmlformats.org/presentationml/2006/main" xmlns:r="http://schemas.openxmlformats.org/officeDocument/2006/relationships">
   <p:cSld>
     <p:spTree>
@@ -6407,7 +6727,7 @@
 </p:sld>
 </file>
 
-<file path=ppt/slides/slide15.xml><?xml version="1.0" encoding="utf-8"?>
+<file path=ppt/slides/slide16.xml><?xml version="1.0" encoding="utf-8"?>
 <p:sld xmlns:a="http://schemas.openxmlformats.org/drawingml/2006/main" xmlns:p="http://schemas.openxmlformats.org/presentationml/2006/main" xmlns:r="http://schemas.openxmlformats.org/officeDocument/2006/relationships">
   <p:cSld>
     <p:spTree>
@@ -6599,7 +6919,7 @@
 </p:sld>
 </file>
 
-<file path=ppt/slides/slide16.xml><?xml version="1.0" encoding="utf-8"?>
+<file path=ppt/slides/slide17.xml><?xml version="1.0" encoding="utf-8"?>
 <p:sld xmlns:a="http://schemas.openxmlformats.org/drawingml/2006/main" xmlns:r="http://schemas.openxmlformats.org/officeDocument/2006/relationships" xmlns:p="http://schemas.openxmlformats.org/presentationml/2006/main">
   <p:cSld>
     <p:spTree>
@@ -6932,7 +7252,7 @@
 </p:sld>
 </file>
 
-<file path=ppt/slides/slide17.xml><?xml version="1.0" encoding="utf-8"?>
+<file path=ppt/slides/slide18.xml><?xml version="1.0" encoding="utf-8"?>
 <p:sld xmlns:a="http://schemas.openxmlformats.org/drawingml/2006/main" xmlns:r="http://schemas.openxmlformats.org/officeDocument/2006/relationships" xmlns:p="http://schemas.openxmlformats.org/presentationml/2006/main">
   <p:cSld>
     <p:spTree>
@@ -7158,7 +7478,7 @@
                 </a:solidFill>
                 <a:latin typeface="Calibri"/>
               </a:rPr>
-              <a:t>The one practice — committed aloud, or modified to one you will actually keep</a:t>
+              <a:t>What will you do or say differently? — the one practice, committed aloud</a:t>
             </a:r>
           </a:p>
           <a:p>
@@ -7323,321 +7643,6 @@
             <a:pPr algn="r"/>
             <a:r>
               <a:t>G18</a:t>
-            </a:r>
-            <a:endParaRPr sz="1000" b="1">
-              <a:solidFill>
-                <a:srgbClr val="7A8A6E"/>
-              </a:solidFill>
-              <a:latin typeface="Calibri"/>
-            </a:endParaRPr>
-          </a:p>
-        </p:txBody>
-      </p:sp>
-    </p:spTree>
-  </p:cSld>
-  <p:clrMapOvr>
-    <a:masterClrMapping/>
-  </p:clrMapOvr>
-</p:sld>
-</file>
-
-<file path=ppt/slides/slide18.xml><?xml version="1.0" encoding="utf-8"?>
-<p:sld xmlns:a="http://schemas.openxmlformats.org/drawingml/2006/main" xmlns:p="http://schemas.openxmlformats.org/presentationml/2006/main" xmlns:r="http://schemas.openxmlformats.org/officeDocument/2006/relationships">
-  <p:cSld>
-    <p:spTree>
-      <p:nvGrpSpPr>
-        <p:cNvPr id="1" name=""/>
-        <p:cNvGrpSpPr/>
-        <p:nvPr/>
-      </p:nvGrpSpPr>
-      <p:grpSpPr/>
-      <p:sp>
-        <p:nvSpPr>
-          <p:cNvPr id="2" name="Rectangle 1"/>
-          <p:cNvSpPr/>
-          <p:nvPr/>
-        </p:nvSpPr>
-        <p:spPr>
-          <a:xfrm>
-            <a:off x="0" y="0"/>
-            <a:ext cx="12191695" cy="6858000"/>
-          </a:xfrm>
-          <a:prstGeom prst="rect">
-            <a:avLst/>
-          </a:prstGeom>
-          <a:solidFill>
-            <a:srgbClr val="FFFFFF"/>
-          </a:solidFill>
-          <a:ln>
-            <a:noFill/>
-          </a:ln>
-        </p:spPr>
-        <p:txBody>
-          <a:bodyPr/>
-          <a:lstStyle/>
-          <a:p>
-            <a:endParaRPr/>
-          </a:p>
-        </p:txBody>
-      </p:sp>
-      <p:sp>
-        <p:nvSpPr>
-          <p:cNvPr id="3" name="TextBox 2"/>
-          <p:cNvSpPr txBox="1"/>
-          <p:nvPr/>
-        </p:nvSpPr>
-        <p:spPr>
-          <a:xfrm>
-            <a:off x="822960" y="502920"/>
-            <a:ext cx="10515600" cy="822960"/>
-          </a:xfrm>
-          <a:prstGeom prst="rect">
-            <a:avLst/>
-          </a:prstGeom>
-          <a:noFill/>
-        </p:spPr>
-        <p:txBody>
-          <a:bodyPr wrap="square">
-            <a:spAutoFit/>
-          </a:bodyPr>
-          <a:lstStyle/>
-          <a:p>
-            <a:pPr algn="l">
-              <a:spcAft>
-                <a:spcPts val="600"/>
-              </a:spcAft>
-            </a:pPr>
-            <a:r>
-              <a:rPr sz="2800" b="1" i="0">
-                <a:solidFill>
-                  <a:srgbClr val="2C5F2D"/>
-                </a:solidFill>
-                <a:latin typeface="Cambria"/>
-              </a:rPr>
-              <a:t>The Garden — Round Two: Invite Jesus In</a:t>
-            </a:r>
-          </a:p>
-        </p:txBody>
-      </p:sp>
-      <p:sp>
-        <p:nvSpPr>
-          <p:cNvPr id="4" name="TextBox 4"/>
-          <p:cNvSpPr txBox="1"/>
-          <p:nvPr/>
-        </p:nvSpPr>
-        <p:spPr>
-          <a:xfrm>
-            <a:off x="822960" y="1554480"/>
-            <a:ext cx="10515600" cy="4892040"/>
-          </a:xfrm>
-          <a:prstGeom prst="rect">
-            <a:avLst/>
-          </a:prstGeom>
-          <a:noFill/>
-        </p:spPr>
-        <p:txBody>
-          <a:bodyPr wrap="square" lIns="91440" tIns="91440" rIns="91440" bIns="91440"/>
-          <a:lstStyle/>
-          <a:p>
-            <a:pPr marL="342900" indent="-342900">
-              <a:spcAft>
-                <a:spcPts val="750"/>
-              </a:spcAft>
-            </a:pPr>
-            <a:r>
-              <a:rPr sz="2000" b="1" i="0">
-                <a:solidFill>
-                  <a:srgbClr val="97BC62"/>
-                </a:solidFill>
-                <a:latin typeface="Calibri"/>
-              </a:rPr>
-              <a:t>1   </a:t>
-            </a:r>
-            <a:r>
-              <a:rPr sz="2000" b="0" i="0">
-                <a:solidFill>
-                  <a:srgbClr val="222B22"/>
-                </a:solidFill>
-                <a:latin typeface="Calibri"/>
-              </a:rPr>
-              <a:t>Go back to your garden — you know the way now</a:t>
-            </a:r>
-          </a:p>
-          <a:p>
-            <a:pPr marL="342900" indent="-342900">
-              <a:spcAft>
-                <a:spcPts val="750"/>
-              </a:spcAft>
-            </a:pPr>
-            <a:r>
-              <a:rPr sz="2000" b="1" i="0">
-                <a:solidFill>
-                  <a:srgbClr val="97BC62"/>
-                </a:solidFill>
-                <a:latin typeface="Calibri"/>
-              </a:rPr>
-              <a:t>2   </a:t>
-            </a:r>
-            <a:r>
-              <a:rPr sz="2000" b="0" i="0">
-                <a:solidFill>
-                  <a:srgbClr val="222B22"/>
-                </a:solidFill>
-                <a:latin typeface="Calibri"/>
-              </a:rPr>
-              <a:t>Invite Jesus in (8 min) — give him permission to do or say anything he wishes; then watch, and listen</a:t>
-            </a:r>
-          </a:p>
-          <a:p>
-            <a:pPr marL="342900" indent="-342900">
-              <a:spcAft>
-                <a:spcPts val="750"/>
-              </a:spcAft>
-            </a:pPr>
-            <a:r>
-              <a:rPr sz="2000" b="1" i="0">
-                <a:solidFill>
-                  <a:srgbClr val="97BC62"/>
-                </a:solidFill>
-                <a:latin typeface="Calibri"/>
-              </a:rPr>
-              <a:t>3   </a:t>
-            </a:r>
-            <a:r>
-              <a:rPr sz="2000" b="0" i="0">
-                <a:solidFill>
-                  <a:srgbClr val="222B22"/>
-                </a:solidFill>
-                <a:latin typeface="Calibri"/>
-              </a:rPr>
-              <a:t>Return — thank him, tell him you will be back, open your eyes</a:t>
-            </a:r>
-          </a:p>
-          <a:p>
-            <a:pPr marL="342900" indent="-342900">
-              <a:spcAft>
-                <a:spcPts val="750"/>
-              </a:spcAft>
-            </a:pPr>
-            <a:r>
-              <a:rPr sz="2000" b="1" i="0">
-                <a:solidFill>
-                  <a:srgbClr val="97BC62"/>
-                </a:solidFill>
-                <a:latin typeface="Calibri"/>
-              </a:rPr>
-              <a:t>4   </a:t>
-            </a:r>
-            <a:r>
-              <a:rPr sz="2000" b="0" i="0">
-                <a:solidFill>
-                  <a:srgbClr val="222B22"/>
-                </a:solidFill>
-                <a:latin typeface="Calibri"/>
-              </a:rPr>
-              <a:t>Write (4 min) — what did he do? Where did he go? Did he say anything? “Nothing happened” is honest</a:t>
-            </a:r>
-          </a:p>
-          <a:p>
-            <a:pPr marL="342900" indent="-342900">
-              <a:spcAft>
-                <a:spcPts val="750"/>
-              </a:spcAft>
-            </a:pPr>
-            <a:r>
-              <a:rPr sz="2000" b="1" i="0">
-                <a:solidFill>
-                  <a:srgbClr val="97BC62"/>
-                </a:solidFill>
-                <a:latin typeface="Calibri"/>
-              </a:rPr>
-              <a:t>5   </a:t>
-            </a:r>
-            <a:r>
-              <a:rPr sz="2000" b="0" i="0">
-                <a:solidFill>
-                  <a:srgbClr val="222B22"/>
-                </a:solidFill>
-                <a:latin typeface="Calibri"/>
-              </a:rPr>
-              <a:t>Share in pairs (6 min) — by invitation only; a parent opens; silence is a complete answer</a:t>
-            </a:r>
-          </a:p>
-          <a:p>
-            <a:pPr marL="342900" indent="-342900">
-              <a:spcAft>
-                <a:spcPts val="750"/>
-              </a:spcAft>
-            </a:pPr>
-            <a:r>
-              <a:rPr sz="2000" b="1" i="0">
-                <a:solidFill>
-                  <a:srgbClr val="97BC62"/>
-                </a:solidFill>
-                <a:latin typeface="Calibri"/>
-              </a:rPr>
-              <a:t>•  </a:t>
-            </a:r>
-            <a:r>
-              <a:rPr sz="2000" b="0" i="0">
-                <a:solidFill>
-                  <a:srgbClr val="222B22"/>
-                </a:solidFill>
-                <a:latin typeface="Calibri"/>
-              </a:rPr>
-              <a:t>Never “God was telling you _____.” Notice, don’t conclude — the returns are for testing</a:t>
-            </a:r>
-          </a:p>
-          <a:p>
-            <a:pPr marL="342900" indent="-342900">
-              <a:spcAft>
-                <a:spcPts val="750"/>
-              </a:spcAft>
-            </a:pPr>
-            <a:r>
-              <a:rPr sz="2000" b="1" i="0">
-                <a:solidFill>
-                  <a:srgbClr val="97BC62"/>
-                </a:solidFill>
-                <a:latin typeface="Calibri"/>
-              </a:rPr>
-              <a:t>•  </a:t>
-            </a:r>
-            <a:r>
-              <a:rPr sz="2000" b="0" i="0">
-                <a:solidFill>
-                  <a:srgbClr val="222B22"/>
-                </a:solidFill>
-                <a:latin typeface="Calibri"/>
-              </a:rPr>
-              <a:t>If something painful surfaces — bless it: “I hear that. May Jesus stay with you in that place this week.”</a:t>
-            </a:r>
-          </a:p>
-        </p:txBody>
-      </p:sp>
-      <p:sp>
-        <p:nvSpPr>
-          <p:cNvPr id="90" name="SlideNum"/>
-          <p:cNvSpPr txBox="1"/>
-          <p:nvPr/>
-        </p:nvSpPr>
-        <p:spPr>
-          <a:xfrm>
-            <a:off x="11384280" y="6446520"/>
-            <a:ext cx="640080" cy="292608"/>
-          </a:xfrm>
-          <a:prstGeom prst="rect">
-            <a:avLst/>
-          </a:prstGeom>
-          <a:noFill/>
-        </p:spPr>
-        <p:txBody>
-          <a:bodyPr wrap="none" lIns="0" tIns="0" rIns="45720" bIns="0" anchor="ctr"/>
-          <a:lstStyle/>
-          <a:p>
-            <a:pPr algn="r"/>
-            <a:r>
-              <a:t>G12</a:t>
             </a:r>
             <a:endParaRPr sz="1000" b="1">
               <a:solidFill>
@@ -8404,7 +8409,7 @@
                 </a:solidFill>
                 <a:latin typeface="Calibri"/>
               </a:rPr>
-              <a:t>Merge and one-word landing</a:t>
+              <a:t>Merge — the two gardens, then one word</a:t>
             </a:r>
           </a:p>
           <a:p>

</xml_diff>

<commit_message>
v2.48: Evening 7's materials carry the long gap (John's word, 2026-10-28) - four-week take-home on one page (weeks 1-4 grid; garden returns, check-in, week two, weeks three and four chosen with why; two preparation sentences); new Practices So Far card (Evenings 1-7); deck G15 The Long Gap, homework slide = weeks one and two, sheet slides re-imaged, close says December 8 (19 slides, leader notes rebuilt); run sheet homework 8:13-8:16, long gap and sheets 8:16-8:21, still two pages; Evening 7 page brought in line with the 13 October design (how did you know, two rounds); sync map adds the card; synced to OneDrive
Co-Authored-By: Claude Opus 5.5 <noreply@anthropic.com>
</commit_message>
<xml_diff>
--- a/_implementation-notes/evening-series/FotH Evening Session 9-10 Combined Slides DRAFT v1.pptx
+++ b/_implementation-notes/evening-series/FotH Evening Session 9-10 Combined Slides DRAFT v1.pptx
@@ -22,6 +22,7 @@
     <p:sldId id="538" r:id="rId26"/>
     <p:sldId id="406" r:id="rId122"/>
     <p:sldId id="407" r:id="rId123"/>
+    <p:sldId id="539" r:id="rId27"/>
     <p:sldId id="534" r:id="rId23"/>
     <p:sldId id="535" r:id="rId24"/>
     <p:sldId id="408" r:id="rId125"/>
@@ -1256,7 +1257,7 @@
           <a:lstStyle/>
           <a:p>
             <a:r>
-              <a:t>E7 · 8:13–8:18 · LEAD: CONTENT PRESENTER</a:t>
+              <a:t>E7 · 8:13–8:16 · LEAD: CONTENT PRESENTER</a:t>
             </a:r>
           </a:p>
           <a:p>
@@ -1267,6 +1268,11 @@
           <a:p>
             <a:r>
               <a:t>COMBINED FORM: say it plainly — the second guided evening lives in the returns now. Five to ten minutes each, journaled; no junior varsity garden: Jesus meets each person in the garden they actually have. Next session's check-in receives the returns.</a:t>
+            </a:r>
+          </a:p>
+          <a:p>
+            <a:r>
+              <a:t>THE LONG GAP: this is weeks one and two of four; the next slide gives weeks three and four.</a:t>
             </a:r>
           </a:p>
         </p:txBody>
@@ -1368,7 +1374,12 @@
           </a:p>
           <a:p>
             <a:r>
-              <a:t>BEATS: 0. Step 4 tonight asks the Four Connects impact question: 'What will you do or say differently?' — one sentence, committed aloud. 1. 'What happened in your pair is yours. Carry it gently — don't debrief it on the way home unless your heart is fully ready.' 2. If something heavy surfaced, reach out — the team is walking with you. 3. Aaronic blessing; see you evenings.</a:t>
+              <a:t>BEATS: 0. Step 4 tonight asks the Four Connects impact question: 'What will you do or say differently?' — one sentence, committed aloud. 1. 'What happened in your pair is yours. Carry it gently — don't debrief it on the way home unless your heart is fully ready.' 2. If something heavy surfaced, reach out — the team is walking with you. 3. Aaronic blessing; see you on Tuesday, December 8.</a:t>
+            </a:r>
+          </a:p>
+          <a:p>
+            <a:r>
+              <a:t>GAP: say the date once more, and who to reach over Thanksgiving.</a:t>
             </a:r>
           </a:p>
           <a:p>
@@ -1586,7 +1597,7 @@
           </a:p>
           <a:p>
             <a:r>
-              <a:t>CUES: The four parts are the next slide.</a:t>
+              <a:t>CUES: The five parts are the next slide.</a:t>
             </a:r>
           </a:p>
         </p:txBody>
@@ -1632,7 +1643,7 @@
           <a:lstStyle/>
           <a:p>
             <a:r>
-              <a:t>E7 · COMMISSIONING · LEAD: CONTENT PRESENTER</a:t>
+              <a:t>E7 · COMMISSIONING · 8:19–8:21 · LEAD: CONTENT PRESENTER</a:t>
             </a:r>
           </a:p>
           <a:p>
@@ -1642,12 +1653,17 @@
           </a:p>
           <a:p>
             <a:r>
-              <a:t>1. The four parts, in order: the homework practice, week one; the end-of-week-one check-in; the homework practice, week two; one sentence of preparation.</a:t>
-            </a:r>
-          </a:p>
-          <a:p>
-            <a:r>
-              <a:t>2. Check-in partners are named aloud before leaving this slide — the sheet has the line to write the name.</a:t>
+              <a:t>1. The five parts, in order: week one, the garden returns; the end-of-week-one check-in; week two, the garden again; weeks three and four, your choice from The Practices So Far; two sentences of preparation for December 8.</a:t>
+            </a:r>
+          </a:p>
+          <a:p>
+            <a:r>
+              <a:t>2. Check-in partners are named aloud before leaving this slide; the sheet has the line to write the name.</a:t>
+            </a:r>
+          </a:p>
+          <a:p>
+            <a:r>
+              <a:t>3. The Practices So Far card and the How Did You Know? card go with the sheet.</a:t>
             </a:r>
           </a:p>
           <a:p>
@@ -1785,6 +1801,67 @@
           <a:p>
             <a:r>
               <a:t>FROM: the Four Connects deck (FotH, September 2025), 'Garden of the Heart': take them back to that relaxed state; picture the heart again; invite Jesus in; suggest they ask him to do or say whatever he wants; let it sit a few minutes; return and record; then share.</a:t>
+            </a:r>
+          </a:p>
+        </p:txBody>
+      </p:sp>
+    </p:spTree>
+  </p:cSld>
+  <p:clrMapOvr>
+    <a:masterClrMapping/>
+  </p:clrMapOvr>
+</p:notes>
+</file>
+
+<file path=ppt/notesSlides/notesSlide19.xml><?xml version="1.0" encoding="utf-8"?>
+<p:notes xmlns:a="http://schemas.openxmlformats.org/drawingml/2006/main" xmlns:p="http://schemas.openxmlformats.org/presentationml/2006/main" xmlns:r="http://schemas.openxmlformats.org/officeDocument/2006/relationships">
+  <p:cSld>
+    <p:spTree>
+      <p:nvGrpSpPr>
+        <p:cNvPr id="1" name=""/>
+        <p:cNvGrpSpPr/>
+        <p:nvPr/>
+      </p:nvGrpSpPr>
+      <p:grpSpPr>
+        <a:xfrm>
+          <a:off x="0" y="0"/>
+          <a:ext cx="0" cy="0"/>
+          <a:chOff x="0" y="0"/>
+          <a:chExt cx="0" cy="0"/>
+        </a:xfrm>
+      </p:grpSpPr>
+      <p:sp>
+        <p:nvSpPr>
+          <p:cNvPr id="2" name="Notes Placeholder 1"/>
+          <p:cNvSpPr>
+            <a:spLocks noGrp="1"/>
+          </p:cNvSpPr>
+          <p:nvPr>
+            <p:ph type="body" idx="1"/>
+          </p:nvPr>
+        </p:nvSpPr>
+        <p:spPr/>
+        <p:txBody>
+          <a:bodyPr/>
+          <a:lstStyle/>
+          <a:p>
+            <a:r>
+              <a:t>E7 · 8:16–8:19 · LEAD: CONTENT PRESENTER</a:t>
+            </a:r>
+          </a:p>
+          <a:p>
+            <a:r>
+              <a:t>BEATS: 1. Name the gap plainly: no evening over Thanksgiving week; four weeks to Tuesday, December 8. "See you in a couple of weeks" is how practices die. 2. Weeks one and two run as always: the garden returns, the check-in after week one. 3. Weeks three and four are yours: each week, one practice from The Practices So Far card, a different one in week four; write down which, and why. 4. Read the list once, aloud, so everyone knows the menu. 5. The returning rule: if it slips, begin again the next day; no starting over, no streaks. 6. Name who to reach over the gap. 7. December 8 opens with three questions: which did you choose, did you come back on your own, which would you keep?</a:t>
+            </a:r>
+          </a:p>
+          <a:p>
+            <a:r>
+              <a:t>GUARD: Walk the list; never steer. The choices are made at home, freely: which practices people really want to do is what we are learning (John's word, 28 October).</a:t>
+            </a:r>
+          </a:p>
+          <a:p>
+            <a:r>
+              <a:t>CUES: Hand out The Practices So Far card with the take-home sheet on the next slide.</a:t>
             </a:r>
           </a:p>
         </p:txBody>
@@ -6257,7 +6334,7 @@
                 </a:solidFill>
                 <a:latin typeface="Cambria"/>
               </a:rPr>
-              <a:t>Homework — Two Weeks, Four Parts</a:t>
+              <a:t>Homework — Weeks One and Two</a:t>
             </a:r>
           </a:p>
         </p:txBody>
@@ -6554,7 +6631,7 @@
         <p:spPr>
           <a:xfrm>
             <a:off x="0" y="0"/>
-            <a:ext cx="12192000" cy="6858000"/>
+            <a:ext cx="12191695" cy="6858000"/>
           </a:xfrm>
           <a:prstGeom prst="rect">
             <a:avLst/>
@@ -6565,27 +6642,12 @@
           <a:ln>
             <a:noFill/>
           </a:ln>
-          <a:effectLst/>
         </p:spPr>
-        <p:style>
-          <a:lnRef idx="1">
-            <a:schemeClr val="accent1"/>
-          </a:lnRef>
-          <a:fillRef idx="3">
-            <a:schemeClr val="accent1"/>
-          </a:fillRef>
-          <a:effectRef idx="2">
-            <a:schemeClr val="accent1"/>
-          </a:effectRef>
-          <a:fontRef idx="minor">
-            <a:schemeClr val="lt1"/>
-          </a:fontRef>
-        </p:style>
-        <p:txBody>
-          <a:bodyPr rtlCol="0" anchor="ctr"/>
-          <a:lstStyle/>
-          <a:p>
-            <a:pPr algn="ctr"/>
+        <p:txBody>
+          <a:bodyPr/>
+          <a:lstStyle/>
+          <a:p>
+            <a:endParaRPr/>
           </a:p>
         </p:txBody>
       </p:sp>
@@ -6611,57 +6673,33 @@
           </a:bodyPr>
           <a:lstStyle/>
           <a:p>
-            <a:r>
-              <a:rPr sz="2800" b="1">
+            <a:pPr algn="l">
+              <a:spcAft>
+                <a:spcPts val="600"/>
+              </a:spcAft>
+            </a:pPr>
+            <a:r>
+              <a:rPr sz="2800" b="1" i="0">
                 <a:solidFill>
                   <a:srgbClr val="2C5F2D"/>
                 </a:solidFill>
                 <a:latin typeface="Cambria"/>
               </a:rPr>
-              <a:t>The Take-Home Sheet — the Daily Rhythm</a:t>
-            </a:r>
-          </a:p>
-        </p:txBody>
-      </p:sp>
-      <p:pic>
-        <p:nvPicPr>
-          <p:cNvPr id="4" name="Picture 3" descr="s9_part1.png"/>
-          <p:cNvPicPr>
-            <a:picLocks noChangeAspect="1"/>
-          </p:cNvPicPr>
+              <a:t>The Long Gap — Weeks Three and Four</a:t>
+            </a:r>
+          </a:p>
+        </p:txBody>
+      </p:sp>
+      <p:sp>
+        <p:nvSpPr>
+          <p:cNvPr id="4" name="TextBox 4"/>
+          <p:cNvSpPr txBox="1"/>
           <p:nvPr/>
-        </p:nvPicPr>
-        <p:blipFill>
-          <a:blip r:embed="rId2"/>
-          <a:stretch>
-            <a:fillRect/>
-          </a:stretch>
-        </p:blipFill>
+        </p:nvSpPr>
         <p:spPr>
           <a:xfrm>
-            <a:off x="1798167" y="1463040"/>
-            <a:ext cx="8595360" cy="4039819"/>
-          </a:xfrm>
-          <a:prstGeom prst="rect">
-            <a:avLst/>
-          </a:prstGeom>
-          <a:ln w="12700">
-            <a:solidFill>
-              <a:srgbClr val="C8C8C8"/>
-            </a:solidFill>
-          </a:ln>
-        </p:spPr>
-      </p:pic>
-      <p:sp>
-        <p:nvSpPr>
-          <p:cNvPr id="5" name="TextBox 4"/>
-          <p:cNvSpPr txBox="1"/>
-          <p:nvPr/>
-        </p:nvSpPr>
-        <p:spPr>
-          <a:xfrm>
-            <a:off x="822960" y="6355080"/>
-            <a:ext cx="10515600" cy="411480"/>
+            <a:off x="822960" y="1554480"/>
+            <a:ext cx="6675120" cy="4892040"/>
           </a:xfrm>
           <a:prstGeom prst="rect">
             <a:avLst/>
@@ -6669,19 +6707,181 @@
           <a:noFill/>
         </p:spPr>
         <p:txBody>
-          <a:bodyPr wrap="square">
-            <a:spAutoFit/>
-          </a:bodyPr>
-          <a:lstStyle/>
-          <a:p>
-            <a:r>
-              <a:rPr sz="1400" i="1">
-                <a:solidFill>
-                  <a:srgbClr val="595959"/>
-                </a:solidFill>
-                <a:latin typeface="Calibri"/>
-              </a:rPr>
-              <a:t>Handed out now — this is the sheet in your hands.</a:t>
+          <a:bodyPr wrap="square" lIns="91440" tIns="91440" rIns="91440" bIns="91440"/>
+          <a:lstStyle/>
+          <a:p>
+            <a:pPr marL="274320" indent="-274320">
+              <a:spcAft>
+                <a:spcPts val="750"/>
+              </a:spcAft>
+            </a:pPr>
+            <a:r>
+              <a:rPr sz="1900" b="1" i="0">
+                <a:solidFill>
+                  <a:srgbClr val="97BC62"/>
+                </a:solidFill>
+                <a:latin typeface="Calibri"/>
+              </a:rPr>
+              <a:t>•  </a:t>
+            </a:r>
+            <a:r>
+              <a:rPr sz="1900" b="0" i="0">
+                <a:solidFill>
+                  <a:srgbClr val="222B22"/>
+                </a:solidFill>
+                <a:latin typeface="Calibri"/>
+              </a:rPr>
+              <a:t>No evening over Thanksgiving — we meet again Tuesday, December 8: four weeks</a:t>
+            </a:r>
+          </a:p>
+          <a:p>
+            <a:pPr marL="274320" indent="-274320">
+              <a:spcAft>
+                <a:spcPts val="750"/>
+              </a:spcAft>
+            </a:pPr>
+            <a:r>
+              <a:rPr sz="1900" b="1" i="0">
+                <a:solidFill>
+                  <a:srgbClr val="97BC62"/>
+                </a:solidFill>
+                <a:latin typeface="Calibri"/>
+              </a:rPr>
+              <a:t>•  </a:t>
+            </a:r>
+            <a:r>
+              <a:rPr sz="1900" b="0" i="0">
+                <a:solidFill>
+                  <a:srgbClr val="222B22"/>
+                </a:solidFill>
+                <a:latin typeface="Calibri"/>
+              </a:rPr>
+              <a:t>Weeks one and two: the garden, with the check-in after week one</a:t>
+            </a:r>
+          </a:p>
+          <a:p>
+            <a:pPr marL="274320" indent="-274320">
+              <a:spcAft>
+                <a:spcPts val="750"/>
+              </a:spcAft>
+            </a:pPr>
+            <a:r>
+              <a:rPr sz="1900" b="1" i="0">
+                <a:solidFill>
+                  <a:srgbClr val="97BC62"/>
+                </a:solidFill>
+                <a:latin typeface="Calibri"/>
+              </a:rPr>
+              <a:t>•  </a:t>
+            </a:r>
+            <a:r>
+              <a:rPr sz="1900" b="0" i="0">
+                <a:solidFill>
+                  <a:srgbClr val="222B22"/>
+                </a:solidFill>
+                <a:latin typeface="Calibri"/>
+              </a:rPr>
+              <a:t>Weeks three and four: your choice — one practice each week from The Practices So Far, a different one in week four</a:t>
+            </a:r>
+          </a:p>
+          <a:p>
+            <a:pPr marL="274320" indent="-274320">
+              <a:spcAft>
+                <a:spcPts val="750"/>
+              </a:spcAft>
+            </a:pPr>
+            <a:r>
+              <a:rPr sz="1900" b="1" i="0">
+                <a:solidFill>
+                  <a:srgbClr val="97BC62"/>
+                </a:solidFill>
+                <a:latin typeface="Calibri"/>
+              </a:rPr>
+              <a:t>•  </a:t>
+            </a:r>
+            <a:r>
+              <a:rPr sz="1900" b="0" i="0">
+                <a:solidFill>
+                  <a:srgbClr val="222B22"/>
+                </a:solidFill>
+                <a:latin typeface="Calibri"/>
+              </a:rPr>
+              <a:t>Choose the one you would really like to do, not the one you think you should — write it down, and why</a:t>
+            </a:r>
+          </a:p>
+          <a:p>
+            <a:pPr marL="274320" indent="-274320">
+              <a:spcAft>
+                <a:spcPts val="750"/>
+              </a:spcAft>
+            </a:pPr>
+            <a:r>
+              <a:rPr sz="1900" b="1" i="0">
+                <a:solidFill>
+                  <a:srgbClr val="97BC62"/>
+                </a:solidFill>
+                <a:latin typeface="Calibri"/>
+              </a:rPr>
+              <a:t>•  </a:t>
+            </a:r>
+            <a:r>
+              <a:rPr sz="1900" b="0" i="0">
+                <a:solidFill>
+                  <a:srgbClr val="222B22"/>
+                </a:solidFill>
+                <a:latin typeface="Calibri"/>
+              </a:rPr>
+              <a:t>If it slips: begin again the next day. No starting over, no streaks</a:t>
+            </a:r>
+          </a:p>
+          <a:p>
+            <a:pPr marL="274320" indent="-274320">
+              <a:spcAft>
+                <a:spcPts val="750"/>
+              </a:spcAft>
+            </a:pPr>
+            <a:r>
+              <a:rPr sz="1900" b="1" i="0">
+                <a:solidFill>
+                  <a:srgbClr val="97BC62"/>
+                </a:solidFill>
+                <a:latin typeface="Calibri"/>
+              </a:rPr>
+              <a:t>•  </a:t>
+            </a:r>
+            <a:r>
+              <a:rPr sz="1900" b="0" i="0">
+                <a:solidFill>
+                  <a:srgbClr val="222B22"/>
+                </a:solidFill>
+                <a:latin typeface="Calibri"/>
+              </a:rPr>
+              <a:t>Over the gap, you know who to reach: ______ (named aloud)</a:t>
+            </a:r>
+          </a:p>
+          <a:p>
+            <a:pPr marL="274320" indent="-274320">
+              <a:spcAft>
+                <a:spcPts val="750"/>
+              </a:spcAft>
+            </a:pPr>
+            <a:r>
+              <a:rPr sz="1900" b="1" i="0">
+                <a:solidFill>
+                  <a:srgbClr val="97BC62"/>
+                </a:solidFill>
+                <a:latin typeface="Calibri"/>
+              </a:rPr>
+              <a:t>•  </a:t>
+            </a:r>
+            <a:r>
+              <a:rPr sz="1900" b="0" i="0">
+                <a:solidFill>
+                  <a:srgbClr val="222B22"/>
+                </a:solidFill>
+                <a:latin typeface="Calibri"/>
+              </a:rPr>
+              <a:t>December 8 opens with: which did you choose? Did you come back on your own? Which would you keep?</a:t>
             </a:r>
           </a:p>
         </p:txBody>
@@ -6716,6 +6916,227 @@
               </a:solidFill>
               <a:latin typeface="Calibri"/>
             </a:endParaRPr>
+          </a:p>
+        </p:txBody>
+      </p:sp>
+      <p:sp>
+        <p:nvSpPr>
+          <p:cNvPr id="4" name="TextBox 5"/>
+          <p:cNvSpPr txBox="1"/>
+          <p:nvPr/>
+        </p:nvSpPr>
+        <p:spPr>
+          <a:xfrm>
+            <a:off x="7863840" y="1554480"/>
+            <a:ext cx="3474720" cy="4892040"/>
+          </a:xfrm>
+          <a:prstGeom prst="rect">
+            <a:avLst/>
+          </a:prstGeom>
+          <a:noFill/>
+        </p:spPr>
+        <p:txBody>
+          <a:bodyPr wrap="square" lIns="91440" tIns="91440" rIns="91440" bIns="91440"/>
+          <a:lstStyle/>
+          <a:p>
+            <a:pPr marL="274320" indent="-274320">
+              <a:spcAft>
+                <a:spcPts val="750"/>
+              </a:spcAft>
+            </a:pPr>
+            <a:r>
+              <a:rPr sz="1900" b="1" i="0">
+                <a:solidFill>
+                  <a:srgbClr val="97BC62"/>
+                </a:solidFill>
+                <a:latin typeface="Calibri"/>
+              </a:rPr>
+              <a:t/>
+            </a:r>
+            <a:r>
+              <a:rPr sz="1900" b="1" i="0">
+                <a:solidFill>
+                  <a:srgbClr val="222B22"/>
+                </a:solidFill>
+                <a:latin typeface="Calibri"/>
+              </a:rPr>
+              <a:t>The Practices So Far</a:t>
+            </a:r>
+          </a:p>
+          <a:p>
+            <a:pPr marL="274320" indent="-274320">
+              <a:spcAft>
+                <a:spcPts val="750"/>
+              </a:spcAft>
+            </a:pPr>
+            <a:r>
+              <a:rPr sz="1900" b="1" i="0">
+                <a:solidFill>
+                  <a:srgbClr val="97BC62"/>
+                </a:solidFill>
+                <a:latin typeface="Calibri"/>
+              </a:rPr>
+              <a:t>•  </a:t>
+            </a:r>
+            <a:r>
+              <a:rPr sz="1900" b="0" i="0">
+                <a:solidFill>
+                  <a:srgbClr val="222B22"/>
+                </a:solidFill>
+                <a:latin typeface="Calibri"/>
+              </a:rPr>
+              <a:t>The abundance question (E1)</a:t>
+            </a:r>
+          </a:p>
+          <a:p>
+            <a:pPr marL="274320" indent="-274320">
+              <a:spcAft>
+                <a:spcPts val="750"/>
+              </a:spcAft>
+            </a:pPr>
+            <a:r>
+              <a:rPr sz="1900" b="1" i="0">
+                <a:solidFill>
+                  <a:srgbClr val="97BC62"/>
+                </a:solidFill>
+                <a:latin typeface="Calibri"/>
+              </a:rPr>
+              <a:t>•  </a:t>
+            </a:r>
+            <a:r>
+              <a:rPr sz="1900" b="0" i="0">
+                <a:solidFill>
+                  <a:srgbClr val="222B22"/>
+                </a:solidFill>
+                <a:latin typeface="Calibri"/>
+              </a:rPr>
+              <a:t>Soil-noticing (E2)</a:t>
+            </a:r>
+          </a:p>
+          <a:p>
+            <a:pPr marL="274320" indent="-274320">
+              <a:spcAft>
+                <a:spcPts val="750"/>
+              </a:spcAft>
+            </a:pPr>
+            <a:r>
+              <a:rPr sz="1900" b="1" i="0">
+                <a:solidFill>
+                  <a:srgbClr val="97BC62"/>
+                </a:solidFill>
+                <a:latin typeface="Calibri"/>
+              </a:rPr>
+              <a:t>•  </a:t>
+            </a:r>
+            <a:r>
+              <a:rPr sz="1900" b="0" i="0">
+                <a:solidFill>
+                  <a:srgbClr val="222B22"/>
+                </a:solidFill>
+                <a:latin typeface="Calibri"/>
+              </a:rPr>
+              <a:t>Joint Footprints (E3)</a:t>
+            </a:r>
+          </a:p>
+          <a:p>
+            <a:pPr marL="274320" indent="-274320">
+              <a:spcAft>
+                <a:spcPts val="750"/>
+              </a:spcAft>
+            </a:pPr>
+            <a:r>
+              <a:rPr sz="1900" b="1" i="0">
+                <a:solidFill>
+                  <a:srgbClr val="97BC62"/>
+                </a:solidFill>
+                <a:latin typeface="Calibri"/>
+              </a:rPr>
+              <a:t>•  </a:t>
+            </a:r>
+            <a:r>
+              <a:rPr sz="1900" b="0" i="0">
+                <a:solidFill>
+                  <a:srgbClr val="222B22"/>
+                </a:solidFill>
+                <a:latin typeface="Calibri"/>
+              </a:rPr>
+              <a:t>Offering a condition (E4)</a:t>
+            </a:r>
+          </a:p>
+          <a:p>
+            <a:pPr marL="274320" indent="-274320">
+              <a:spcAft>
+                <a:spcPts val="750"/>
+              </a:spcAft>
+            </a:pPr>
+            <a:r>
+              <a:rPr sz="1900" b="1" i="0">
+                <a:solidFill>
+                  <a:srgbClr val="97BC62"/>
+                </a:solidFill>
+                <a:latin typeface="Calibri"/>
+              </a:rPr>
+              <a:t>•  </a:t>
+            </a:r>
+            <a:r>
+              <a:rPr sz="1900" b="0" i="0">
+                <a:solidFill>
+                  <a:srgbClr val="222B22"/>
+                </a:solidFill>
+                <a:latin typeface="Calibri"/>
+              </a:rPr>
+              <a:t>The Five-Minute Examen (E5)</a:t>
+            </a:r>
+          </a:p>
+          <a:p>
+            <a:pPr marL="274320" indent="-274320">
+              <a:spcAft>
+                <a:spcPts val="750"/>
+              </a:spcAft>
+            </a:pPr>
+            <a:r>
+              <a:rPr sz="1900" b="1" i="0">
+                <a:solidFill>
+                  <a:srgbClr val="97BC62"/>
+                </a:solidFill>
+                <a:latin typeface="Calibri"/>
+              </a:rPr>
+              <a:t>•  </a:t>
+            </a:r>
+            <a:r>
+              <a:rPr sz="1900" b="0" i="0">
+                <a:solidFill>
+                  <a:srgbClr val="222B22"/>
+                </a:solidFill>
+                <a:latin typeface="Calibri"/>
+              </a:rPr>
+              <a:t>PROAPT (E6)</a:t>
+            </a:r>
+          </a:p>
+          <a:p>
+            <a:pPr marL="274320" indent="-274320">
+              <a:spcAft>
+                <a:spcPts val="750"/>
+              </a:spcAft>
+            </a:pPr>
+            <a:r>
+              <a:rPr sz="1900" b="1" i="0">
+                <a:solidFill>
+                  <a:srgbClr val="97BC62"/>
+                </a:solidFill>
+                <a:latin typeface="Calibri"/>
+              </a:rPr>
+              <a:t>•  </a:t>
+            </a:r>
+            <a:r>
+              <a:rPr sz="1900" b="0" i="0">
+                <a:solidFill>
+                  <a:srgbClr val="222B22"/>
+                </a:solidFill>
+                <a:latin typeface="Calibri"/>
+              </a:rPr>
+              <a:t>The garden (E7)</a:t>
+            </a:r>
           </a:p>
         </p:txBody>
       </p:sp>
@@ -6810,40 +7231,11 @@
                 </a:solidFill>
                 <a:latin typeface="Cambria"/>
               </a:rPr>
-              <a:t>The Take-Home Sheet — the Four Parts</a:t>
-            </a:r>
-          </a:p>
-        </p:txBody>
-      </p:sp>
-      <p:pic>
-        <p:nvPicPr>
-          <p:cNvPr id="4" name="Picture 3" descr="s9_part2.png"/>
-          <p:cNvPicPr>
-            <a:picLocks noChangeAspect="1"/>
-          </p:cNvPicPr>
-          <p:nvPr/>
-        </p:nvPicPr>
-        <p:blipFill>
-          <a:blip r:embed="rId2"/>
-          <a:stretch>
-            <a:fillRect/>
-          </a:stretch>
-        </p:blipFill>
-        <p:spPr>
-          <a:xfrm>
-            <a:off x="2066004" y="1463040"/>
-            <a:ext cx="8059687" cy="4709160"/>
-          </a:xfrm>
-          <a:prstGeom prst="rect">
-            <a:avLst/>
-          </a:prstGeom>
-          <a:ln w="12700">
-            <a:solidFill>
-              <a:srgbClr val="C8C8C8"/>
-            </a:solidFill>
-          </a:ln>
-        </p:spPr>
-      </p:pic>
+              <a:t>The Take-Home Sheet — the Daily Rhythm</a:t>
+            </a:r>
+          </a:p>
+        </p:txBody>
+      </p:sp>
       <p:sp>
         <p:nvSpPr>
           <p:cNvPr id="5" name="TextBox 4"/>
@@ -6873,7 +7265,7 @@
                 </a:solidFill>
                 <a:latin typeface="Calibri"/>
               </a:rPr>
-              <a:t>One practice at a time — and a partner expecting you at the end of week one.</a:t>
+              <a:t>Handed out now — this is the sheet in your hands.</a:t>
             </a:r>
           </a:p>
         </p:txBody>
@@ -6911,6 +7303,30 @@
           </a:p>
         </p:txBody>
       </p:sp>
+      <p:pic>
+        <p:nvPicPr>
+          <p:cNvPr id="91" name="Picture 90" descr="new_s15.png"/>
+          <p:cNvPicPr>
+            <a:picLocks noChangeAspect="1"/>
+          </p:cNvPicPr>
+          <p:nvPr/>
+        </p:nvPicPr>
+        <p:blipFill>
+          <a:blip r:embed="rId4"/>
+          <a:stretch>
+            <a:fillRect/>
+          </a:stretch>
+        </p:blipFill>
+        <p:spPr>
+          <a:xfrm>
+            <a:off x="1798167" y="1463040"/>
+            <a:ext cx="8595360" cy="2773092"/>
+          </a:xfrm>
+          <a:prstGeom prst="rect">
+            <a:avLst/>
+          </a:prstGeom>
+        </p:spPr>
+      </p:pic>
     </p:spTree>
   </p:cSld>
   <p:clrMapOvr>
@@ -6920,6 +7336,193 @@
 </file>
 
 <file path=ppt/slides/slide17.xml><?xml version="1.0" encoding="utf-8"?>
+<p:sld xmlns:a="http://schemas.openxmlformats.org/drawingml/2006/main" xmlns:p="http://schemas.openxmlformats.org/presentationml/2006/main" xmlns:r="http://schemas.openxmlformats.org/officeDocument/2006/relationships">
+  <p:cSld>
+    <p:spTree>
+      <p:nvGrpSpPr>
+        <p:cNvPr id="1" name=""/>
+        <p:cNvGrpSpPr/>
+        <p:nvPr/>
+      </p:nvGrpSpPr>
+      <p:grpSpPr/>
+      <p:sp>
+        <p:nvSpPr>
+          <p:cNvPr id="2" name="Rectangle 1"/>
+          <p:cNvSpPr/>
+          <p:nvPr/>
+        </p:nvSpPr>
+        <p:spPr>
+          <a:xfrm>
+            <a:off x="0" y="0"/>
+            <a:ext cx="12192000" cy="6858000"/>
+          </a:xfrm>
+          <a:prstGeom prst="rect">
+            <a:avLst/>
+          </a:prstGeom>
+          <a:solidFill>
+            <a:srgbClr val="FFFFFF"/>
+          </a:solidFill>
+          <a:ln>
+            <a:noFill/>
+          </a:ln>
+          <a:effectLst/>
+        </p:spPr>
+        <p:style>
+          <a:lnRef idx="1">
+            <a:schemeClr val="accent1"/>
+          </a:lnRef>
+          <a:fillRef idx="3">
+            <a:schemeClr val="accent1"/>
+          </a:fillRef>
+          <a:effectRef idx="2">
+            <a:schemeClr val="accent1"/>
+          </a:effectRef>
+          <a:fontRef idx="minor">
+            <a:schemeClr val="lt1"/>
+          </a:fontRef>
+        </p:style>
+        <p:txBody>
+          <a:bodyPr rtlCol="0" anchor="ctr"/>
+          <a:lstStyle/>
+          <a:p>
+            <a:pPr algn="ctr"/>
+          </a:p>
+        </p:txBody>
+      </p:sp>
+      <p:sp>
+        <p:nvSpPr>
+          <p:cNvPr id="3" name="TextBox 2"/>
+          <p:cNvSpPr txBox="1"/>
+          <p:nvPr/>
+        </p:nvSpPr>
+        <p:spPr>
+          <a:xfrm>
+            <a:off x="822960" y="502920"/>
+            <a:ext cx="10515600" cy="822960"/>
+          </a:xfrm>
+          <a:prstGeom prst="rect">
+            <a:avLst/>
+          </a:prstGeom>
+          <a:noFill/>
+        </p:spPr>
+        <p:txBody>
+          <a:bodyPr wrap="square">
+            <a:spAutoFit/>
+          </a:bodyPr>
+          <a:lstStyle/>
+          <a:p>
+            <a:r>
+              <a:rPr sz="2800" b="1">
+                <a:solidFill>
+                  <a:srgbClr val="2C5F2D"/>
+                </a:solidFill>
+                <a:latin typeface="Cambria"/>
+              </a:rPr>
+              <a:t>The Take-Home Sheet — the Five Parts</a:t>
+            </a:r>
+          </a:p>
+        </p:txBody>
+      </p:sp>
+      <p:sp>
+        <p:nvSpPr>
+          <p:cNvPr id="5" name="TextBox 4"/>
+          <p:cNvSpPr txBox="1"/>
+          <p:nvPr/>
+        </p:nvSpPr>
+        <p:spPr>
+          <a:xfrm>
+            <a:off x="822960" y="6355080"/>
+            <a:ext cx="10515600" cy="411480"/>
+          </a:xfrm>
+          <a:prstGeom prst="rect">
+            <a:avLst/>
+          </a:prstGeom>
+          <a:noFill/>
+        </p:spPr>
+        <p:txBody>
+          <a:bodyPr wrap="square">
+            <a:spAutoFit/>
+          </a:bodyPr>
+          <a:lstStyle/>
+          <a:p>
+            <a:r>
+              <a:rPr sz="1400" i="1">
+                <a:solidFill>
+                  <a:srgbClr val="595959"/>
+                </a:solidFill>
+                <a:latin typeface="Calibri"/>
+              </a:rPr>
+              <a:t>Two weeks as always, then two you choose — and a partner expecting you at the end of week one.</a:t>
+            </a:r>
+          </a:p>
+        </p:txBody>
+      </p:sp>
+      <p:sp>
+        <p:nvSpPr>
+          <p:cNvPr id="90" name="SlideNum"/>
+          <p:cNvSpPr txBox="1"/>
+          <p:nvPr/>
+        </p:nvSpPr>
+        <p:spPr>
+          <a:xfrm>
+            <a:off x="11384280" y="6446520"/>
+            <a:ext cx="640080" cy="292608"/>
+          </a:xfrm>
+          <a:prstGeom prst="rect">
+            <a:avLst/>
+          </a:prstGeom>
+          <a:noFill/>
+        </p:spPr>
+        <p:txBody>
+          <a:bodyPr wrap="none" lIns="0" tIns="0" rIns="45720" bIns="0" anchor="ctr"/>
+          <a:lstStyle/>
+          <a:p>
+            <a:pPr algn="r"/>
+            <a:r>
+              <a:t>G17</a:t>
+            </a:r>
+            <a:endParaRPr sz="1000" b="1">
+              <a:solidFill>
+                <a:srgbClr val="7A8A6E"/>
+              </a:solidFill>
+              <a:latin typeface="Calibri"/>
+            </a:endParaRPr>
+          </a:p>
+        </p:txBody>
+      </p:sp>
+      <p:pic>
+        <p:nvPicPr>
+          <p:cNvPr id="91" name="Picture 90" descr="new_s16.png"/>
+          <p:cNvPicPr>
+            <a:picLocks noChangeAspect="1"/>
+          </p:cNvPicPr>
+          <p:nvPr/>
+        </p:nvPicPr>
+        <p:blipFill>
+          <a:blip r:embed="rId4"/>
+          <a:stretch>
+            <a:fillRect/>
+          </a:stretch>
+        </p:blipFill>
+        <p:spPr>
+          <a:xfrm>
+            <a:off x="3523272" y="1463040"/>
+            <a:ext cx="5145456" cy="4892040"/>
+          </a:xfrm>
+          <a:prstGeom prst="rect">
+            <a:avLst/>
+          </a:prstGeom>
+        </p:spPr>
+      </p:pic>
+    </p:spTree>
+  </p:cSld>
+  <p:clrMapOvr>
+    <a:masterClrMapping/>
+  </p:clrMapOvr>
+</p:sld>
+</file>
+
+<file path=ppt/slides/slide18.xml><?xml version="1.0" encoding="utf-8"?>
 <p:sld xmlns:a="http://schemas.openxmlformats.org/drawingml/2006/main" xmlns:r="http://schemas.openxmlformats.org/officeDocument/2006/relationships" xmlns:p="http://schemas.openxmlformats.org/presentationml/2006/main">
   <p:cSld>
     <p:spTree>
@@ -7197,7 +7800,7 @@
           <a:p>
             <a:pPr algn="r"/>
             <a:r>
-              <a:t>G17</a:t>
+              <a:t>G18</a:t>
             </a:r>
             <a:endParaRPr sz="1000" b="1">
               <a:solidFill>
@@ -7252,7 +7855,7 @@
 </p:sld>
 </file>
 
-<file path=ppt/slides/slide18.xml><?xml version="1.0" encoding="utf-8"?>
+<file path=ppt/slides/slide19.xml><?xml version="1.0" encoding="utf-8"?>
 <p:sld xmlns:a="http://schemas.openxmlformats.org/drawingml/2006/main" xmlns:r="http://schemas.openxmlformats.org/officeDocument/2006/relationships" xmlns:p="http://schemas.openxmlformats.org/presentationml/2006/main">
   <p:cSld>
     <p:spTree>
@@ -7642,7 +8245,7 @@
           <a:p>
             <a:pPr algn="r"/>
             <a:r>
-              <a:t>G18</a:t>
+              <a:t>G19</a:t>
             </a:r>
             <a:endParaRPr sz="1000" b="1">
               <a:solidFill>
@@ -8434,7 +9037,7 @@
                 </a:solidFill>
                 <a:latin typeface="Calibri"/>
               </a:rPr>
-              <a:t>Homework — handout, card, check-in partners</a:t>
+              <a:t>Homework and the long gap</a:t>
             </a:r>
           </a:p>
           <a:p>

</xml_diff>